<commit_message>
feat(v1.1.0): evolve from 47-page real-world testing
Added:
- bars layout: 2-4 item quantitative comparison, native editable shapes
- timeline layout: 3-4 node milestone timeline
- speaker notes: per-slide 'note' field -> PPTX notes page
- deck-level gradient switch: top-level false kills all gradients
- path fence: safeResolve boundary checks (Mimosa security fix)

Fixed:
- featureGrid/compare/split multi-line body valign top (was ~25px
  column misalignment due to pptxgenjs default middle anchoring)

Changed:
- check_layout warns when gradient pages > 4
- business example upgraded to 13 pages with bars/timeline/notes
- docs synced: layouts specs, SKILL/USAGE field refs, changelog

Acceptance: business 13/13 judge pass; valign fix re-verified (<=5px)
</commit_message>
<xml_diff>
--- a/assets/example_deck.pptx
+++ b/assets/example_deck.pptx
@@ -689,7 +689,7 @@
           <a:p>
             <a:r>
               <a:rPr lang="en-US" dirty="0"/>
-              <a:t/>
+              <a:t>* 本演示为风格化戏仿，与 Apple Inc. 无任何关联。</a:t>
             </a:r>
             <a:endParaRPr lang="en-US" dirty="0"/>
           </a:p>
@@ -3140,7 +3140,7 @@
           <a:ln/>
         </p:spPr>
         <p:txBody>
-          <a:bodyPr wrap="square" rtlCol="0" anchor="ctr"/>
+          <a:bodyPr wrap="square" rtlCol="0" anchor="t"/>
           <a:lstStyle/>
           <a:p>
             <a:pPr indent="0" marL="0">
@@ -3221,7 +3221,7 @@
           <a:ln/>
         </p:spPr>
         <p:txBody>
-          <a:bodyPr wrap="square" rtlCol="0" anchor="ctr"/>
+          <a:bodyPr wrap="square" rtlCol="0" anchor="t"/>
           <a:lstStyle/>
           <a:p>
             <a:pPr indent="0" marL="0">
@@ -3302,7 +3302,7 @@
           <a:ln/>
         </p:spPr>
         <p:txBody>
-          <a:bodyPr wrap="square" rtlCol="0" anchor="ctr"/>
+          <a:bodyPr wrap="square" rtlCol="0" anchor="t"/>
           <a:lstStyle/>
           <a:p>
             <a:pPr indent="0" marL="0">
@@ -3532,7 +3532,7 @@
           <a:ln/>
         </p:spPr>
         <p:txBody>
-          <a:bodyPr wrap="square" rtlCol="0" anchor="ctr"/>
+          <a:bodyPr wrap="square" rtlCol="0" anchor="t"/>
           <a:lstStyle/>
           <a:p>
             <a:pPr indent="0" marL="0">
@@ -3614,7 +3614,7 @@
           <a:ln/>
         </p:spPr>
         <p:txBody>
-          <a:bodyPr wrap="square" rtlCol="0" anchor="ctr"/>
+          <a:bodyPr wrap="square" rtlCol="0" anchor="t"/>
           <a:lstStyle/>
           <a:p>
             <a:pPr indent="0" marL="0">

</xml_diff>

<commit_message>
feat: keynote-style transitions and entrance animations (OOXML post-processing)
- add_animations.py: injects per-slide fade-dissolve transition (0.7s) and
  staggered fade+rise entrance for every element (0.45s, 160ms cascade,
  auto-plays on slide entry, ordered by visual position top-down)
- row XML distilled from genuine PowerPoint 16 output
  (ppt-master/pptx_animation_presets.json, entrance_fade preset_id=10)
- bldP written only for text-bearing p:sp per OOXML build-reference rules
- build_deck: auto-runs after generation; outline 'animations': false opts out
- verified via PowerPoint COM: no repair prompt, transitions recognized
  (0.7s), animation sequences match element counts (4/1/3 on cover/
  statement/section; 18 on bars page), EffectType=10 fade,
  TriggerType=WithPrevious, 3 behaviors per effect (set/fade/rise)
- all 4 showcase decks regenerated with animations (243 animated elements)
- note: docs intentionally NOT updated per maintainer request
</commit_message>
<xml_diff>
--- a/assets/example_deck.pptx
+++ b/assets/example_deck.pptx
@@ -2029,6 +2029,298 @@
   <p:clrMapOvr>
     <a:masterClrMapping/>
   </p:clrMapOvr>
+  <p:transition xmlns:p14="http://schemas.microsoft.com/office/powerpoint/2010/main" spd="slow" p14:dur="700">
+    <p:fade/>
+  </p:transition>
+  <p:timing xmlns:p="http://schemas.openxmlformats.org/presentationml/2006/main">
+    <p:tnLst>
+      <p:par>
+        <p:cTn id="1" dur="indefinite" restart="never" nodeType="tmRoot">
+          <p:childTnLst>
+            <p:seq concurrent="1" nextAc="seek">
+              <p:cTn id="2" dur="indefinite" nodeType="mainSeq">
+                <p:childTnLst>
+                  <p:par>
+                    <p:cTn id="3" fill="hold">
+                      <p:stCondLst>
+                        <p:cond delay="indefinite"/>
+                        <p:cond evt="onBegin" delay="0">
+                          <p:tn val="2"/>
+                        </p:cond>
+                      </p:stCondLst>
+                      <p:childTnLst>
+                        <p:par>
+                          <p:cTn id="4" fill="hold">
+                            <p:stCondLst>
+                              <p:cond delay="0"/>
+                            </p:stCondLst>
+                            <p:childTnLst>
+                              <p:par>
+                                <p:cTn id="5" presetID="10" presetClass="entr" presetSubtype="0" fill="hold" grpId="0" nodeType="withEffect">
+                                  <p:stCondLst>
+                                    <p:cond delay="0"/>
+                                  </p:stCondLst>
+                                  <p:childTnLst>
+                                    <p:set>
+                                      <p:cBhvr>
+                                        <p:cTn id="6" dur="1" fill="hold">
+                                          <p:stCondLst>
+                                            <p:cond delay="0"/>
+                                          </p:stCondLst>
+                                        </p:cTn>
+                                        <p:tgtEl>
+                                          <p:spTgt spid="2"/>
+                                        </p:tgtEl>
+                                        <p:attrNameLst>
+                                          <p:attrName>style.visibility</p:attrName>
+                                        </p:attrNameLst>
+                                      </p:cBhvr>
+                                      <p:to>
+                                        <p:strVal val="visible"/>
+                                      </p:to>
+                                    </p:set>
+                                    <p:animEffect transition="in" filter="fade">
+                                      <p:cBhvr>
+                                        <p:cTn id="7" dur="450"/>
+                                        <p:tgtEl>
+                                          <p:spTgt spid="2"/>
+                                        </p:tgtEl>
+                                      </p:cBhvr>
+                                    </p:animEffect>
+                                    <p:anim calcmode="lin" valueType="num">
+                                      <p:cBhvr additive="base">
+                                        <p:cTn id="8" dur="450" fill="hold"/>
+                                        <p:tgtEl>
+                                          <p:spTgt spid="2"/>
+                                        </p:tgtEl>
+                                        <p:attrNameLst>
+                                          <p:attrName>ppt_y</p:attrName>
+                                        </p:attrNameLst>
+                                      </p:cBhvr>
+                                      <p:tavLst>
+                                        <p:tav tm="0">
+                                          <p:val>
+                                            <p:strVal val="#ppt_y+0.025"/>
+                                          </p:val>
+                                        </p:tav>
+                                        <p:tav tm="100000">
+                                          <p:val>
+                                            <p:strVal val="#ppt_y"/>
+                                          </p:val>
+                                        </p:tav>
+                                      </p:tavLst>
+                                    </p:anim>
+                                  </p:childTnLst>
+                                </p:cTn>
+                              </p:par>
+                              <p:par>
+                                <p:cTn id="9" presetID="10" presetClass="entr" presetSubtype="0" fill="hold" grpId="0" nodeType="withEffect">
+                                  <p:stCondLst>
+                                    <p:cond delay="160"/>
+                                  </p:stCondLst>
+                                  <p:childTnLst>
+                                    <p:set>
+                                      <p:cBhvr>
+                                        <p:cTn id="10" dur="1" fill="hold">
+                                          <p:stCondLst>
+                                            <p:cond delay="0"/>
+                                          </p:stCondLst>
+                                        </p:cTn>
+                                        <p:tgtEl>
+                                          <p:spTgt spid="3"/>
+                                        </p:tgtEl>
+                                        <p:attrNameLst>
+                                          <p:attrName>style.visibility</p:attrName>
+                                        </p:attrNameLst>
+                                      </p:cBhvr>
+                                      <p:to>
+                                        <p:strVal val="visible"/>
+                                      </p:to>
+                                    </p:set>
+                                    <p:animEffect transition="in" filter="fade">
+                                      <p:cBhvr>
+                                        <p:cTn id="11" dur="450"/>
+                                        <p:tgtEl>
+                                          <p:spTgt spid="3"/>
+                                        </p:tgtEl>
+                                      </p:cBhvr>
+                                    </p:animEffect>
+                                    <p:anim calcmode="lin" valueType="num">
+                                      <p:cBhvr additive="base">
+                                        <p:cTn id="12" dur="450" fill="hold"/>
+                                        <p:tgtEl>
+                                          <p:spTgt spid="3"/>
+                                        </p:tgtEl>
+                                        <p:attrNameLst>
+                                          <p:attrName>ppt_y</p:attrName>
+                                        </p:attrNameLst>
+                                      </p:cBhvr>
+                                      <p:tavLst>
+                                        <p:tav tm="0">
+                                          <p:val>
+                                            <p:strVal val="#ppt_y+0.025"/>
+                                          </p:val>
+                                        </p:tav>
+                                        <p:tav tm="100000">
+                                          <p:val>
+                                            <p:strVal val="#ppt_y"/>
+                                          </p:val>
+                                        </p:tav>
+                                      </p:tavLst>
+                                    </p:anim>
+                                  </p:childTnLst>
+                                </p:cTn>
+                              </p:par>
+                              <p:par>
+                                <p:cTn id="13" presetID="10" presetClass="entr" presetSubtype="0" fill="hold" grpId="0" nodeType="withEffect">
+                                  <p:stCondLst>
+                                    <p:cond delay="320"/>
+                                  </p:stCondLst>
+                                  <p:childTnLst>
+                                    <p:set>
+                                      <p:cBhvr>
+                                        <p:cTn id="14" dur="1" fill="hold">
+                                          <p:stCondLst>
+                                            <p:cond delay="0"/>
+                                          </p:stCondLst>
+                                        </p:cTn>
+                                        <p:tgtEl>
+                                          <p:spTgt spid="4"/>
+                                        </p:tgtEl>
+                                        <p:attrNameLst>
+                                          <p:attrName>style.visibility</p:attrName>
+                                        </p:attrNameLst>
+                                      </p:cBhvr>
+                                      <p:to>
+                                        <p:strVal val="visible"/>
+                                      </p:to>
+                                    </p:set>
+                                    <p:animEffect transition="in" filter="fade">
+                                      <p:cBhvr>
+                                        <p:cTn id="15" dur="450"/>
+                                        <p:tgtEl>
+                                          <p:spTgt spid="4"/>
+                                        </p:tgtEl>
+                                      </p:cBhvr>
+                                    </p:animEffect>
+                                    <p:anim calcmode="lin" valueType="num">
+                                      <p:cBhvr additive="base">
+                                        <p:cTn id="16" dur="450" fill="hold"/>
+                                        <p:tgtEl>
+                                          <p:spTgt spid="4"/>
+                                        </p:tgtEl>
+                                        <p:attrNameLst>
+                                          <p:attrName>ppt_y</p:attrName>
+                                        </p:attrNameLst>
+                                      </p:cBhvr>
+                                      <p:tavLst>
+                                        <p:tav tm="0">
+                                          <p:val>
+                                            <p:strVal val="#ppt_y+0.025"/>
+                                          </p:val>
+                                        </p:tav>
+                                        <p:tav tm="100000">
+                                          <p:val>
+                                            <p:strVal val="#ppt_y"/>
+                                          </p:val>
+                                        </p:tav>
+                                      </p:tavLst>
+                                    </p:anim>
+                                  </p:childTnLst>
+                                </p:cTn>
+                              </p:par>
+                              <p:par>
+                                <p:cTn id="17" presetID="10" presetClass="entr" presetSubtype="0" fill="hold" grpId="0" nodeType="withEffect">
+                                  <p:stCondLst>
+                                    <p:cond delay="480"/>
+                                  </p:stCondLst>
+                                  <p:childTnLst>
+                                    <p:set>
+                                      <p:cBhvr>
+                                        <p:cTn id="18" dur="1" fill="hold">
+                                          <p:stCondLst>
+                                            <p:cond delay="0"/>
+                                          </p:stCondLst>
+                                        </p:cTn>
+                                        <p:tgtEl>
+                                          <p:spTgt spid="5"/>
+                                        </p:tgtEl>
+                                        <p:attrNameLst>
+                                          <p:attrName>style.visibility</p:attrName>
+                                        </p:attrNameLst>
+                                      </p:cBhvr>
+                                      <p:to>
+                                        <p:strVal val="visible"/>
+                                      </p:to>
+                                    </p:set>
+                                    <p:animEffect transition="in" filter="fade">
+                                      <p:cBhvr>
+                                        <p:cTn id="19" dur="450"/>
+                                        <p:tgtEl>
+                                          <p:spTgt spid="5"/>
+                                        </p:tgtEl>
+                                      </p:cBhvr>
+                                    </p:animEffect>
+                                    <p:anim calcmode="lin" valueType="num">
+                                      <p:cBhvr additive="base">
+                                        <p:cTn id="20" dur="450" fill="hold"/>
+                                        <p:tgtEl>
+                                          <p:spTgt spid="5"/>
+                                        </p:tgtEl>
+                                        <p:attrNameLst>
+                                          <p:attrName>ppt_y</p:attrName>
+                                        </p:attrNameLst>
+                                      </p:cBhvr>
+                                      <p:tavLst>
+                                        <p:tav tm="0">
+                                          <p:val>
+                                            <p:strVal val="#ppt_y+0.025"/>
+                                          </p:val>
+                                        </p:tav>
+                                        <p:tav tm="100000">
+                                          <p:val>
+                                            <p:strVal val="#ppt_y"/>
+                                          </p:val>
+                                        </p:tav>
+                                      </p:tavLst>
+                                    </p:anim>
+                                  </p:childTnLst>
+                                </p:cTn>
+                              </p:par>
+                            </p:childTnLst>
+                          </p:cTn>
+                        </p:par>
+                      </p:childTnLst>
+                    </p:cTn>
+                  </p:par>
+                </p:childTnLst>
+              </p:cTn>
+              <p:prevCondLst>
+                <p:cond evt="onPrev" delay="0">
+                  <p:tgtEl>
+                    <p:sldTgt/>
+                  </p:tgtEl>
+                </p:cond>
+              </p:prevCondLst>
+              <p:nextCondLst>
+                <p:cond evt="onNext" delay="0">
+                  <p:tgtEl>
+                    <p:sldTgt/>
+                  </p:tgtEl>
+                </p:cond>
+              </p:nextCondLst>
+            </p:seq>
+          </p:childTnLst>
+        </p:cTn>
+      </p:par>
+    </p:tnLst>
+    <p:bldLst>
+      <p:bldP spid="2" grpId="0"/>
+      <p:bldP spid="3" grpId="0"/>
+      <p:bldP spid="4" grpId="0"/>
+      <p:bldP spid="5" grpId="0"/>
+    </p:bldLst>
+  </p:timing>
 </p:sld>
 </file>
 
@@ -2117,6 +2409,121 @@
   <p:clrMapOvr>
     <a:masterClrMapping/>
   </p:clrMapOvr>
+  <p:transition xmlns:p14="http://schemas.microsoft.com/office/powerpoint/2010/main" spd="slow" p14:dur="700">
+    <p:fade/>
+  </p:transition>
+  <p:timing xmlns:p="http://schemas.openxmlformats.org/presentationml/2006/main">
+    <p:tnLst>
+      <p:par>
+        <p:cTn id="1" dur="indefinite" restart="never" nodeType="tmRoot">
+          <p:childTnLst>
+            <p:seq concurrent="1" nextAc="seek">
+              <p:cTn id="2" dur="indefinite" nodeType="mainSeq">
+                <p:childTnLst>
+                  <p:par>
+                    <p:cTn id="3" fill="hold">
+                      <p:stCondLst>
+                        <p:cond delay="indefinite"/>
+                        <p:cond evt="onBegin" delay="0">
+                          <p:tn val="2"/>
+                        </p:cond>
+                      </p:stCondLst>
+                      <p:childTnLst>
+                        <p:par>
+                          <p:cTn id="4" fill="hold">
+                            <p:stCondLst>
+                              <p:cond delay="0"/>
+                            </p:stCondLst>
+                            <p:childTnLst>
+                              <p:par>
+                                <p:cTn id="5" presetID="10" presetClass="entr" presetSubtype="0" fill="hold" grpId="0" nodeType="withEffect">
+                                  <p:stCondLst>
+                                    <p:cond delay="0"/>
+                                  </p:stCondLst>
+                                  <p:childTnLst>
+                                    <p:set>
+                                      <p:cBhvr>
+                                        <p:cTn id="6" dur="1" fill="hold">
+                                          <p:stCondLst>
+                                            <p:cond delay="0"/>
+                                          </p:stCondLst>
+                                        </p:cTn>
+                                        <p:tgtEl>
+                                          <p:spTgt spid="2"/>
+                                        </p:tgtEl>
+                                        <p:attrNameLst>
+                                          <p:attrName>style.visibility</p:attrName>
+                                        </p:attrNameLst>
+                                      </p:cBhvr>
+                                      <p:to>
+                                        <p:strVal val="visible"/>
+                                      </p:to>
+                                    </p:set>
+                                    <p:animEffect transition="in" filter="fade">
+                                      <p:cBhvr>
+                                        <p:cTn id="7" dur="450"/>
+                                        <p:tgtEl>
+                                          <p:spTgt spid="2"/>
+                                        </p:tgtEl>
+                                      </p:cBhvr>
+                                    </p:animEffect>
+                                    <p:anim calcmode="lin" valueType="num">
+                                      <p:cBhvr additive="base">
+                                        <p:cTn id="8" dur="450" fill="hold"/>
+                                        <p:tgtEl>
+                                          <p:spTgt spid="2"/>
+                                        </p:tgtEl>
+                                        <p:attrNameLst>
+                                          <p:attrName>ppt_y</p:attrName>
+                                        </p:attrNameLst>
+                                      </p:cBhvr>
+                                      <p:tavLst>
+                                        <p:tav tm="0">
+                                          <p:val>
+                                            <p:strVal val="#ppt_y+0.025"/>
+                                          </p:val>
+                                        </p:tav>
+                                        <p:tav tm="100000">
+                                          <p:val>
+                                            <p:strVal val="#ppt_y"/>
+                                          </p:val>
+                                        </p:tav>
+                                      </p:tavLst>
+                                    </p:anim>
+                                  </p:childTnLst>
+                                </p:cTn>
+                              </p:par>
+                            </p:childTnLst>
+                          </p:cTn>
+                        </p:par>
+                      </p:childTnLst>
+                    </p:cTn>
+                  </p:par>
+                </p:childTnLst>
+              </p:cTn>
+              <p:prevCondLst>
+                <p:cond evt="onPrev" delay="0">
+                  <p:tgtEl>
+                    <p:sldTgt/>
+                  </p:tgtEl>
+                </p:cond>
+              </p:prevCondLst>
+              <p:nextCondLst>
+                <p:cond evt="onNext" delay="0">
+                  <p:tgtEl>
+                    <p:sldTgt/>
+                  </p:tgtEl>
+                </p:cond>
+              </p:nextCondLst>
+            </p:seq>
+          </p:childTnLst>
+        </p:cTn>
+      </p:par>
+    </p:tnLst>
+    <p:bldLst>
+      <p:bldP spid="2" grpId="0"/>
+    </p:bldLst>
+  </p:timing>
 </p:sld>
 </file>
 
@@ -2319,6 +2726,298 @@
   <p:clrMapOvr>
     <a:masterClrMapping/>
   </p:clrMapOvr>
+  <p:transition xmlns:p14="http://schemas.microsoft.com/office/powerpoint/2010/main" spd="slow" p14:dur="700">
+    <p:fade/>
+  </p:transition>
+  <p:timing xmlns:p="http://schemas.openxmlformats.org/presentationml/2006/main">
+    <p:tnLst>
+      <p:par>
+        <p:cTn id="1" dur="indefinite" restart="never" nodeType="tmRoot">
+          <p:childTnLst>
+            <p:seq concurrent="1" nextAc="seek">
+              <p:cTn id="2" dur="indefinite" nodeType="mainSeq">
+                <p:childTnLst>
+                  <p:par>
+                    <p:cTn id="3" fill="hold">
+                      <p:stCondLst>
+                        <p:cond delay="indefinite"/>
+                        <p:cond evt="onBegin" delay="0">
+                          <p:tn val="2"/>
+                        </p:cond>
+                      </p:stCondLst>
+                      <p:childTnLst>
+                        <p:par>
+                          <p:cTn id="4" fill="hold">
+                            <p:stCondLst>
+                              <p:cond delay="0"/>
+                            </p:stCondLst>
+                            <p:childTnLst>
+                              <p:par>
+                                <p:cTn id="5" presetID="10" presetClass="entr" presetSubtype="0" fill="hold" grpId="0" nodeType="withEffect">
+                                  <p:stCondLst>
+                                    <p:cond delay="0"/>
+                                  </p:stCondLst>
+                                  <p:childTnLst>
+                                    <p:set>
+                                      <p:cBhvr>
+                                        <p:cTn id="6" dur="1" fill="hold">
+                                          <p:stCondLst>
+                                            <p:cond delay="0"/>
+                                          </p:stCondLst>
+                                        </p:cTn>
+                                        <p:tgtEl>
+                                          <p:spTgt spid="2"/>
+                                        </p:tgtEl>
+                                        <p:attrNameLst>
+                                          <p:attrName>style.visibility</p:attrName>
+                                        </p:attrNameLst>
+                                      </p:cBhvr>
+                                      <p:to>
+                                        <p:strVal val="visible"/>
+                                      </p:to>
+                                    </p:set>
+                                    <p:animEffect transition="in" filter="fade">
+                                      <p:cBhvr>
+                                        <p:cTn id="7" dur="450"/>
+                                        <p:tgtEl>
+                                          <p:spTgt spid="2"/>
+                                        </p:tgtEl>
+                                      </p:cBhvr>
+                                    </p:animEffect>
+                                    <p:anim calcmode="lin" valueType="num">
+                                      <p:cBhvr additive="base">
+                                        <p:cTn id="8" dur="450" fill="hold"/>
+                                        <p:tgtEl>
+                                          <p:spTgt spid="2"/>
+                                        </p:tgtEl>
+                                        <p:attrNameLst>
+                                          <p:attrName>ppt_y</p:attrName>
+                                        </p:attrNameLst>
+                                      </p:cBhvr>
+                                      <p:tavLst>
+                                        <p:tav tm="0">
+                                          <p:val>
+                                            <p:strVal val="#ppt_y+0.025"/>
+                                          </p:val>
+                                        </p:tav>
+                                        <p:tav tm="100000">
+                                          <p:val>
+                                            <p:strVal val="#ppt_y"/>
+                                          </p:val>
+                                        </p:tav>
+                                      </p:tavLst>
+                                    </p:anim>
+                                  </p:childTnLst>
+                                </p:cTn>
+                              </p:par>
+                              <p:par>
+                                <p:cTn id="9" presetID="10" presetClass="entr" presetSubtype="0" fill="hold" grpId="0" nodeType="withEffect">
+                                  <p:stCondLst>
+                                    <p:cond delay="160"/>
+                                  </p:stCondLst>
+                                  <p:childTnLst>
+                                    <p:set>
+                                      <p:cBhvr>
+                                        <p:cTn id="10" dur="1" fill="hold">
+                                          <p:stCondLst>
+                                            <p:cond delay="0"/>
+                                          </p:stCondLst>
+                                        </p:cTn>
+                                        <p:tgtEl>
+                                          <p:spTgt spid="3"/>
+                                        </p:tgtEl>
+                                        <p:attrNameLst>
+                                          <p:attrName>style.visibility</p:attrName>
+                                        </p:attrNameLst>
+                                      </p:cBhvr>
+                                      <p:to>
+                                        <p:strVal val="visible"/>
+                                      </p:to>
+                                    </p:set>
+                                    <p:animEffect transition="in" filter="fade">
+                                      <p:cBhvr>
+                                        <p:cTn id="11" dur="450"/>
+                                        <p:tgtEl>
+                                          <p:spTgt spid="3"/>
+                                        </p:tgtEl>
+                                      </p:cBhvr>
+                                    </p:animEffect>
+                                    <p:anim calcmode="lin" valueType="num">
+                                      <p:cBhvr additive="base">
+                                        <p:cTn id="12" dur="450" fill="hold"/>
+                                        <p:tgtEl>
+                                          <p:spTgt spid="3"/>
+                                        </p:tgtEl>
+                                        <p:attrNameLst>
+                                          <p:attrName>ppt_y</p:attrName>
+                                        </p:attrNameLst>
+                                      </p:cBhvr>
+                                      <p:tavLst>
+                                        <p:tav tm="0">
+                                          <p:val>
+                                            <p:strVal val="#ppt_y+0.025"/>
+                                          </p:val>
+                                        </p:tav>
+                                        <p:tav tm="100000">
+                                          <p:val>
+                                            <p:strVal val="#ppt_y"/>
+                                          </p:val>
+                                        </p:tav>
+                                      </p:tavLst>
+                                    </p:anim>
+                                  </p:childTnLst>
+                                </p:cTn>
+                              </p:par>
+                              <p:par>
+                                <p:cTn id="13" presetID="10" presetClass="entr" presetSubtype="0" fill="hold" grpId="0" nodeType="withEffect">
+                                  <p:stCondLst>
+                                    <p:cond delay="320"/>
+                                  </p:stCondLst>
+                                  <p:childTnLst>
+                                    <p:set>
+                                      <p:cBhvr>
+                                        <p:cTn id="14" dur="1" fill="hold">
+                                          <p:stCondLst>
+                                            <p:cond delay="0"/>
+                                          </p:stCondLst>
+                                        </p:cTn>
+                                        <p:tgtEl>
+                                          <p:spTgt spid="4"/>
+                                        </p:tgtEl>
+                                        <p:attrNameLst>
+                                          <p:attrName>style.visibility</p:attrName>
+                                        </p:attrNameLst>
+                                      </p:cBhvr>
+                                      <p:to>
+                                        <p:strVal val="visible"/>
+                                      </p:to>
+                                    </p:set>
+                                    <p:animEffect transition="in" filter="fade">
+                                      <p:cBhvr>
+                                        <p:cTn id="15" dur="450"/>
+                                        <p:tgtEl>
+                                          <p:spTgt spid="4"/>
+                                        </p:tgtEl>
+                                      </p:cBhvr>
+                                    </p:animEffect>
+                                    <p:anim calcmode="lin" valueType="num">
+                                      <p:cBhvr additive="base">
+                                        <p:cTn id="16" dur="450" fill="hold"/>
+                                        <p:tgtEl>
+                                          <p:spTgt spid="4"/>
+                                        </p:tgtEl>
+                                        <p:attrNameLst>
+                                          <p:attrName>ppt_y</p:attrName>
+                                        </p:attrNameLst>
+                                      </p:cBhvr>
+                                      <p:tavLst>
+                                        <p:tav tm="0">
+                                          <p:val>
+                                            <p:strVal val="#ppt_y+0.025"/>
+                                          </p:val>
+                                        </p:tav>
+                                        <p:tav tm="100000">
+                                          <p:val>
+                                            <p:strVal val="#ppt_y"/>
+                                          </p:val>
+                                        </p:tav>
+                                      </p:tavLst>
+                                    </p:anim>
+                                  </p:childTnLst>
+                                </p:cTn>
+                              </p:par>
+                              <p:par>
+                                <p:cTn id="17" presetID="10" presetClass="entr" presetSubtype="0" fill="hold" grpId="0" nodeType="withEffect">
+                                  <p:stCondLst>
+                                    <p:cond delay="480"/>
+                                  </p:stCondLst>
+                                  <p:childTnLst>
+                                    <p:set>
+                                      <p:cBhvr>
+                                        <p:cTn id="18" dur="1" fill="hold">
+                                          <p:stCondLst>
+                                            <p:cond delay="0"/>
+                                          </p:stCondLst>
+                                        </p:cTn>
+                                        <p:tgtEl>
+                                          <p:spTgt spid="5"/>
+                                        </p:tgtEl>
+                                        <p:attrNameLst>
+                                          <p:attrName>style.visibility</p:attrName>
+                                        </p:attrNameLst>
+                                      </p:cBhvr>
+                                      <p:to>
+                                        <p:strVal val="visible"/>
+                                      </p:to>
+                                    </p:set>
+                                    <p:animEffect transition="in" filter="fade">
+                                      <p:cBhvr>
+                                        <p:cTn id="19" dur="450"/>
+                                        <p:tgtEl>
+                                          <p:spTgt spid="5"/>
+                                        </p:tgtEl>
+                                      </p:cBhvr>
+                                    </p:animEffect>
+                                    <p:anim calcmode="lin" valueType="num">
+                                      <p:cBhvr additive="base">
+                                        <p:cTn id="20" dur="450" fill="hold"/>
+                                        <p:tgtEl>
+                                          <p:spTgt spid="5"/>
+                                        </p:tgtEl>
+                                        <p:attrNameLst>
+                                          <p:attrName>ppt_y</p:attrName>
+                                        </p:attrNameLst>
+                                      </p:cBhvr>
+                                      <p:tavLst>
+                                        <p:tav tm="0">
+                                          <p:val>
+                                            <p:strVal val="#ppt_y+0.025"/>
+                                          </p:val>
+                                        </p:tav>
+                                        <p:tav tm="100000">
+                                          <p:val>
+                                            <p:strVal val="#ppt_y"/>
+                                          </p:val>
+                                        </p:tav>
+                                      </p:tavLst>
+                                    </p:anim>
+                                  </p:childTnLst>
+                                </p:cTn>
+                              </p:par>
+                            </p:childTnLst>
+                          </p:cTn>
+                        </p:par>
+                      </p:childTnLst>
+                    </p:cTn>
+                  </p:par>
+                </p:childTnLst>
+              </p:cTn>
+              <p:prevCondLst>
+                <p:cond evt="onPrev" delay="0">
+                  <p:tgtEl>
+                    <p:sldTgt/>
+                  </p:tgtEl>
+                </p:cond>
+              </p:prevCondLst>
+              <p:nextCondLst>
+                <p:cond evt="onNext" delay="0">
+                  <p:tgtEl>
+                    <p:sldTgt/>
+                  </p:tgtEl>
+                </p:cond>
+              </p:nextCondLst>
+            </p:seq>
+          </p:childTnLst>
+        </p:cTn>
+      </p:par>
+    </p:tnLst>
+    <p:bldLst>
+      <p:bldP spid="2" grpId="0"/>
+      <p:bldP spid="3" grpId="0"/>
+      <p:bldP spid="4" grpId="0"/>
+      <p:bldP spid="5" grpId="0"/>
+    </p:bldLst>
+  </p:timing>
 </p:sld>
 </file>
 
@@ -2482,6 +3181,239 @@
   <p:clrMapOvr>
     <a:masterClrMapping/>
   </p:clrMapOvr>
+  <p:transition xmlns:p14="http://schemas.microsoft.com/office/powerpoint/2010/main" spd="slow" p14:dur="700">
+    <p:fade/>
+  </p:transition>
+  <p:timing xmlns:p="http://schemas.openxmlformats.org/presentationml/2006/main">
+    <p:tnLst>
+      <p:par>
+        <p:cTn id="1" dur="indefinite" restart="never" nodeType="tmRoot">
+          <p:childTnLst>
+            <p:seq concurrent="1" nextAc="seek">
+              <p:cTn id="2" dur="indefinite" nodeType="mainSeq">
+                <p:childTnLst>
+                  <p:par>
+                    <p:cTn id="3" fill="hold">
+                      <p:stCondLst>
+                        <p:cond delay="indefinite"/>
+                        <p:cond evt="onBegin" delay="0">
+                          <p:tn val="2"/>
+                        </p:cond>
+                      </p:stCondLst>
+                      <p:childTnLst>
+                        <p:par>
+                          <p:cTn id="4" fill="hold">
+                            <p:stCondLst>
+                              <p:cond delay="0"/>
+                            </p:stCondLst>
+                            <p:childTnLst>
+                              <p:par>
+                                <p:cTn id="5" presetID="10" presetClass="entr" presetSubtype="0" fill="hold" grpId="0" nodeType="withEffect">
+                                  <p:stCondLst>
+                                    <p:cond delay="0"/>
+                                  </p:stCondLst>
+                                  <p:childTnLst>
+                                    <p:set>
+                                      <p:cBhvr>
+                                        <p:cTn id="6" dur="1" fill="hold">
+                                          <p:stCondLst>
+                                            <p:cond delay="0"/>
+                                          </p:stCondLst>
+                                        </p:cTn>
+                                        <p:tgtEl>
+                                          <p:spTgt spid="2"/>
+                                        </p:tgtEl>
+                                        <p:attrNameLst>
+                                          <p:attrName>style.visibility</p:attrName>
+                                        </p:attrNameLst>
+                                      </p:cBhvr>
+                                      <p:to>
+                                        <p:strVal val="visible"/>
+                                      </p:to>
+                                    </p:set>
+                                    <p:animEffect transition="in" filter="fade">
+                                      <p:cBhvr>
+                                        <p:cTn id="7" dur="450"/>
+                                        <p:tgtEl>
+                                          <p:spTgt spid="2"/>
+                                        </p:tgtEl>
+                                      </p:cBhvr>
+                                    </p:animEffect>
+                                    <p:anim calcmode="lin" valueType="num">
+                                      <p:cBhvr additive="base">
+                                        <p:cTn id="8" dur="450" fill="hold"/>
+                                        <p:tgtEl>
+                                          <p:spTgt spid="2"/>
+                                        </p:tgtEl>
+                                        <p:attrNameLst>
+                                          <p:attrName>ppt_y</p:attrName>
+                                        </p:attrNameLst>
+                                      </p:cBhvr>
+                                      <p:tavLst>
+                                        <p:tav tm="0">
+                                          <p:val>
+                                            <p:strVal val="#ppt_y+0.025"/>
+                                          </p:val>
+                                        </p:tav>
+                                        <p:tav tm="100000">
+                                          <p:val>
+                                            <p:strVal val="#ppt_y"/>
+                                          </p:val>
+                                        </p:tav>
+                                      </p:tavLst>
+                                    </p:anim>
+                                  </p:childTnLst>
+                                </p:cTn>
+                              </p:par>
+                              <p:par>
+                                <p:cTn id="9" presetID="10" presetClass="entr" presetSubtype="0" fill="hold" grpId="0" nodeType="withEffect">
+                                  <p:stCondLst>
+                                    <p:cond delay="160"/>
+                                  </p:stCondLst>
+                                  <p:childTnLst>
+                                    <p:set>
+                                      <p:cBhvr>
+                                        <p:cTn id="10" dur="1" fill="hold">
+                                          <p:stCondLst>
+                                            <p:cond delay="0"/>
+                                          </p:stCondLst>
+                                        </p:cTn>
+                                        <p:tgtEl>
+                                          <p:spTgt spid="3"/>
+                                        </p:tgtEl>
+                                        <p:attrNameLst>
+                                          <p:attrName>style.visibility</p:attrName>
+                                        </p:attrNameLst>
+                                      </p:cBhvr>
+                                      <p:to>
+                                        <p:strVal val="visible"/>
+                                      </p:to>
+                                    </p:set>
+                                    <p:animEffect transition="in" filter="fade">
+                                      <p:cBhvr>
+                                        <p:cTn id="11" dur="450"/>
+                                        <p:tgtEl>
+                                          <p:spTgt spid="3"/>
+                                        </p:tgtEl>
+                                      </p:cBhvr>
+                                    </p:animEffect>
+                                    <p:anim calcmode="lin" valueType="num">
+                                      <p:cBhvr additive="base">
+                                        <p:cTn id="12" dur="450" fill="hold"/>
+                                        <p:tgtEl>
+                                          <p:spTgt spid="3"/>
+                                        </p:tgtEl>
+                                        <p:attrNameLst>
+                                          <p:attrName>ppt_y</p:attrName>
+                                        </p:attrNameLst>
+                                      </p:cBhvr>
+                                      <p:tavLst>
+                                        <p:tav tm="0">
+                                          <p:val>
+                                            <p:strVal val="#ppt_y+0.025"/>
+                                          </p:val>
+                                        </p:tav>
+                                        <p:tav tm="100000">
+                                          <p:val>
+                                            <p:strVal val="#ppt_y"/>
+                                          </p:val>
+                                        </p:tav>
+                                      </p:tavLst>
+                                    </p:anim>
+                                  </p:childTnLst>
+                                </p:cTn>
+                              </p:par>
+                              <p:par>
+                                <p:cTn id="13" presetID="10" presetClass="entr" presetSubtype="0" fill="hold" grpId="0" nodeType="withEffect">
+                                  <p:stCondLst>
+                                    <p:cond delay="320"/>
+                                  </p:stCondLst>
+                                  <p:childTnLst>
+                                    <p:set>
+                                      <p:cBhvr>
+                                        <p:cTn id="14" dur="1" fill="hold">
+                                          <p:stCondLst>
+                                            <p:cond delay="0"/>
+                                          </p:stCondLst>
+                                        </p:cTn>
+                                        <p:tgtEl>
+                                          <p:spTgt spid="4"/>
+                                        </p:tgtEl>
+                                        <p:attrNameLst>
+                                          <p:attrName>style.visibility</p:attrName>
+                                        </p:attrNameLst>
+                                      </p:cBhvr>
+                                      <p:to>
+                                        <p:strVal val="visible"/>
+                                      </p:to>
+                                    </p:set>
+                                    <p:animEffect transition="in" filter="fade">
+                                      <p:cBhvr>
+                                        <p:cTn id="15" dur="450"/>
+                                        <p:tgtEl>
+                                          <p:spTgt spid="4"/>
+                                        </p:tgtEl>
+                                      </p:cBhvr>
+                                    </p:animEffect>
+                                    <p:anim calcmode="lin" valueType="num">
+                                      <p:cBhvr additive="base">
+                                        <p:cTn id="16" dur="450" fill="hold"/>
+                                        <p:tgtEl>
+                                          <p:spTgt spid="4"/>
+                                        </p:tgtEl>
+                                        <p:attrNameLst>
+                                          <p:attrName>ppt_y</p:attrName>
+                                        </p:attrNameLst>
+                                      </p:cBhvr>
+                                      <p:tavLst>
+                                        <p:tav tm="0">
+                                          <p:val>
+                                            <p:strVal val="#ppt_y+0.025"/>
+                                          </p:val>
+                                        </p:tav>
+                                        <p:tav tm="100000">
+                                          <p:val>
+                                            <p:strVal val="#ppt_y"/>
+                                          </p:val>
+                                        </p:tav>
+                                      </p:tavLst>
+                                    </p:anim>
+                                  </p:childTnLst>
+                                </p:cTn>
+                              </p:par>
+                            </p:childTnLst>
+                          </p:cTn>
+                        </p:par>
+                      </p:childTnLst>
+                    </p:cTn>
+                  </p:par>
+                </p:childTnLst>
+              </p:cTn>
+              <p:prevCondLst>
+                <p:cond evt="onPrev" delay="0">
+                  <p:tgtEl>
+                    <p:sldTgt/>
+                  </p:tgtEl>
+                </p:cond>
+              </p:prevCondLst>
+              <p:nextCondLst>
+                <p:cond evt="onNext" delay="0">
+                  <p:tgtEl>
+                    <p:sldTgt/>
+                  </p:tgtEl>
+                </p:cond>
+              </p:nextCondLst>
+            </p:seq>
+          </p:childTnLst>
+        </p:cTn>
+      </p:par>
+    </p:tnLst>
+    <p:bldLst>
+      <p:bldP spid="2" grpId="0"/>
+      <p:bldP spid="3" grpId="0"/>
+      <p:bldP spid="4" grpId="0"/>
+    </p:bldLst>
+  </p:timing>
 </p:sld>
 </file>
 
@@ -2556,6 +3488,121 @@
   <p:clrMapOvr>
     <a:masterClrMapping/>
   </p:clrMapOvr>
+  <p:transition xmlns:p14="http://schemas.microsoft.com/office/powerpoint/2010/main" spd="slow" p14:dur="700">
+    <p:fade/>
+  </p:transition>
+  <p:timing xmlns:p="http://schemas.openxmlformats.org/presentationml/2006/main">
+    <p:tnLst>
+      <p:par>
+        <p:cTn id="1" dur="indefinite" restart="never" nodeType="tmRoot">
+          <p:childTnLst>
+            <p:seq concurrent="1" nextAc="seek">
+              <p:cTn id="2" dur="indefinite" nodeType="mainSeq">
+                <p:childTnLst>
+                  <p:par>
+                    <p:cTn id="3" fill="hold">
+                      <p:stCondLst>
+                        <p:cond delay="indefinite"/>
+                        <p:cond evt="onBegin" delay="0">
+                          <p:tn val="2"/>
+                        </p:cond>
+                      </p:stCondLst>
+                      <p:childTnLst>
+                        <p:par>
+                          <p:cTn id="4" fill="hold">
+                            <p:stCondLst>
+                              <p:cond delay="0"/>
+                            </p:stCondLst>
+                            <p:childTnLst>
+                              <p:par>
+                                <p:cTn id="5" presetID="10" presetClass="entr" presetSubtype="0" fill="hold" grpId="0" nodeType="withEffect">
+                                  <p:stCondLst>
+                                    <p:cond delay="0"/>
+                                  </p:stCondLst>
+                                  <p:childTnLst>
+                                    <p:set>
+                                      <p:cBhvr>
+                                        <p:cTn id="6" dur="1" fill="hold">
+                                          <p:stCondLst>
+                                            <p:cond delay="0"/>
+                                          </p:stCondLst>
+                                        </p:cTn>
+                                        <p:tgtEl>
+                                          <p:spTgt spid="2"/>
+                                        </p:tgtEl>
+                                        <p:attrNameLst>
+                                          <p:attrName>style.visibility</p:attrName>
+                                        </p:attrNameLst>
+                                      </p:cBhvr>
+                                      <p:to>
+                                        <p:strVal val="visible"/>
+                                      </p:to>
+                                    </p:set>
+                                    <p:animEffect transition="in" filter="fade">
+                                      <p:cBhvr>
+                                        <p:cTn id="7" dur="450"/>
+                                        <p:tgtEl>
+                                          <p:spTgt spid="2"/>
+                                        </p:tgtEl>
+                                      </p:cBhvr>
+                                    </p:animEffect>
+                                    <p:anim calcmode="lin" valueType="num">
+                                      <p:cBhvr additive="base">
+                                        <p:cTn id="8" dur="450" fill="hold"/>
+                                        <p:tgtEl>
+                                          <p:spTgt spid="2"/>
+                                        </p:tgtEl>
+                                        <p:attrNameLst>
+                                          <p:attrName>ppt_y</p:attrName>
+                                        </p:attrNameLst>
+                                      </p:cBhvr>
+                                      <p:tavLst>
+                                        <p:tav tm="0">
+                                          <p:val>
+                                            <p:strVal val="#ppt_y+0.025"/>
+                                          </p:val>
+                                        </p:tav>
+                                        <p:tav tm="100000">
+                                          <p:val>
+                                            <p:strVal val="#ppt_y"/>
+                                          </p:val>
+                                        </p:tav>
+                                      </p:tavLst>
+                                    </p:anim>
+                                  </p:childTnLst>
+                                </p:cTn>
+                              </p:par>
+                            </p:childTnLst>
+                          </p:cTn>
+                        </p:par>
+                      </p:childTnLst>
+                    </p:cTn>
+                  </p:par>
+                </p:childTnLst>
+              </p:cTn>
+              <p:prevCondLst>
+                <p:cond evt="onPrev" delay="0">
+                  <p:tgtEl>
+                    <p:sldTgt/>
+                  </p:tgtEl>
+                </p:cond>
+              </p:prevCondLst>
+              <p:nextCondLst>
+                <p:cond evt="onNext" delay="0">
+                  <p:tgtEl>
+                    <p:sldTgt/>
+                  </p:tgtEl>
+                </p:cond>
+              </p:nextCondLst>
+            </p:seq>
+          </p:childTnLst>
+        </p:cTn>
+      </p:par>
+    </p:tnLst>
+    <p:bldLst>
+      <p:bldP spid="2" grpId="0"/>
+    </p:bldLst>
+  </p:timing>
 </p:sld>
 </file>
 
@@ -2705,6 +3752,239 @@
   <p:clrMapOvr>
     <a:masterClrMapping/>
   </p:clrMapOvr>
+  <p:transition xmlns:p14="http://schemas.microsoft.com/office/powerpoint/2010/main" spd="slow" p14:dur="700">
+    <p:fade/>
+  </p:transition>
+  <p:timing xmlns:p="http://schemas.openxmlformats.org/presentationml/2006/main">
+    <p:tnLst>
+      <p:par>
+        <p:cTn id="1" dur="indefinite" restart="never" nodeType="tmRoot">
+          <p:childTnLst>
+            <p:seq concurrent="1" nextAc="seek">
+              <p:cTn id="2" dur="indefinite" nodeType="mainSeq">
+                <p:childTnLst>
+                  <p:par>
+                    <p:cTn id="3" fill="hold">
+                      <p:stCondLst>
+                        <p:cond delay="indefinite"/>
+                        <p:cond evt="onBegin" delay="0">
+                          <p:tn val="2"/>
+                        </p:cond>
+                      </p:stCondLst>
+                      <p:childTnLst>
+                        <p:par>
+                          <p:cTn id="4" fill="hold">
+                            <p:stCondLst>
+                              <p:cond delay="0"/>
+                            </p:stCondLst>
+                            <p:childTnLst>
+                              <p:par>
+                                <p:cTn id="5" presetID="10" presetClass="entr" presetSubtype="0" fill="hold" grpId="0" nodeType="withEffect">
+                                  <p:stCondLst>
+                                    <p:cond delay="0"/>
+                                  </p:stCondLst>
+                                  <p:childTnLst>
+                                    <p:set>
+                                      <p:cBhvr>
+                                        <p:cTn id="6" dur="1" fill="hold">
+                                          <p:stCondLst>
+                                            <p:cond delay="0"/>
+                                          </p:stCondLst>
+                                        </p:cTn>
+                                        <p:tgtEl>
+                                          <p:spTgt spid="2"/>
+                                        </p:tgtEl>
+                                        <p:attrNameLst>
+                                          <p:attrName>style.visibility</p:attrName>
+                                        </p:attrNameLst>
+                                      </p:cBhvr>
+                                      <p:to>
+                                        <p:strVal val="visible"/>
+                                      </p:to>
+                                    </p:set>
+                                    <p:animEffect transition="in" filter="fade">
+                                      <p:cBhvr>
+                                        <p:cTn id="7" dur="450"/>
+                                        <p:tgtEl>
+                                          <p:spTgt spid="2"/>
+                                        </p:tgtEl>
+                                      </p:cBhvr>
+                                    </p:animEffect>
+                                    <p:anim calcmode="lin" valueType="num">
+                                      <p:cBhvr additive="base">
+                                        <p:cTn id="8" dur="450" fill="hold"/>
+                                        <p:tgtEl>
+                                          <p:spTgt spid="2"/>
+                                        </p:tgtEl>
+                                        <p:attrNameLst>
+                                          <p:attrName>ppt_y</p:attrName>
+                                        </p:attrNameLst>
+                                      </p:cBhvr>
+                                      <p:tavLst>
+                                        <p:tav tm="0">
+                                          <p:val>
+                                            <p:strVal val="#ppt_y+0.025"/>
+                                          </p:val>
+                                        </p:tav>
+                                        <p:tav tm="100000">
+                                          <p:val>
+                                            <p:strVal val="#ppt_y"/>
+                                          </p:val>
+                                        </p:tav>
+                                      </p:tavLst>
+                                    </p:anim>
+                                  </p:childTnLst>
+                                </p:cTn>
+                              </p:par>
+                              <p:par>
+                                <p:cTn id="9" presetID="10" presetClass="entr" presetSubtype="0" fill="hold" grpId="0" nodeType="withEffect">
+                                  <p:stCondLst>
+                                    <p:cond delay="160"/>
+                                  </p:stCondLst>
+                                  <p:childTnLst>
+                                    <p:set>
+                                      <p:cBhvr>
+                                        <p:cTn id="10" dur="1" fill="hold">
+                                          <p:stCondLst>
+                                            <p:cond delay="0"/>
+                                          </p:stCondLst>
+                                        </p:cTn>
+                                        <p:tgtEl>
+                                          <p:spTgt spid="3"/>
+                                        </p:tgtEl>
+                                        <p:attrNameLst>
+                                          <p:attrName>style.visibility</p:attrName>
+                                        </p:attrNameLst>
+                                      </p:cBhvr>
+                                      <p:to>
+                                        <p:strVal val="visible"/>
+                                      </p:to>
+                                    </p:set>
+                                    <p:animEffect transition="in" filter="fade">
+                                      <p:cBhvr>
+                                        <p:cTn id="11" dur="450"/>
+                                        <p:tgtEl>
+                                          <p:spTgt spid="3"/>
+                                        </p:tgtEl>
+                                      </p:cBhvr>
+                                    </p:animEffect>
+                                    <p:anim calcmode="lin" valueType="num">
+                                      <p:cBhvr additive="base">
+                                        <p:cTn id="12" dur="450" fill="hold"/>
+                                        <p:tgtEl>
+                                          <p:spTgt spid="3"/>
+                                        </p:tgtEl>
+                                        <p:attrNameLst>
+                                          <p:attrName>ppt_y</p:attrName>
+                                        </p:attrNameLst>
+                                      </p:cBhvr>
+                                      <p:tavLst>
+                                        <p:tav tm="0">
+                                          <p:val>
+                                            <p:strVal val="#ppt_y+0.025"/>
+                                          </p:val>
+                                        </p:tav>
+                                        <p:tav tm="100000">
+                                          <p:val>
+                                            <p:strVal val="#ppt_y"/>
+                                          </p:val>
+                                        </p:tav>
+                                      </p:tavLst>
+                                    </p:anim>
+                                  </p:childTnLst>
+                                </p:cTn>
+                              </p:par>
+                              <p:par>
+                                <p:cTn id="13" presetID="10" presetClass="entr" presetSubtype="0" fill="hold" grpId="0" nodeType="withEffect">
+                                  <p:stCondLst>
+                                    <p:cond delay="320"/>
+                                  </p:stCondLst>
+                                  <p:childTnLst>
+                                    <p:set>
+                                      <p:cBhvr>
+                                        <p:cTn id="14" dur="1" fill="hold">
+                                          <p:stCondLst>
+                                            <p:cond delay="0"/>
+                                          </p:stCondLst>
+                                        </p:cTn>
+                                        <p:tgtEl>
+                                          <p:spTgt spid="4"/>
+                                        </p:tgtEl>
+                                        <p:attrNameLst>
+                                          <p:attrName>style.visibility</p:attrName>
+                                        </p:attrNameLst>
+                                      </p:cBhvr>
+                                      <p:to>
+                                        <p:strVal val="visible"/>
+                                      </p:to>
+                                    </p:set>
+                                    <p:animEffect transition="in" filter="fade">
+                                      <p:cBhvr>
+                                        <p:cTn id="15" dur="450"/>
+                                        <p:tgtEl>
+                                          <p:spTgt spid="4"/>
+                                        </p:tgtEl>
+                                      </p:cBhvr>
+                                    </p:animEffect>
+                                    <p:anim calcmode="lin" valueType="num">
+                                      <p:cBhvr additive="base">
+                                        <p:cTn id="16" dur="450" fill="hold"/>
+                                        <p:tgtEl>
+                                          <p:spTgt spid="4"/>
+                                        </p:tgtEl>
+                                        <p:attrNameLst>
+                                          <p:attrName>ppt_y</p:attrName>
+                                        </p:attrNameLst>
+                                      </p:cBhvr>
+                                      <p:tavLst>
+                                        <p:tav tm="0">
+                                          <p:val>
+                                            <p:strVal val="#ppt_y+0.025"/>
+                                          </p:val>
+                                        </p:tav>
+                                        <p:tav tm="100000">
+                                          <p:val>
+                                            <p:strVal val="#ppt_y"/>
+                                          </p:val>
+                                        </p:tav>
+                                      </p:tavLst>
+                                    </p:anim>
+                                  </p:childTnLst>
+                                </p:cTn>
+                              </p:par>
+                            </p:childTnLst>
+                          </p:cTn>
+                        </p:par>
+                      </p:childTnLst>
+                    </p:cTn>
+                  </p:par>
+                </p:childTnLst>
+              </p:cTn>
+              <p:prevCondLst>
+                <p:cond evt="onPrev" delay="0">
+                  <p:tgtEl>
+                    <p:sldTgt/>
+                  </p:tgtEl>
+                </p:cond>
+              </p:prevCondLst>
+              <p:nextCondLst>
+                <p:cond evt="onNext" delay="0">
+                  <p:tgtEl>
+                    <p:sldTgt/>
+                  </p:tgtEl>
+                </p:cond>
+              </p:nextCondLst>
+            </p:seq>
+          </p:childTnLst>
+        </p:cTn>
+      </p:par>
+    </p:tnLst>
+    <p:bldLst>
+      <p:bldP spid="2" grpId="0"/>
+      <p:bldP spid="3" grpId="0"/>
+      <p:bldP spid="4" grpId="0"/>
+    </p:bldLst>
+  </p:timing>
 </p:sld>
 </file>
 
@@ -2815,6 +4095,180 @@
   <p:clrMapOvr>
     <a:masterClrMapping/>
   </p:clrMapOvr>
+  <p:transition xmlns:p14="http://schemas.microsoft.com/office/powerpoint/2010/main" spd="slow" p14:dur="700">
+    <p:fade/>
+  </p:transition>
+  <p:timing xmlns:p="http://schemas.openxmlformats.org/presentationml/2006/main">
+    <p:tnLst>
+      <p:par>
+        <p:cTn id="1" dur="indefinite" restart="never" nodeType="tmRoot">
+          <p:childTnLst>
+            <p:seq concurrent="1" nextAc="seek">
+              <p:cTn id="2" dur="indefinite" nodeType="mainSeq">
+                <p:childTnLst>
+                  <p:par>
+                    <p:cTn id="3" fill="hold">
+                      <p:stCondLst>
+                        <p:cond delay="indefinite"/>
+                        <p:cond evt="onBegin" delay="0">
+                          <p:tn val="2"/>
+                        </p:cond>
+                      </p:stCondLst>
+                      <p:childTnLst>
+                        <p:par>
+                          <p:cTn id="4" fill="hold">
+                            <p:stCondLst>
+                              <p:cond delay="0"/>
+                            </p:stCondLst>
+                            <p:childTnLst>
+                              <p:par>
+                                <p:cTn id="5" presetID="10" presetClass="entr" presetSubtype="0" fill="hold" grpId="0" nodeType="withEffect">
+                                  <p:stCondLst>
+                                    <p:cond delay="0"/>
+                                  </p:stCondLst>
+                                  <p:childTnLst>
+                                    <p:set>
+                                      <p:cBhvr>
+                                        <p:cTn id="6" dur="1" fill="hold">
+                                          <p:stCondLst>
+                                            <p:cond delay="0"/>
+                                          </p:stCondLst>
+                                        </p:cTn>
+                                        <p:tgtEl>
+                                          <p:spTgt spid="2"/>
+                                        </p:tgtEl>
+                                        <p:attrNameLst>
+                                          <p:attrName>style.visibility</p:attrName>
+                                        </p:attrNameLst>
+                                      </p:cBhvr>
+                                      <p:to>
+                                        <p:strVal val="visible"/>
+                                      </p:to>
+                                    </p:set>
+                                    <p:animEffect transition="in" filter="fade">
+                                      <p:cBhvr>
+                                        <p:cTn id="7" dur="450"/>
+                                        <p:tgtEl>
+                                          <p:spTgt spid="2"/>
+                                        </p:tgtEl>
+                                      </p:cBhvr>
+                                    </p:animEffect>
+                                    <p:anim calcmode="lin" valueType="num">
+                                      <p:cBhvr additive="base">
+                                        <p:cTn id="8" dur="450" fill="hold"/>
+                                        <p:tgtEl>
+                                          <p:spTgt spid="2"/>
+                                        </p:tgtEl>
+                                        <p:attrNameLst>
+                                          <p:attrName>ppt_y</p:attrName>
+                                        </p:attrNameLst>
+                                      </p:cBhvr>
+                                      <p:tavLst>
+                                        <p:tav tm="0">
+                                          <p:val>
+                                            <p:strVal val="#ppt_y+0.025"/>
+                                          </p:val>
+                                        </p:tav>
+                                        <p:tav tm="100000">
+                                          <p:val>
+                                            <p:strVal val="#ppt_y"/>
+                                          </p:val>
+                                        </p:tav>
+                                      </p:tavLst>
+                                    </p:anim>
+                                  </p:childTnLst>
+                                </p:cTn>
+                              </p:par>
+                              <p:par>
+                                <p:cTn id="9" presetID="10" presetClass="entr" presetSubtype="0" fill="hold" grpId="0" nodeType="withEffect">
+                                  <p:stCondLst>
+                                    <p:cond delay="160"/>
+                                  </p:stCondLst>
+                                  <p:childTnLst>
+                                    <p:set>
+                                      <p:cBhvr>
+                                        <p:cTn id="10" dur="1" fill="hold">
+                                          <p:stCondLst>
+                                            <p:cond delay="0"/>
+                                          </p:stCondLst>
+                                        </p:cTn>
+                                        <p:tgtEl>
+                                          <p:spTgt spid="3"/>
+                                        </p:tgtEl>
+                                        <p:attrNameLst>
+                                          <p:attrName>style.visibility</p:attrName>
+                                        </p:attrNameLst>
+                                      </p:cBhvr>
+                                      <p:to>
+                                        <p:strVal val="visible"/>
+                                      </p:to>
+                                    </p:set>
+                                    <p:animEffect transition="in" filter="fade">
+                                      <p:cBhvr>
+                                        <p:cTn id="11" dur="450"/>
+                                        <p:tgtEl>
+                                          <p:spTgt spid="3"/>
+                                        </p:tgtEl>
+                                      </p:cBhvr>
+                                    </p:animEffect>
+                                    <p:anim calcmode="lin" valueType="num">
+                                      <p:cBhvr additive="base">
+                                        <p:cTn id="12" dur="450" fill="hold"/>
+                                        <p:tgtEl>
+                                          <p:spTgt spid="3"/>
+                                        </p:tgtEl>
+                                        <p:attrNameLst>
+                                          <p:attrName>ppt_y</p:attrName>
+                                        </p:attrNameLst>
+                                      </p:cBhvr>
+                                      <p:tavLst>
+                                        <p:tav tm="0">
+                                          <p:val>
+                                            <p:strVal val="#ppt_y+0.025"/>
+                                          </p:val>
+                                        </p:tav>
+                                        <p:tav tm="100000">
+                                          <p:val>
+                                            <p:strVal val="#ppt_y"/>
+                                          </p:val>
+                                        </p:tav>
+                                      </p:tavLst>
+                                    </p:anim>
+                                  </p:childTnLst>
+                                </p:cTn>
+                              </p:par>
+                            </p:childTnLst>
+                          </p:cTn>
+                        </p:par>
+                      </p:childTnLst>
+                    </p:cTn>
+                  </p:par>
+                </p:childTnLst>
+              </p:cTn>
+              <p:prevCondLst>
+                <p:cond evt="onPrev" delay="0">
+                  <p:tgtEl>
+                    <p:sldTgt/>
+                  </p:tgtEl>
+                </p:cond>
+              </p:prevCondLst>
+              <p:nextCondLst>
+                <p:cond evt="onNext" delay="0">
+                  <p:tgtEl>
+                    <p:sldTgt/>
+                  </p:tgtEl>
+                </p:cond>
+              </p:nextCondLst>
+            </p:seq>
+          </p:childTnLst>
+        </p:cTn>
+      </p:par>
+    </p:tnLst>
+    <p:bldLst>
+      <p:bldP spid="2" grpId="0"/>
+      <p:bldP spid="3" grpId="0"/>
+    </p:bldLst>
+  </p:timing>
 </p:sld>
 </file>
 
@@ -3017,6 +4471,298 @@
   <p:clrMapOvr>
     <a:masterClrMapping/>
   </p:clrMapOvr>
+  <p:transition xmlns:p14="http://schemas.microsoft.com/office/powerpoint/2010/main" spd="slow" p14:dur="700">
+    <p:fade/>
+  </p:transition>
+  <p:timing xmlns:p="http://schemas.openxmlformats.org/presentationml/2006/main">
+    <p:tnLst>
+      <p:par>
+        <p:cTn id="1" dur="indefinite" restart="never" nodeType="tmRoot">
+          <p:childTnLst>
+            <p:seq concurrent="1" nextAc="seek">
+              <p:cTn id="2" dur="indefinite" nodeType="mainSeq">
+                <p:childTnLst>
+                  <p:par>
+                    <p:cTn id="3" fill="hold">
+                      <p:stCondLst>
+                        <p:cond delay="indefinite"/>
+                        <p:cond evt="onBegin" delay="0">
+                          <p:tn val="2"/>
+                        </p:cond>
+                      </p:stCondLst>
+                      <p:childTnLst>
+                        <p:par>
+                          <p:cTn id="4" fill="hold">
+                            <p:stCondLst>
+                              <p:cond delay="0"/>
+                            </p:stCondLst>
+                            <p:childTnLst>
+                              <p:par>
+                                <p:cTn id="5" presetID="10" presetClass="entr" presetSubtype="0" fill="hold" grpId="0" nodeType="withEffect">
+                                  <p:stCondLst>
+                                    <p:cond delay="0"/>
+                                  </p:stCondLst>
+                                  <p:childTnLst>
+                                    <p:set>
+                                      <p:cBhvr>
+                                        <p:cTn id="6" dur="1" fill="hold">
+                                          <p:stCondLst>
+                                            <p:cond delay="0"/>
+                                          </p:stCondLst>
+                                        </p:cTn>
+                                        <p:tgtEl>
+                                          <p:spTgt spid="2"/>
+                                        </p:tgtEl>
+                                        <p:attrNameLst>
+                                          <p:attrName>style.visibility</p:attrName>
+                                        </p:attrNameLst>
+                                      </p:cBhvr>
+                                      <p:to>
+                                        <p:strVal val="visible"/>
+                                      </p:to>
+                                    </p:set>
+                                    <p:animEffect transition="in" filter="fade">
+                                      <p:cBhvr>
+                                        <p:cTn id="7" dur="450"/>
+                                        <p:tgtEl>
+                                          <p:spTgt spid="2"/>
+                                        </p:tgtEl>
+                                      </p:cBhvr>
+                                    </p:animEffect>
+                                    <p:anim calcmode="lin" valueType="num">
+                                      <p:cBhvr additive="base">
+                                        <p:cTn id="8" dur="450" fill="hold"/>
+                                        <p:tgtEl>
+                                          <p:spTgt spid="2"/>
+                                        </p:tgtEl>
+                                        <p:attrNameLst>
+                                          <p:attrName>ppt_y</p:attrName>
+                                        </p:attrNameLst>
+                                      </p:cBhvr>
+                                      <p:tavLst>
+                                        <p:tav tm="0">
+                                          <p:val>
+                                            <p:strVal val="#ppt_y+0.025"/>
+                                          </p:val>
+                                        </p:tav>
+                                        <p:tav tm="100000">
+                                          <p:val>
+                                            <p:strVal val="#ppt_y"/>
+                                          </p:val>
+                                        </p:tav>
+                                      </p:tavLst>
+                                    </p:anim>
+                                  </p:childTnLst>
+                                </p:cTn>
+                              </p:par>
+                              <p:par>
+                                <p:cTn id="9" presetID="10" presetClass="entr" presetSubtype="0" fill="hold" grpId="0" nodeType="withEffect">
+                                  <p:stCondLst>
+                                    <p:cond delay="160"/>
+                                  </p:stCondLst>
+                                  <p:childTnLst>
+                                    <p:set>
+                                      <p:cBhvr>
+                                        <p:cTn id="10" dur="1" fill="hold">
+                                          <p:stCondLst>
+                                            <p:cond delay="0"/>
+                                          </p:stCondLst>
+                                        </p:cTn>
+                                        <p:tgtEl>
+                                          <p:spTgt spid="3"/>
+                                        </p:tgtEl>
+                                        <p:attrNameLst>
+                                          <p:attrName>style.visibility</p:attrName>
+                                        </p:attrNameLst>
+                                      </p:cBhvr>
+                                      <p:to>
+                                        <p:strVal val="visible"/>
+                                      </p:to>
+                                    </p:set>
+                                    <p:animEffect transition="in" filter="fade">
+                                      <p:cBhvr>
+                                        <p:cTn id="11" dur="450"/>
+                                        <p:tgtEl>
+                                          <p:spTgt spid="3"/>
+                                        </p:tgtEl>
+                                      </p:cBhvr>
+                                    </p:animEffect>
+                                    <p:anim calcmode="lin" valueType="num">
+                                      <p:cBhvr additive="base">
+                                        <p:cTn id="12" dur="450" fill="hold"/>
+                                        <p:tgtEl>
+                                          <p:spTgt spid="3"/>
+                                        </p:tgtEl>
+                                        <p:attrNameLst>
+                                          <p:attrName>ppt_y</p:attrName>
+                                        </p:attrNameLst>
+                                      </p:cBhvr>
+                                      <p:tavLst>
+                                        <p:tav tm="0">
+                                          <p:val>
+                                            <p:strVal val="#ppt_y+0.025"/>
+                                          </p:val>
+                                        </p:tav>
+                                        <p:tav tm="100000">
+                                          <p:val>
+                                            <p:strVal val="#ppt_y"/>
+                                          </p:val>
+                                        </p:tav>
+                                      </p:tavLst>
+                                    </p:anim>
+                                  </p:childTnLst>
+                                </p:cTn>
+                              </p:par>
+                              <p:par>
+                                <p:cTn id="13" presetID="10" presetClass="entr" presetSubtype="0" fill="hold" grpId="0" nodeType="withEffect">
+                                  <p:stCondLst>
+                                    <p:cond delay="320"/>
+                                  </p:stCondLst>
+                                  <p:childTnLst>
+                                    <p:set>
+                                      <p:cBhvr>
+                                        <p:cTn id="14" dur="1" fill="hold">
+                                          <p:stCondLst>
+                                            <p:cond delay="0"/>
+                                          </p:stCondLst>
+                                        </p:cTn>
+                                        <p:tgtEl>
+                                          <p:spTgt spid="4"/>
+                                        </p:tgtEl>
+                                        <p:attrNameLst>
+                                          <p:attrName>style.visibility</p:attrName>
+                                        </p:attrNameLst>
+                                      </p:cBhvr>
+                                      <p:to>
+                                        <p:strVal val="visible"/>
+                                      </p:to>
+                                    </p:set>
+                                    <p:animEffect transition="in" filter="fade">
+                                      <p:cBhvr>
+                                        <p:cTn id="15" dur="450"/>
+                                        <p:tgtEl>
+                                          <p:spTgt spid="4"/>
+                                        </p:tgtEl>
+                                      </p:cBhvr>
+                                    </p:animEffect>
+                                    <p:anim calcmode="lin" valueType="num">
+                                      <p:cBhvr additive="base">
+                                        <p:cTn id="16" dur="450" fill="hold"/>
+                                        <p:tgtEl>
+                                          <p:spTgt spid="4"/>
+                                        </p:tgtEl>
+                                        <p:attrNameLst>
+                                          <p:attrName>ppt_y</p:attrName>
+                                        </p:attrNameLst>
+                                      </p:cBhvr>
+                                      <p:tavLst>
+                                        <p:tav tm="0">
+                                          <p:val>
+                                            <p:strVal val="#ppt_y+0.025"/>
+                                          </p:val>
+                                        </p:tav>
+                                        <p:tav tm="100000">
+                                          <p:val>
+                                            <p:strVal val="#ppt_y"/>
+                                          </p:val>
+                                        </p:tav>
+                                      </p:tavLst>
+                                    </p:anim>
+                                  </p:childTnLst>
+                                </p:cTn>
+                              </p:par>
+                              <p:par>
+                                <p:cTn id="17" presetID="10" presetClass="entr" presetSubtype="0" fill="hold" grpId="0" nodeType="withEffect">
+                                  <p:stCondLst>
+                                    <p:cond delay="480"/>
+                                  </p:stCondLst>
+                                  <p:childTnLst>
+                                    <p:set>
+                                      <p:cBhvr>
+                                        <p:cTn id="18" dur="1" fill="hold">
+                                          <p:stCondLst>
+                                            <p:cond delay="0"/>
+                                          </p:stCondLst>
+                                        </p:cTn>
+                                        <p:tgtEl>
+                                          <p:spTgt spid="5"/>
+                                        </p:tgtEl>
+                                        <p:attrNameLst>
+                                          <p:attrName>style.visibility</p:attrName>
+                                        </p:attrNameLst>
+                                      </p:cBhvr>
+                                      <p:to>
+                                        <p:strVal val="visible"/>
+                                      </p:to>
+                                    </p:set>
+                                    <p:animEffect transition="in" filter="fade">
+                                      <p:cBhvr>
+                                        <p:cTn id="19" dur="450"/>
+                                        <p:tgtEl>
+                                          <p:spTgt spid="5"/>
+                                        </p:tgtEl>
+                                      </p:cBhvr>
+                                    </p:animEffect>
+                                    <p:anim calcmode="lin" valueType="num">
+                                      <p:cBhvr additive="base">
+                                        <p:cTn id="20" dur="450" fill="hold"/>
+                                        <p:tgtEl>
+                                          <p:spTgt spid="5"/>
+                                        </p:tgtEl>
+                                        <p:attrNameLst>
+                                          <p:attrName>ppt_y</p:attrName>
+                                        </p:attrNameLst>
+                                      </p:cBhvr>
+                                      <p:tavLst>
+                                        <p:tav tm="0">
+                                          <p:val>
+                                            <p:strVal val="#ppt_y+0.025"/>
+                                          </p:val>
+                                        </p:tav>
+                                        <p:tav tm="100000">
+                                          <p:val>
+                                            <p:strVal val="#ppt_y"/>
+                                          </p:val>
+                                        </p:tav>
+                                      </p:tavLst>
+                                    </p:anim>
+                                  </p:childTnLst>
+                                </p:cTn>
+                              </p:par>
+                            </p:childTnLst>
+                          </p:cTn>
+                        </p:par>
+                      </p:childTnLst>
+                    </p:cTn>
+                  </p:par>
+                </p:childTnLst>
+              </p:cTn>
+              <p:prevCondLst>
+                <p:cond evt="onPrev" delay="0">
+                  <p:tgtEl>
+                    <p:sldTgt/>
+                  </p:tgtEl>
+                </p:cond>
+              </p:prevCondLst>
+              <p:nextCondLst>
+                <p:cond evt="onNext" delay="0">
+                  <p:tgtEl>
+                    <p:sldTgt/>
+                  </p:tgtEl>
+                </p:cond>
+              </p:nextCondLst>
+            </p:seq>
+          </p:childTnLst>
+        </p:cTn>
+      </p:par>
+    </p:tnLst>
+    <p:bldLst>
+      <p:bldP spid="2" grpId="0"/>
+      <p:bldP spid="3" grpId="0"/>
+      <p:bldP spid="4" grpId="0"/>
+      <p:bldP spid="5" grpId="0"/>
+    </p:bldLst>
+  </p:timing>
 </p:sld>
 </file>
 
@@ -3331,6 +5077,475 @@
   <p:clrMapOvr>
     <a:masterClrMapping/>
   </p:clrMapOvr>
+  <p:transition xmlns:p14="http://schemas.microsoft.com/office/powerpoint/2010/main" spd="slow" p14:dur="700">
+    <p:fade/>
+  </p:transition>
+  <p:timing xmlns:p="http://schemas.openxmlformats.org/presentationml/2006/main">
+    <p:tnLst>
+      <p:par>
+        <p:cTn id="1" dur="indefinite" restart="never" nodeType="tmRoot">
+          <p:childTnLst>
+            <p:seq concurrent="1" nextAc="seek">
+              <p:cTn id="2" dur="indefinite" nodeType="mainSeq">
+                <p:childTnLst>
+                  <p:par>
+                    <p:cTn id="3" fill="hold">
+                      <p:stCondLst>
+                        <p:cond delay="indefinite"/>
+                        <p:cond evt="onBegin" delay="0">
+                          <p:tn val="2"/>
+                        </p:cond>
+                      </p:stCondLst>
+                      <p:childTnLst>
+                        <p:par>
+                          <p:cTn id="4" fill="hold">
+                            <p:stCondLst>
+                              <p:cond delay="0"/>
+                            </p:stCondLst>
+                            <p:childTnLst>
+                              <p:par>
+                                <p:cTn id="5" presetID="10" presetClass="entr" presetSubtype="0" fill="hold" grpId="0" nodeType="withEffect">
+                                  <p:stCondLst>
+                                    <p:cond delay="0"/>
+                                  </p:stCondLst>
+                                  <p:childTnLst>
+                                    <p:set>
+                                      <p:cBhvr>
+                                        <p:cTn id="6" dur="1" fill="hold">
+                                          <p:stCondLst>
+                                            <p:cond delay="0"/>
+                                          </p:stCondLst>
+                                        </p:cTn>
+                                        <p:tgtEl>
+                                          <p:spTgt spid="2"/>
+                                        </p:tgtEl>
+                                        <p:attrNameLst>
+                                          <p:attrName>style.visibility</p:attrName>
+                                        </p:attrNameLst>
+                                      </p:cBhvr>
+                                      <p:to>
+                                        <p:strVal val="visible"/>
+                                      </p:to>
+                                    </p:set>
+                                    <p:animEffect transition="in" filter="fade">
+                                      <p:cBhvr>
+                                        <p:cTn id="7" dur="450"/>
+                                        <p:tgtEl>
+                                          <p:spTgt spid="2"/>
+                                        </p:tgtEl>
+                                      </p:cBhvr>
+                                    </p:animEffect>
+                                    <p:anim calcmode="lin" valueType="num">
+                                      <p:cBhvr additive="base">
+                                        <p:cTn id="8" dur="450" fill="hold"/>
+                                        <p:tgtEl>
+                                          <p:spTgt spid="2"/>
+                                        </p:tgtEl>
+                                        <p:attrNameLst>
+                                          <p:attrName>ppt_y</p:attrName>
+                                        </p:attrNameLst>
+                                      </p:cBhvr>
+                                      <p:tavLst>
+                                        <p:tav tm="0">
+                                          <p:val>
+                                            <p:strVal val="#ppt_y+0.025"/>
+                                          </p:val>
+                                        </p:tav>
+                                        <p:tav tm="100000">
+                                          <p:val>
+                                            <p:strVal val="#ppt_y"/>
+                                          </p:val>
+                                        </p:tav>
+                                      </p:tavLst>
+                                    </p:anim>
+                                  </p:childTnLst>
+                                </p:cTn>
+                              </p:par>
+                              <p:par>
+                                <p:cTn id="9" presetID="10" presetClass="entr" presetSubtype="0" fill="hold" grpId="0" nodeType="withEffect">
+                                  <p:stCondLst>
+                                    <p:cond delay="160"/>
+                                  </p:stCondLst>
+                                  <p:childTnLst>
+                                    <p:set>
+                                      <p:cBhvr>
+                                        <p:cTn id="10" dur="1" fill="hold">
+                                          <p:stCondLst>
+                                            <p:cond delay="0"/>
+                                          </p:stCondLst>
+                                        </p:cTn>
+                                        <p:tgtEl>
+                                          <p:spTgt spid="3"/>
+                                        </p:tgtEl>
+                                        <p:attrNameLst>
+                                          <p:attrName>style.visibility</p:attrName>
+                                        </p:attrNameLst>
+                                      </p:cBhvr>
+                                      <p:to>
+                                        <p:strVal val="visible"/>
+                                      </p:to>
+                                    </p:set>
+                                    <p:animEffect transition="in" filter="fade">
+                                      <p:cBhvr>
+                                        <p:cTn id="11" dur="450"/>
+                                        <p:tgtEl>
+                                          <p:spTgt spid="3"/>
+                                        </p:tgtEl>
+                                      </p:cBhvr>
+                                    </p:animEffect>
+                                    <p:anim calcmode="lin" valueType="num">
+                                      <p:cBhvr additive="base">
+                                        <p:cTn id="12" dur="450" fill="hold"/>
+                                        <p:tgtEl>
+                                          <p:spTgt spid="3"/>
+                                        </p:tgtEl>
+                                        <p:attrNameLst>
+                                          <p:attrName>ppt_y</p:attrName>
+                                        </p:attrNameLst>
+                                      </p:cBhvr>
+                                      <p:tavLst>
+                                        <p:tav tm="0">
+                                          <p:val>
+                                            <p:strVal val="#ppt_y+0.025"/>
+                                          </p:val>
+                                        </p:tav>
+                                        <p:tav tm="100000">
+                                          <p:val>
+                                            <p:strVal val="#ppt_y"/>
+                                          </p:val>
+                                        </p:tav>
+                                      </p:tavLst>
+                                    </p:anim>
+                                  </p:childTnLst>
+                                </p:cTn>
+                              </p:par>
+                              <p:par>
+                                <p:cTn id="13" presetID="10" presetClass="entr" presetSubtype="0" fill="hold" grpId="0" nodeType="withEffect">
+                                  <p:stCondLst>
+                                    <p:cond delay="320"/>
+                                  </p:stCondLst>
+                                  <p:childTnLst>
+                                    <p:set>
+                                      <p:cBhvr>
+                                        <p:cTn id="14" dur="1" fill="hold">
+                                          <p:stCondLst>
+                                            <p:cond delay="0"/>
+                                          </p:stCondLst>
+                                        </p:cTn>
+                                        <p:tgtEl>
+                                          <p:spTgt spid="5"/>
+                                        </p:tgtEl>
+                                        <p:attrNameLst>
+                                          <p:attrName>style.visibility</p:attrName>
+                                        </p:attrNameLst>
+                                      </p:cBhvr>
+                                      <p:to>
+                                        <p:strVal val="visible"/>
+                                      </p:to>
+                                    </p:set>
+                                    <p:animEffect transition="in" filter="fade">
+                                      <p:cBhvr>
+                                        <p:cTn id="15" dur="450"/>
+                                        <p:tgtEl>
+                                          <p:spTgt spid="5"/>
+                                        </p:tgtEl>
+                                      </p:cBhvr>
+                                    </p:animEffect>
+                                    <p:anim calcmode="lin" valueType="num">
+                                      <p:cBhvr additive="base">
+                                        <p:cTn id="16" dur="450" fill="hold"/>
+                                        <p:tgtEl>
+                                          <p:spTgt spid="5"/>
+                                        </p:tgtEl>
+                                        <p:attrNameLst>
+                                          <p:attrName>ppt_y</p:attrName>
+                                        </p:attrNameLst>
+                                      </p:cBhvr>
+                                      <p:tavLst>
+                                        <p:tav tm="0">
+                                          <p:val>
+                                            <p:strVal val="#ppt_y+0.025"/>
+                                          </p:val>
+                                        </p:tav>
+                                        <p:tav tm="100000">
+                                          <p:val>
+                                            <p:strVal val="#ppt_y"/>
+                                          </p:val>
+                                        </p:tav>
+                                      </p:tavLst>
+                                    </p:anim>
+                                  </p:childTnLst>
+                                </p:cTn>
+                              </p:par>
+                              <p:par>
+                                <p:cTn id="17" presetID="10" presetClass="entr" presetSubtype="0" fill="hold" grpId="0" nodeType="withEffect">
+                                  <p:stCondLst>
+                                    <p:cond delay="480"/>
+                                  </p:stCondLst>
+                                  <p:childTnLst>
+                                    <p:set>
+                                      <p:cBhvr>
+                                        <p:cTn id="18" dur="1" fill="hold">
+                                          <p:stCondLst>
+                                            <p:cond delay="0"/>
+                                          </p:stCondLst>
+                                        </p:cTn>
+                                        <p:tgtEl>
+                                          <p:spTgt spid="7"/>
+                                        </p:tgtEl>
+                                        <p:attrNameLst>
+                                          <p:attrName>style.visibility</p:attrName>
+                                        </p:attrNameLst>
+                                      </p:cBhvr>
+                                      <p:to>
+                                        <p:strVal val="visible"/>
+                                      </p:to>
+                                    </p:set>
+                                    <p:animEffect transition="in" filter="fade">
+                                      <p:cBhvr>
+                                        <p:cTn id="19" dur="450"/>
+                                        <p:tgtEl>
+                                          <p:spTgt spid="7"/>
+                                        </p:tgtEl>
+                                      </p:cBhvr>
+                                    </p:animEffect>
+                                    <p:anim calcmode="lin" valueType="num">
+                                      <p:cBhvr additive="base">
+                                        <p:cTn id="20" dur="450" fill="hold"/>
+                                        <p:tgtEl>
+                                          <p:spTgt spid="7"/>
+                                        </p:tgtEl>
+                                        <p:attrNameLst>
+                                          <p:attrName>ppt_y</p:attrName>
+                                        </p:attrNameLst>
+                                      </p:cBhvr>
+                                      <p:tavLst>
+                                        <p:tav tm="0">
+                                          <p:val>
+                                            <p:strVal val="#ppt_y+0.025"/>
+                                          </p:val>
+                                        </p:tav>
+                                        <p:tav tm="100000">
+                                          <p:val>
+                                            <p:strVal val="#ppt_y"/>
+                                          </p:val>
+                                        </p:tav>
+                                      </p:tavLst>
+                                    </p:anim>
+                                  </p:childTnLst>
+                                </p:cTn>
+                              </p:par>
+                              <p:par>
+                                <p:cTn id="21" presetID="10" presetClass="entr" presetSubtype="0" fill="hold" grpId="0" nodeType="withEffect">
+                                  <p:stCondLst>
+                                    <p:cond delay="640"/>
+                                  </p:stCondLst>
+                                  <p:childTnLst>
+                                    <p:set>
+                                      <p:cBhvr>
+                                        <p:cTn id="22" dur="1" fill="hold">
+                                          <p:stCondLst>
+                                            <p:cond delay="0"/>
+                                          </p:stCondLst>
+                                        </p:cTn>
+                                        <p:tgtEl>
+                                          <p:spTgt spid="4"/>
+                                        </p:tgtEl>
+                                        <p:attrNameLst>
+                                          <p:attrName>style.visibility</p:attrName>
+                                        </p:attrNameLst>
+                                      </p:cBhvr>
+                                      <p:to>
+                                        <p:strVal val="visible"/>
+                                      </p:to>
+                                    </p:set>
+                                    <p:animEffect transition="in" filter="fade">
+                                      <p:cBhvr>
+                                        <p:cTn id="23" dur="450"/>
+                                        <p:tgtEl>
+                                          <p:spTgt spid="4"/>
+                                        </p:tgtEl>
+                                      </p:cBhvr>
+                                    </p:animEffect>
+                                    <p:anim calcmode="lin" valueType="num">
+                                      <p:cBhvr additive="base">
+                                        <p:cTn id="24" dur="450" fill="hold"/>
+                                        <p:tgtEl>
+                                          <p:spTgt spid="4"/>
+                                        </p:tgtEl>
+                                        <p:attrNameLst>
+                                          <p:attrName>ppt_y</p:attrName>
+                                        </p:attrNameLst>
+                                      </p:cBhvr>
+                                      <p:tavLst>
+                                        <p:tav tm="0">
+                                          <p:val>
+                                            <p:strVal val="#ppt_y+0.025"/>
+                                          </p:val>
+                                        </p:tav>
+                                        <p:tav tm="100000">
+                                          <p:val>
+                                            <p:strVal val="#ppt_y"/>
+                                          </p:val>
+                                        </p:tav>
+                                      </p:tavLst>
+                                    </p:anim>
+                                  </p:childTnLst>
+                                </p:cTn>
+                              </p:par>
+                              <p:par>
+                                <p:cTn id="25" presetID="10" presetClass="entr" presetSubtype="0" fill="hold" grpId="0" nodeType="withEffect">
+                                  <p:stCondLst>
+                                    <p:cond delay="800"/>
+                                  </p:stCondLst>
+                                  <p:childTnLst>
+                                    <p:set>
+                                      <p:cBhvr>
+                                        <p:cTn id="26" dur="1" fill="hold">
+                                          <p:stCondLst>
+                                            <p:cond delay="0"/>
+                                          </p:stCondLst>
+                                        </p:cTn>
+                                        <p:tgtEl>
+                                          <p:spTgt spid="6"/>
+                                        </p:tgtEl>
+                                        <p:attrNameLst>
+                                          <p:attrName>style.visibility</p:attrName>
+                                        </p:attrNameLst>
+                                      </p:cBhvr>
+                                      <p:to>
+                                        <p:strVal val="visible"/>
+                                      </p:to>
+                                    </p:set>
+                                    <p:animEffect transition="in" filter="fade">
+                                      <p:cBhvr>
+                                        <p:cTn id="27" dur="450"/>
+                                        <p:tgtEl>
+                                          <p:spTgt spid="6"/>
+                                        </p:tgtEl>
+                                      </p:cBhvr>
+                                    </p:animEffect>
+                                    <p:anim calcmode="lin" valueType="num">
+                                      <p:cBhvr additive="base">
+                                        <p:cTn id="28" dur="450" fill="hold"/>
+                                        <p:tgtEl>
+                                          <p:spTgt spid="6"/>
+                                        </p:tgtEl>
+                                        <p:attrNameLst>
+                                          <p:attrName>ppt_y</p:attrName>
+                                        </p:attrNameLst>
+                                      </p:cBhvr>
+                                      <p:tavLst>
+                                        <p:tav tm="0">
+                                          <p:val>
+                                            <p:strVal val="#ppt_y+0.025"/>
+                                          </p:val>
+                                        </p:tav>
+                                        <p:tav tm="100000">
+                                          <p:val>
+                                            <p:strVal val="#ppt_y"/>
+                                          </p:val>
+                                        </p:tav>
+                                      </p:tavLst>
+                                    </p:anim>
+                                  </p:childTnLst>
+                                </p:cTn>
+                              </p:par>
+                              <p:par>
+                                <p:cTn id="29" presetID="10" presetClass="entr" presetSubtype="0" fill="hold" grpId="0" nodeType="withEffect">
+                                  <p:stCondLst>
+                                    <p:cond delay="960"/>
+                                  </p:stCondLst>
+                                  <p:childTnLst>
+                                    <p:set>
+                                      <p:cBhvr>
+                                        <p:cTn id="30" dur="1" fill="hold">
+                                          <p:stCondLst>
+                                            <p:cond delay="0"/>
+                                          </p:stCondLst>
+                                        </p:cTn>
+                                        <p:tgtEl>
+                                          <p:spTgt spid="8"/>
+                                        </p:tgtEl>
+                                        <p:attrNameLst>
+                                          <p:attrName>style.visibility</p:attrName>
+                                        </p:attrNameLst>
+                                      </p:cBhvr>
+                                      <p:to>
+                                        <p:strVal val="visible"/>
+                                      </p:to>
+                                    </p:set>
+                                    <p:animEffect transition="in" filter="fade">
+                                      <p:cBhvr>
+                                        <p:cTn id="31" dur="450"/>
+                                        <p:tgtEl>
+                                          <p:spTgt spid="8"/>
+                                        </p:tgtEl>
+                                      </p:cBhvr>
+                                    </p:animEffect>
+                                    <p:anim calcmode="lin" valueType="num">
+                                      <p:cBhvr additive="base">
+                                        <p:cTn id="32" dur="450" fill="hold"/>
+                                        <p:tgtEl>
+                                          <p:spTgt spid="8"/>
+                                        </p:tgtEl>
+                                        <p:attrNameLst>
+                                          <p:attrName>ppt_y</p:attrName>
+                                        </p:attrNameLst>
+                                      </p:cBhvr>
+                                      <p:tavLst>
+                                        <p:tav tm="0">
+                                          <p:val>
+                                            <p:strVal val="#ppt_y+0.025"/>
+                                          </p:val>
+                                        </p:tav>
+                                        <p:tav tm="100000">
+                                          <p:val>
+                                            <p:strVal val="#ppt_y"/>
+                                          </p:val>
+                                        </p:tav>
+                                      </p:tavLst>
+                                    </p:anim>
+                                  </p:childTnLst>
+                                </p:cTn>
+                              </p:par>
+                            </p:childTnLst>
+                          </p:cTn>
+                        </p:par>
+                      </p:childTnLst>
+                    </p:cTn>
+                  </p:par>
+                </p:childTnLst>
+              </p:cTn>
+              <p:prevCondLst>
+                <p:cond evt="onPrev" delay="0">
+                  <p:tgtEl>
+                    <p:sldTgt/>
+                  </p:tgtEl>
+                </p:cond>
+              </p:prevCondLst>
+              <p:nextCondLst>
+                <p:cond evt="onNext" delay="0">
+                  <p:tgtEl>
+                    <p:sldTgt/>
+                  </p:tgtEl>
+                </p:cond>
+              </p:nextCondLst>
+            </p:seq>
+          </p:childTnLst>
+        </p:cTn>
+      </p:par>
+    </p:tnLst>
+    <p:bldLst>
+      <p:bldP spid="2" grpId="0"/>
+      <p:bldP spid="3" grpId="0"/>
+      <p:bldP spid="5" grpId="0"/>
+      <p:bldP spid="7" grpId="0"/>
+      <p:bldP spid="4" grpId="0"/>
+      <p:bldP spid="6" grpId="0"/>
+      <p:bldP spid="8" grpId="0"/>
+    </p:bldLst>
+  </p:timing>
 </p:sld>
 </file>
 
@@ -3703,6 +5918,474 @@
   <p:clrMapOvr>
     <a:masterClrMapping/>
   </p:clrMapOvr>
+  <p:transition xmlns:p14="http://schemas.microsoft.com/office/powerpoint/2010/main" spd="slow" p14:dur="700">
+    <p:fade/>
+  </p:transition>
+  <p:timing xmlns:p="http://schemas.openxmlformats.org/presentationml/2006/main">
+    <p:tnLst>
+      <p:par>
+        <p:cTn id="1" dur="indefinite" restart="never" nodeType="tmRoot">
+          <p:childTnLst>
+            <p:seq concurrent="1" nextAc="seek">
+              <p:cTn id="2" dur="indefinite" nodeType="mainSeq">
+                <p:childTnLst>
+                  <p:par>
+                    <p:cTn id="3" fill="hold">
+                      <p:stCondLst>
+                        <p:cond delay="indefinite"/>
+                        <p:cond evt="onBegin" delay="0">
+                          <p:tn val="2"/>
+                        </p:cond>
+                      </p:stCondLst>
+                      <p:childTnLst>
+                        <p:par>
+                          <p:cTn id="4" fill="hold">
+                            <p:stCondLst>
+                              <p:cond delay="0"/>
+                            </p:stCondLst>
+                            <p:childTnLst>
+                              <p:par>
+                                <p:cTn id="5" presetID="10" presetClass="entr" presetSubtype="0" fill="hold" grpId="0" nodeType="withEffect">
+                                  <p:stCondLst>
+                                    <p:cond delay="0"/>
+                                  </p:stCondLst>
+                                  <p:childTnLst>
+                                    <p:set>
+                                      <p:cBhvr>
+                                        <p:cTn id="6" dur="1" fill="hold">
+                                          <p:stCondLst>
+                                            <p:cond delay="0"/>
+                                          </p:stCondLst>
+                                        </p:cTn>
+                                        <p:tgtEl>
+                                          <p:spTgt spid="2"/>
+                                        </p:tgtEl>
+                                        <p:attrNameLst>
+                                          <p:attrName>style.visibility</p:attrName>
+                                        </p:attrNameLst>
+                                      </p:cBhvr>
+                                      <p:to>
+                                        <p:strVal val="visible"/>
+                                      </p:to>
+                                    </p:set>
+                                    <p:animEffect transition="in" filter="fade">
+                                      <p:cBhvr>
+                                        <p:cTn id="7" dur="450"/>
+                                        <p:tgtEl>
+                                          <p:spTgt spid="2"/>
+                                        </p:tgtEl>
+                                      </p:cBhvr>
+                                    </p:animEffect>
+                                    <p:anim calcmode="lin" valueType="num">
+                                      <p:cBhvr additive="base">
+                                        <p:cTn id="8" dur="450" fill="hold"/>
+                                        <p:tgtEl>
+                                          <p:spTgt spid="2"/>
+                                        </p:tgtEl>
+                                        <p:attrNameLst>
+                                          <p:attrName>ppt_y</p:attrName>
+                                        </p:attrNameLst>
+                                      </p:cBhvr>
+                                      <p:tavLst>
+                                        <p:tav tm="0">
+                                          <p:val>
+                                            <p:strVal val="#ppt_y+0.025"/>
+                                          </p:val>
+                                        </p:tav>
+                                        <p:tav tm="100000">
+                                          <p:val>
+                                            <p:strVal val="#ppt_y"/>
+                                          </p:val>
+                                        </p:tav>
+                                      </p:tavLst>
+                                    </p:anim>
+                                  </p:childTnLst>
+                                </p:cTn>
+                              </p:par>
+                              <p:par>
+                                <p:cTn id="9" presetID="10" presetClass="entr" presetSubtype="0" fill="hold" grpId="0" nodeType="withEffect">
+                                  <p:stCondLst>
+                                    <p:cond delay="160"/>
+                                  </p:stCondLst>
+                                  <p:childTnLst>
+                                    <p:set>
+                                      <p:cBhvr>
+                                        <p:cTn id="10" dur="1" fill="hold">
+                                          <p:stCondLst>
+                                            <p:cond delay="0"/>
+                                          </p:stCondLst>
+                                        </p:cTn>
+                                        <p:tgtEl>
+                                          <p:spTgt spid="3"/>
+                                        </p:tgtEl>
+                                        <p:attrNameLst>
+                                          <p:attrName>style.visibility</p:attrName>
+                                        </p:attrNameLst>
+                                      </p:cBhvr>
+                                      <p:to>
+                                        <p:strVal val="visible"/>
+                                      </p:to>
+                                    </p:set>
+                                    <p:animEffect transition="in" filter="fade">
+                                      <p:cBhvr>
+                                        <p:cTn id="11" dur="450"/>
+                                        <p:tgtEl>
+                                          <p:spTgt spid="3"/>
+                                        </p:tgtEl>
+                                      </p:cBhvr>
+                                    </p:animEffect>
+                                    <p:anim calcmode="lin" valueType="num">
+                                      <p:cBhvr additive="base">
+                                        <p:cTn id="12" dur="450" fill="hold"/>
+                                        <p:tgtEl>
+                                          <p:spTgt spid="3"/>
+                                        </p:tgtEl>
+                                        <p:attrNameLst>
+                                          <p:attrName>ppt_y</p:attrName>
+                                        </p:attrNameLst>
+                                      </p:cBhvr>
+                                      <p:tavLst>
+                                        <p:tav tm="0">
+                                          <p:val>
+                                            <p:strVal val="#ppt_y+0.025"/>
+                                          </p:val>
+                                        </p:tav>
+                                        <p:tav tm="100000">
+                                          <p:val>
+                                            <p:strVal val="#ppt_y"/>
+                                          </p:val>
+                                        </p:tav>
+                                      </p:tavLst>
+                                    </p:anim>
+                                  </p:childTnLst>
+                                </p:cTn>
+                              </p:par>
+                              <p:par>
+                                <p:cTn id="13" presetID="10" presetClass="entr" presetSubtype="0" fill="hold" grpId="0" nodeType="withEffect">
+                                  <p:stCondLst>
+                                    <p:cond delay="320"/>
+                                  </p:stCondLst>
+                                  <p:childTnLst>
+                                    <p:set>
+                                      <p:cBhvr>
+                                        <p:cTn id="14" dur="1" fill="hold">
+                                          <p:stCondLst>
+                                            <p:cond delay="0"/>
+                                          </p:stCondLst>
+                                        </p:cTn>
+                                        <p:tgtEl>
+                                          <p:spTgt spid="8"/>
+                                        </p:tgtEl>
+                                        <p:attrNameLst>
+                                          <p:attrName>style.visibility</p:attrName>
+                                        </p:attrNameLst>
+                                      </p:cBhvr>
+                                      <p:to>
+                                        <p:strVal val="visible"/>
+                                      </p:to>
+                                    </p:set>
+                                    <p:animEffect transition="in" filter="fade">
+                                      <p:cBhvr>
+                                        <p:cTn id="15" dur="450"/>
+                                        <p:tgtEl>
+                                          <p:spTgt spid="8"/>
+                                        </p:tgtEl>
+                                      </p:cBhvr>
+                                    </p:animEffect>
+                                    <p:anim calcmode="lin" valueType="num">
+                                      <p:cBhvr additive="base">
+                                        <p:cTn id="16" dur="450" fill="hold"/>
+                                        <p:tgtEl>
+                                          <p:spTgt spid="8"/>
+                                        </p:tgtEl>
+                                        <p:attrNameLst>
+                                          <p:attrName>ppt_y</p:attrName>
+                                        </p:attrNameLst>
+                                      </p:cBhvr>
+                                      <p:tavLst>
+                                        <p:tav tm="0">
+                                          <p:val>
+                                            <p:strVal val="#ppt_y+0.025"/>
+                                          </p:val>
+                                        </p:tav>
+                                        <p:tav tm="100000">
+                                          <p:val>
+                                            <p:strVal val="#ppt_y"/>
+                                          </p:val>
+                                        </p:tav>
+                                      </p:tavLst>
+                                    </p:anim>
+                                  </p:childTnLst>
+                                </p:cTn>
+                              </p:par>
+                              <p:par>
+                                <p:cTn id="17" presetID="10" presetClass="entr" presetSubtype="0" fill="hold" grpId="0" nodeType="withEffect">
+                                  <p:stCondLst>
+                                    <p:cond delay="480"/>
+                                  </p:stCondLst>
+                                  <p:childTnLst>
+                                    <p:set>
+                                      <p:cBhvr>
+                                        <p:cTn id="18" dur="1" fill="hold">
+                                          <p:stCondLst>
+                                            <p:cond delay="0"/>
+                                          </p:stCondLst>
+                                        </p:cTn>
+                                        <p:tgtEl>
+                                          <p:spTgt spid="4"/>
+                                        </p:tgtEl>
+                                        <p:attrNameLst>
+                                          <p:attrName>style.visibility</p:attrName>
+                                        </p:attrNameLst>
+                                      </p:cBhvr>
+                                      <p:to>
+                                        <p:strVal val="visible"/>
+                                      </p:to>
+                                    </p:set>
+                                    <p:animEffect transition="in" filter="fade">
+                                      <p:cBhvr>
+                                        <p:cTn id="19" dur="450"/>
+                                        <p:tgtEl>
+                                          <p:spTgt spid="4"/>
+                                        </p:tgtEl>
+                                      </p:cBhvr>
+                                    </p:animEffect>
+                                    <p:anim calcmode="lin" valueType="num">
+                                      <p:cBhvr additive="base">
+                                        <p:cTn id="20" dur="450" fill="hold"/>
+                                        <p:tgtEl>
+                                          <p:spTgt spid="4"/>
+                                        </p:tgtEl>
+                                        <p:attrNameLst>
+                                          <p:attrName>ppt_y</p:attrName>
+                                        </p:attrNameLst>
+                                      </p:cBhvr>
+                                      <p:tavLst>
+                                        <p:tav tm="0">
+                                          <p:val>
+                                            <p:strVal val="#ppt_y+0.025"/>
+                                          </p:val>
+                                        </p:tav>
+                                        <p:tav tm="100000">
+                                          <p:val>
+                                            <p:strVal val="#ppt_y"/>
+                                          </p:val>
+                                        </p:tav>
+                                      </p:tavLst>
+                                    </p:anim>
+                                  </p:childTnLst>
+                                </p:cTn>
+                              </p:par>
+                              <p:par>
+                                <p:cTn id="21" presetID="10" presetClass="entr" presetSubtype="0" fill="hold" grpId="0" nodeType="withEffect">
+                                  <p:stCondLst>
+                                    <p:cond delay="640"/>
+                                  </p:stCondLst>
+                                  <p:childTnLst>
+                                    <p:set>
+                                      <p:cBhvr>
+                                        <p:cTn id="22" dur="1" fill="hold">
+                                          <p:stCondLst>
+                                            <p:cond delay="0"/>
+                                          </p:stCondLst>
+                                        </p:cTn>
+                                        <p:tgtEl>
+                                          <p:spTgt spid="5"/>
+                                        </p:tgtEl>
+                                        <p:attrNameLst>
+                                          <p:attrName>style.visibility</p:attrName>
+                                        </p:attrNameLst>
+                                      </p:cBhvr>
+                                      <p:to>
+                                        <p:strVal val="visible"/>
+                                      </p:to>
+                                    </p:set>
+                                    <p:animEffect transition="in" filter="fade">
+                                      <p:cBhvr>
+                                        <p:cTn id="23" dur="450"/>
+                                        <p:tgtEl>
+                                          <p:spTgt spid="5"/>
+                                        </p:tgtEl>
+                                      </p:cBhvr>
+                                    </p:animEffect>
+                                    <p:anim calcmode="lin" valueType="num">
+                                      <p:cBhvr additive="base">
+                                        <p:cTn id="24" dur="450" fill="hold"/>
+                                        <p:tgtEl>
+                                          <p:spTgt spid="5"/>
+                                        </p:tgtEl>
+                                        <p:attrNameLst>
+                                          <p:attrName>ppt_y</p:attrName>
+                                        </p:attrNameLst>
+                                      </p:cBhvr>
+                                      <p:tavLst>
+                                        <p:tav tm="0">
+                                          <p:val>
+                                            <p:strVal val="#ppt_y+0.025"/>
+                                          </p:val>
+                                        </p:tav>
+                                        <p:tav tm="100000">
+                                          <p:val>
+                                            <p:strVal val="#ppt_y"/>
+                                          </p:val>
+                                        </p:tav>
+                                      </p:tavLst>
+                                    </p:anim>
+                                  </p:childTnLst>
+                                </p:cTn>
+                              </p:par>
+                              <p:par>
+                                <p:cTn id="25" presetID="10" presetClass="entr" presetSubtype="0" fill="hold" grpId="0" nodeType="withEffect">
+                                  <p:stCondLst>
+                                    <p:cond delay="800"/>
+                                  </p:stCondLst>
+                                  <p:childTnLst>
+                                    <p:set>
+                                      <p:cBhvr>
+                                        <p:cTn id="26" dur="1" fill="hold">
+                                          <p:stCondLst>
+                                            <p:cond delay="0"/>
+                                          </p:stCondLst>
+                                        </p:cTn>
+                                        <p:tgtEl>
+                                          <p:spTgt spid="6"/>
+                                        </p:tgtEl>
+                                        <p:attrNameLst>
+                                          <p:attrName>style.visibility</p:attrName>
+                                        </p:attrNameLst>
+                                      </p:cBhvr>
+                                      <p:to>
+                                        <p:strVal val="visible"/>
+                                      </p:to>
+                                    </p:set>
+                                    <p:animEffect transition="in" filter="fade">
+                                      <p:cBhvr>
+                                        <p:cTn id="27" dur="450"/>
+                                        <p:tgtEl>
+                                          <p:spTgt spid="6"/>
+                                        </p:tgtEl>
+                                      </p:cBhvr>
+                                    </p:animEffect>
+                                    <p:anim calcmode="lin" valueType="num">
+                                      <p:cBhvr additive="base">
+                                        <p:cTn id="28" dur="450" fill="hold"/>
+                                        <p:tgtEl>
+                                          <p:spTgt spid="6"/>
+                                        </p:tgtEl>
+                                        <p:attrNameLst>
+                                          <p:attrName>ppt_y</p:attrName>
+                                        </p:attrNameLst>
+                                      </p:cBhvr>
+                                      <p:tavLst>
+                                        <p:tav tm="0">
+                                          <p:val>
+                                            <p:strVal val="#ppt_y+0.025"/>
+                                          </p:val>
+                                        </p:tav>
+                                        <p:tav tm="100000">
+                                          <p:val>
+                                            <p:strVal val="#ppt_y"/>
+                                          </p:val>
+                                        </p:tav>
+                                      </p:tavLst>
+                                    </p:anim>
+                                  </p:childTnLst>
+                                </p:cTn>
+                              </p:par>
+                              <p:par>
+                                <p:cTn id="29" presetID="10" presetClass="entr" presetSubtype="0" fill="hold" grpId="0" nodeType="withEffect">
+                                  <p:stCondLst>
+                                    <p:cond delay="960"/>
+                                  </p:stCondLst>
+                                  <p:childTnLst>
+                                    <p:set>
+                                      <p:cBhvr>
+                                        <p:cTn id="30" dur="1" fill="hold">
+                                          <p:stCondLst>
+                                            <p:cond delay="0"/>
+                                          </p:stCondLst>
+                                        </p:cTn>
+                                        <p:tgtEl>
+                                          <p:spTgt spid="7"/>
+                                        </p:tgtEl>
+                                        <p:attrNameLst>
+                                          <p:attrName>style.visibility</p:attrName>
+                                        </p:attrNameLst>
+                                      </p:cBhvr>
+                                      <p:to>
+                                        <p:strVal val="visible"/>
+                                      </p:to>
+                                    </p:set>
+                                    <p:animEffect transition="in" filter="fade">
+                                      <p:cBhvr>
+                                        <p:cTn id="31" dur="450"/>
+                                        <p:tgtEl>
+                                          <p:spTgt spid="7"/>
+                                        </p:tgtEl>
+                                      </p:cBhvr>
+                                    </p:animEffect>
+                                    <p:anim calcmode="lin" valueType="num">
+                                      <p:cBhvr additive="base">
+                                        <p:cTn id="32" dur="450" fill="hold"/>
+                                        <p:tgtEl>
+                                          <p:spTgt spid="7"/>
+                                        </p:tgtEl>
+                                        <p:attrNameLst>
+                                          <p:attrName>ppt_y</p:attrName>
+                                        </p:attrNameLst>
+                                      </p:cBhvr>
+                                      <p:tavLst>
+                                        <p:tav tm="0">
+                                          <p:val>
+                                            <p:strVal val="#ppt_y+0.025"/>
+                                          </p:val>
+                                        </p:tav>
+                                        <p:tav tm="100000">
+                                          <p:val>
+                                            <p:strVal val="#ppt_y"/>
+                                          </p:val>
+                                        </p:tav>
+                                      </p:tavLst>
+                                    </p:anim>
+                                  </p:childTnLst>
+                                </p:cTn>
+                              </p:par>
+                            </p:childTnLst>
+                          </p:cTn>
+                        </p:par>
+                      </p:childTnLst>
+                    </p:cTn>
+                  </p:par>
+                </p:childTnLst>
+              </p:cTn>
+              <p:prevCondLst>
+                <p:cond evt="onPrev" delay="0">
+                  <p:tgtEl>
+                    <p:sldTgt/>
+                  </p:tgtEl>
+                </p:cond>
+              </p:prevCondLst>
+              <p:nextCondLst>
+                <p:cond evt="onNext" delay="0">
+                  <p:tgtEl>
+                    <p:sldTgt/>
+                  </p:tgtEl>
+                </p:cond>
+              </p:nextCondLst>
+            </p:seq>
+          </p:childTnLst>
+        </p:cTn>
+      </p:par>
+    </p:tnLst>
+    <p:bldLst>
+      <p:bldP spid="2" grpId="0"/>
+      <p:bldP spid="3" grpId="0"/>
+      <p:bldP spid="4" grpId="0"/>
+      <p:bldP spid="5" grpId="0"/>
+      <p:bldP spid="6" grpId="0"/>
+      <p:bldP spid="7" grpId="0"/>
+    </p:bldLst>
+  </p:timing>
 </p:sld>
 </file>
 
@@ -4374,6 +7057,1177 @@
   <p:clrMapOvr>
     <a:masterClrMapping/>
   </p:clrMapOvr>
+  <p:transition xmlns:p14="http://schemas.microsoft.com/office/powerpoint/2010/main" spd="slow" p14:dur="700">
+    <p:fade/>
+  </p:transition>
+  <p:timing xmlns:p="http://schemas.openxmlformats.org/presentationml/2006/main">
+    <p:tnLst>
+      <p:par>
+        <p:cTn id="1" dur="indefinite" restart="never" nodeType="tmRoot">
+          <p:childTnLst>
+            <p:seq concurrent="1" nextAc="seek">
+              <p:cTn id="2" dur="indefinite" nodeType="mainSeq">
+                <p:childTnLst>
+                  <p:par>
+                    <p:cTn id="3" fill="hold">
+                      <p:stCondLst>
+                        <p:cond delay="indefinite"/>
+                        <p:cond evt="onBegin" delay="0">
+                          <p:tn val="2"/>
+                        </p:cond>
+                      </p:stCondLst>
+                      <p:childTnLst>
+                        <p:par>
+                          <p:cTn id="4" fill="hold">
+                            <p:stCondLst>
+                              <p:cond delay="0"/>
+                            </p:stCondLst>
+                            <p:childTnLst>
+                              <p:par>
+                                <p:cTn id="5" presetID="10" presetClass="entr" presetSubtype="0" fill="hold" grpId="0" nodeType="withEffect">
+                                  <p:stCondLst>
+                                    <p:cond delay="0"/>
+                                  </p:stCondLst>
+                                  <p:childTnLst>
+                                    <p:set>
+                                      <p:cBhvr>
+                                        <p:cTn id="6" dur="1" fill="hold">
+                                          <p:stCondLst>
+                                            <p:cond delay="0"/>
+                                          </p:stCondLst>
+                                        </p:cTn>
+                                        <p:tgtEl>
+                                          <p:spTgt spid="2"/>
+                                        </p:tgtEl>
+                                        <p:attrNameLst>
+                                          <p:attrName>style.visibility</p:attrName>
+                                        </p:attrNameLst>
+                                      </p:cBhvr>
+                                      <p:to>
+                                        <p:strVal val="visible"/>
+                                      </p:to>
+                                    </p:set>
+                                    <p:animEffect transition="in" filter="fade">
+                                      <p:cBhvr>
+                                        <p:cTn id="7" dur="450"/>
+                                        <p:tgtEl>
+                                          <p:spTgt spid="2"/>
+                                        </p:tgtEl>
+                                      </p:cBhvr>
+                                    </p:animEffect>
+                                    <p:anim calcmode="lin" valueType="num">
+                                      <p:cBhvr additive="base">
+                                        <p:cTn id="8" dur="450" fill="hold"/>
+                                        <p:tgtEl>
+                                          <p:spTgt spid="2"/>
+                                        </p:tgtEl>
+                                        <p:attrNameLst>
+                                          <p:attrName>ppt_y</p:attrName>
+                                        </p:attrNameLst>
+                                      </p:cBhvr>
+                                      <p:tavLst>
+                                        <p:tav tm="0">
+                                          <p:val>
+                                            <p:strVal val="#ppt_y+0.025"/>
+                                          </p:val>
+                                        </p:tav>
+                                        <p:tav tm="100000">
+                                          <p:val>
+                                            <p:strVal val="#ppt_y"/>
+                                          </p:val>
+                                        </p:tav>
+                                      </p:tavLst>
+                                    </p:anim>
+                                  </p:childTnLst>
+                                </p:cTn>
+                              </p:par>
+                              <p:par>
+                                <p:cTn id="9" presetID="10" presetClass="entr" presetSubtype="0" fill="hold" grpId="0" nodeType="withEffect">
+                                  <p:stCondLst>
+                                    <p:cond delay="61"/>
+                                  </p:stCondLst>
+                                  <p:childTnLst>
+                                    <p:set>
+                                      <p:cBhvr>
+                                        <p:cTn id="10" dur="1" fill="hold">
+                                          <p:stCondLst>
+                                            <p:cond delay="0"/>
+                                          </p:stCondLst>
+                                        </p:cTn>
+                                        <p:tgtEl>
+                                          <p:spTgt spid="3"/>
+                                        </p:tgtEl>
+                                        <p:attrNameLst>
+                                          <p:attrName>style.visibility</p:attrName>
+                                        </p:attrNameLst>
+                                      </p:cBhvr>
+                                      <p:to>
+                                        <p:strVal val="visible"/>
+                                      </p:to>
+                                    </p:set>
+                                    <p:animEffect transition="in" filter="fade">
+                                      <p:cBhvr>
+                                        <p:cTn id="11" dur="450"/>
+                                        <p:tgtEl>
+                                          <p:spTgt spid="3"/>
+                                        </p:tgtEl>
+                                      </p:cBhvr>
+                                    </p:animEffect>
+                                    <p:anim calcmode="lin" valueType="num">
+                                      <p:cBhvr additive="base">
+                                        <p:cTn id="12" dur="450" fill="hold"/>
+                                        <p:tgtEl>
+                                          <p:spTgt spid="3"/>
+                                        </p:tgtEl>
+                                        <p:attrNameLst>
+                                          <p:attrName>ppt_y</p:attrName>
+                                        </p:attrNameLst>
+                                      </p:cBhvr>
+                                      <p:tavLst>
+                                        <p:tav tm="0">
+                                          <p:val>
+                                            <p:strVal val="#ppt_y+0.025"/>
+                                          </p:val>
+                                        </p:tav>
+                                        <p:tav tm="100000">
+                                          <p:val>
+                                            <p:strVal val="#ppt_y"/>
+                                          </p:val>
+                                        </p:tav>
+                                      </p:tavLst>
+                                    </p:anim>
+                                  </p:childTnLst>
+                                </p:cTn>
+                              </p:par>
+                              <p:par>
+                                <p:cTn id="13" presetID="10" presetClass="entr" presetSubtype="0" fill="hold" grpId="0" nodeType="withEffect">
+                                  <p:stCondLst>
+                                    <p:cond delay="122"/>
+                                  </p:stCondLst>
+                                  <p:childTnLst>
+                                    <p:set>
+                                      <p:cBhvr>
+                                        <p:cTn id="14" dur="1" fill="hold">
+                                          <p:stCondLst>
+                                            <p:cond delay="0"/>
+                                          </p:stCondLst>
+                                        </p:cTn>
+                                        <p:tgtEl>
+                                          <p:spTgt spid="6"/>
+                                        </p:tgtEl>
+                                        <p:attrNameLst>
+                                          <p:attrName>style.visibility</p:attrName>
+                                        </p:attrNameLst>
+                                      </p:cBhvr>
+                                      <p:to>
+                                        <p:strVal val="visible"/>
+                                      </p:to>
+                                    </p:set>
+                                    <p:animEffect transition="in" filter="fade">
+                                      <p:cBhvr>
+                                        <p:cTn id="15" dur="450"/>
+                                        <p:tgtEl>
+                                          <p:spTgt spid="6"/>
+                                        </p:tgtEl>
+                                      </p:cBhvr>
+                                    </p:animEffect>
+                                    <p:anim calcmode="lin" valueType="num">
+                                      <p:cBhvr additive="base">
+                                        <p:cTn id="16" dur="450" fill="hold"/>
+                                        <p:tgtEl>
+                                          <p:spTgt spid="6"/>
+                                        </p:tgtEl>
+                                        <p:attrNameLst>
+                                          <p:attrName>ppt_y</p:attrName>
+                                        </p:attrNameLst>
+                                      </p:cBhvr>
+                                      <p:tavLst>
+                                        <p:tav tm="0">
+                                          <p:val>
+                                            <p:strVal val="#ppt_y+0.025"/>
+                                          </p:val>
+                                        </p:tav>
+                                        <p:tav tm="100000">
+                                          <p:val>
+                                            <p:strVal val="#ppt_y"/>
+                                          </p:val>
+                                        </p:tav>
+                                      </p:tavLst>
+                                    </p:anim>
+                                  </p:childTnLst>
+                                </p:cTn>
+                              </p:par>
+                              <p:par>
+                                <p:cTn id="17" presetID="10" presetClass="entr" presetSubtype="0" fill="hold" grpId="0" nodeType="withEffect">
+                                  <p:stCondLst>
+                                    <p:cond delay="183"/>
+                                  </p:stCondLst>
+                                  <p:childTnLst>
+                                    <p:set>
+                                      <p:cBhvr>
+                                        <p:cTn id="18" dur="1" fill="hold">
+                                          <p:stCondLst>
+                                            <p:cond delay="0"/>
+                                          </p:stCondLst>
+                                        </p:cTn>
+                                        <p:tgtEl>
+                                          <p:spTgt spid="9"/>
+                                        </p:tgtEl>
+                                        <p:attrNameLst>
+                                          <p:attrName>style.visibility</p:attrName>
+                                        </p:attrNameLst>
+                                      </p:cBhvr>
+                                      <p:to>
+                                        <p:strVal val="visible"/>
+                                      </p:to>
+                                    </p:set>
+                                    <p:animEffect transition="in" filter="fade">
+                                      <p:cBhvr>
+                                        <p:cTn id="19" dur="450"/>
+                                        <p:tgtEl>
+                                          <p:spTgt spid="9"/>
+                                        </p:tgtEl>
+                                      </p:cBhvr>
+                                    </p:animEffect>
+                                    <p:anim calcmode="lin" valueType="num">
+                                      <p:cBhvr additive="base">
+                                        <p:cTn id="20" dur="450" fill="hold"/>
+                                        <p:tgtEl>
+                                          <p:spTgt spid="9"/>
+                                        </p:tgtEl>
+                                        <p:attrNameLst>
+                                          <p:attrName>ppt_y</p:attrName>
+                                        </p:attrNameLst>
+                                      </p:cBhvr>
+                                      <p:tavLst>
+                                        <p:tav tm="0">
+                                          <p:val>
+                                            <p:strVal val="#ppt_y+0.025"/>
+                                          </p:val>
+                                        </p:tav>
+                                        <p:tav tm="100000">
+                                          <p:val>
+                                            <p:strVal val="#ppt_y"/>
+                                          </p:val>
+                                        </p:tav>
+                                      </p:tavLst>
+                                    </p:anim>
+                                  </p:childTnLst>
+                                </p:cTn>
+                              </p:par>
+                              <p:par>
+                                <p:cTn id="21" presetID="10" presetClass="entr" presetSubtype="0" fill="hold" grpId="0" nodeType="withEffect">
+                                  <p:stCondLst>
+                                    <p:cond delay="244"/>
+                                  </p:stCondLst>
+                                  <p:childTnLst>
+                                    <p:set>
+                                      <p:cBhvr>
+                                        <p:cTn id="22" dur="1" fill="hold">
+                                          <p:stCondLst>
+                                            <p:cond delay="0"/>
+                                          </p:stCondLst>
+                                        </p:cTn>
+                                        <p:tgtEl>
+                                          <p:spTgt spid="12"/>
+                                        </p:tgtEl>
+                                        <p:attrNameLst>
+                                          <p:attrName>style.visibility</p:attrName>
+                                        </p:attrNameLst>
+                                      </p:cBhvr>
+                                      <p:to>
+                                        <p:strVal val="visible"/>
+                                      </p:to>
+                                    </p:set>
+                                    <p:animEffect transition="in" filter="fade">
+                                      <p:cBhvr>
+                                        <p:cTn id="23" dur="450"/>
+                                        <p:tgtEl>
+                                          <p:spTgt spid="12"/>
+                                        </p:tgtEl>
+                                      </p:cBhvr>
+                                    </p:animEffect>
+                                    <p:anim calcmode="lin" valueType="num">
+                                      <p:cBhvr additive="base">
+                                        <p:cTn id="24" dur="450" fill="hold"/>
+                                        <p:tgtEl>
+                                          <p:spTgt spid="12"/>
+                                        </p:tgtEl>
+                                        <p:attrNameLst>
+                                          <p:attrName>ppt_y</p:attrName>
+                                        </p:attrNameLst>
+                                      </p:cBhvr>
+                                      <p:tavLst>
+                                        <p:tav tm="0">
+                                          <p:val>
+                                            <p:strVal val="#ppt_y+0.025"/>
+                                          </p:val>
+                                        </p:tav>
+                                        <p:tav tm="100000">
+                                          <p:val>
+                                            <p:strVal val="#ppt_y"/>
+                                          </p:val>
+                                        </p:tav>
+                                      </p:tavLst>
+                                    </p:anim>
+                                  </p:childTnLst>
+                                </p:cTn>
+                              </p:par>
+                              <p:par>
+                                <p:cTn id="25" presetID="10" presetClass="entr" presetSubtype="0" fill="hold" grpId="0" nodeType="withEffect">
+                                  <p:stCondLst>
+                                    <p:cond delay="305"/>
+                                  </p:stCondLst>
+                                  <p:childTnLst>
+                                    <p:set>
+                                      <p:cBhvr>
+                                        <p:cTn id="26" dur="1" fill="hold">
+                                          <p:stCondLst>
+                                            <p:cond delay="0"/>
+                                          </p:stCondLst>
+                                        </p:cTn>
+                                        <p:tgtEl>
+                                          <p:spTgt spid="15"/>
+                                        </p:tgtEl>
+                                        <p:attrNameLst>
+                                          <p:attrName>style.visibility</p:attrName>
+                                        </p:attrNameLst>
+                                      </p:cBhvr>
+                                      <p:to>
+                                        <p:strVal val="visible"/>
+                                      </p:to>
+                                    </p:set>
+                                    <p:animEffect transition="in" filter="fade">
+                                      <p:cBhvr>
+                                        <p:cTn id="27" dur="450"/>
+                                        <p:tgtEl>
+                                          <p:spTgt spid="15"/>
+                                        </p:tgtEl>
+                                      </p:cBhvr>
+                                    </p:animEffect>
+                                    <p:anim calcmode="lin" valueType="num">
+                                      <p:cBhvr additive="base">
+                                        <p:cTn id="28" dur="450" fill="hold"/>
+                                        <p:tgtEl>
+                                          <p:spTgt spid="15"/>
+                                        </p:tgtEl>
+                                        <p:attrNameLst>
+                                          <p:attrName>ppt_y</p:attrName>
+                                        </p:attrNameLst>
+                                      </p:cBhvr>
+                                      <p:tavLst>
+                                        <p:tav tm="0">
+                                          <p:val>
+                                            <p:strVal val="#ppt_y+0.025"/>
+                                          </p:val>
+                                        </p:tav>
+                                        <p:tav tm="100000">
+                                          <p:val>
+                                            <p:strVal val="#ppt_y"/>
+                                          </p:val>
+                                        </p:tav>
+                                      </p:tavLst>
+                                    </p:anim>
+                                  </p:childTnLst>
+                                </p:cTn>
+                              </p:par>
+                              <p:par>
+                                <p:cTn id="29" presetID="10" presetClass="entr" presetSubtype="0" fill="hold" grpId="0" nodeType="withEffect">
+                                  <p:stCondLst>
+                                    <p:cond delay="366"/>
+                                  </p:stCondLst>
+                                  <p:childTnLst>
+                                    <p:set>
+                                      <p:cBhvr>
+                                        <p:cTn id="30" dur="1" fill="hold">
+                                          <p:stCondLst>
+                                            <p:cond delay="0"/>
+                                          </p:stCondLst>
+                                        </p:cTn>
+                                        <p:tgtEl>
+                                          <p:spTgt spid="18"/>
+                                        </p:tgtEl>
+                                        <p:attrNameLst>
+                                          <p:attrName>style.visibility</p:attrName>
+                                        </p:attrNameLst>
+                                      </p:cBhvr>
+                                      <p:to>
+                                        <p:strVal val="visible"/>
+                                      </p:to>
+                                    </p:set>
+                                    <p:animEffect transition="in" filter="fade">
+                                      <p:cBhvr>
+                                        <p:cTn id="31" dur="450"/>
+                                        <p:tgtEl>
+                                          <p:spTgt spid="18"/>
+                                        </p:tgtEl>
+                                      </p:cBhvr>
+                                    </p:animEffect>
+                                    <p:anim calcmode="lin" valueType="num">
+                                      <p:cBhvr additive="base">
+                                        <p:cTn id="32" dur="450" fill="hold"/>
+                                        <p:tgtEl>
+                                          <p:spTgt spid="18"/>
+                                        </p:tgtEl>
+                                        <p:attrNameLst>
+                                          <p:attrName>ppt_y</p:attrName>
+                                        </p:attrNameLst>
+                                      </p:cBhvr>
+                                      <p:tavLst>
+                                        <p:tav tm="0">
+                                          <p:val>
+                                            <p:strVal val="#ppt_y+0.025"/>
+                                          </p:val>
+                                        </p:tav>
+                                        <p:tav tm="100000">
+                                          <p:val>
+                                            <p:strVal val="#ppt_y"/>
+                                          </p:val>
+                                        </p:tav>
+                                      </p:tavLst>
+                                    </p:anim>
+                                  </p:childTnLst>
+                                </p:cTn>
+                              </p:par>
+                              <p:par>
+                                <p:cTn id="33" presetID="10" presetClass="entr" presetSubtype="0" fill="hold" grpId="0" nodeType="withEffect">
+                                  <p:stCondLst>
+                                    <p:cond delay="427"/>
+                                  </p:stCondLst>
+                                  <p:childTnLst>
+                                    <p:set>
+                                      <p:cBhvr>
+                                        <p:cTn id="34" dur="1" fill="hold">
+                                          <p:stCondLst>
+                                            <p:cond delay="0"/>
+                                          </p:stCondLst>
+                                        </p:cTn>
+                                        <p:tgtEl>
+                                          <p:spTgt spid="4"/>
+                                        </p:tgtEl>
+                                        <p:attrNameLst>
+                                          <p:attrName>style.visibility</p:attrName>
+                                        </p:attrNameLst>
+                                      </p:cBhvr>
+                                      <p:to>
+                                        <p:strVal val="visible"/>
+                                      </p:to>
+                                    </p:set>
+                                    <p:animEffect transition="in" filter="fade">
+                                      <p:cBhvr>
+                                        <p:cTn id="35" dur="450"/>
+                                        <p:tgtEl>
+                                          <p:spTgt spid="4"/>
+                                        </p:tgtEl>
+                                      </p:cBhvr>
+                                    </p:animEffect>
+                                    <p:anim calcmode="lin" valueType="num">
+                                      <p:cBhvr additive="base">
+                                        <p:cTn id="36" dur="450" fill="hold"/>
+                                        <p:tgtEl>
+                                          <p:spTgt spid="4"/>
+                                        </p:tgtEl>
+                                        <p:attrNameLst>
+                                          <p:attrName>ppt_y</p:attrName>
+                                        </p:attrNameLst>
+                                      </p:cBhvr>
+                                      <p:tavLst>
+                                        <p:tav tm="0">
+                                          <p:val>
+                                            <p:strVal val="#ppt_y+0.025"/>
+                                          </p:val>
+                                        </p:tav>
+                                        <p:tav tm="100000">
+                                          <p:val>
+                                            <p:strVal val="#ppt_y"/>
+                                          </p:val>
+                                        </p:tav>
+                                      </p:tavLst>
+                                    </p:anim>
+                                  </p:childTnLst>
+                                </p:cTn>
+                              </p:par>
+                              <p:par>
+                                <p:cTn id="37" presetID="10" presetClass="entr" presetSubtype="0" fill="hold" grpId="0" nodeType="withEffect">
+                                  <p:stCondLst>
+                                    <p:cond delay="488"/>
+                                  </p:stCondLst>
+                                  <p:childTnLst>
+                                    <p:set>
+                                      <p:cBhvr>
+                                        <p:cTn id="38" dur="1" fill="hold">
+                                          <p:stCondLst>
+                                            <p:cond delay="0"/>
+                                          </p:stCondLst>
+                                        </p:cTn>
+                                        <p:tgtEl>
+                                          <p:spTgt spid="7"/>
+                                        </p:tgtEl>
+                                        <p:attrNameLst>
+                                          <p:attrName>style.visibility</p:attrName>
+                                        </p:attrNameLst>
+                                      </p:cBhvr>
+                                      <p:to>
+                                        <p:strVal val="visible"/>
+                                      </p:to>
+                                    </p:set>
+                                    <p:animEffect transition="in" filter="fade">
+                                      <p:cBhvr>
+                                        <p:cTn id="39" dur="450"/>
+                                        <p:tgtEl>
+                                          <p:spTgt spid="7"/>
+                                        </p:tgtEl>
+                                      </p:cBhvr>
+                                    </p:animEffect>
+                                    <p:anim calcmode="lin" valueType="num">
+                                      <p:cBhvr additive="base">
+                                        <p:cTn id="40" dur="450" fill="hold"/>
+                                        <p:tgtEl>
+                                          <p:spTgt spid="7"/>
+                                        </p:tgtEl>
+                                        <p:attrNameLst>
+                                          <p:attrName>ppt_y</p:attrName>
+                                        </p:attrNameLst>
+                                      </p:cBhvr>
+                                      <p:tavLst>
+                                        <p:tav tm="0">
+                                          <p:val>
+                                            <p:strVal val="#ppt_y+0.025"/>
+                                          </p:val>
+                                        </p:tav>
+                                        <p:tav tm="100000">
+                                          <p:val>
+                                            <p:strVal val="#ppt_y"/>
+                                          </p:val>
+                                        </p:tav>
+                                      </p:tavLst>
+                                    </p:anim>
+                                  </p:childTnLst>
+                                </p:cTn>
+                              </p:par>
+                              <p:par>
+                                <p:cTn id="41" presetID="10" presetClass="entr" presetSubtype="0" fill="hold" grpId="0" nodeType="withEffect">
+                                  <p:stCondLst>
+                                    <p:cond delay="549"/>
+                                  </p:stCondLst>
+                                  <p:childTnLst>
+                                    <p:set>
+                                      <p:cBhvr>
+                                        <p:cTn id="42" dur="1" fill="hold">
+                                          <p:stCondLst>
+                                            <p:cond delay="0"/>
+                                          </p:stCondLst>
+                                        </p:cTn>
+                                        <p:tgtEl>
+                                          <p:spTgt spid="10"/>
+                                        </p:tgtEl>
+                                        <p:attrNameLst>
+                                          <p:attrName>style.visibility</p:attrName>
+                                        </p:attrNameLst>
+                                      </p:cBhvr>
+                                      <p:to>
+                                        <p:strVal val="visible"/>
+                                      </p:to>
+                                    </p:set>
+                                    <p:animEffect transition="in" filter="fade">
+                                      <p:cBhvr>
+                                        <p:cTn id="43" dur="450"/>
+                                        <p:tgtEl>
+                                          <p:spTgt spid="10"/>
+                                        </p:tgtEl>
+                                      </p:cBhvr>
+                                    </p:animEffect>
+                                    <p:anim calcmode="lin" valueType="num">
+                                      <p:cBhvr additive="base">
+                                        <p:cTn id="44" dur="450" fill="hold"/>
+                                        <p:tgtEl>
+                                          <p:spTgt spid="10"/>
+                                        </p:tgtEl>
+                                        <p:attrNameLst>
+                                          <p:attrName>ppt_y</p:attrName>
+                                        </p:attrNameLst>
+                                      </p:cBhvr>
+                                      <p:tavLst>
+                                        <p:tav tm="0">
+                                          <p:val>
+                                            <p:strVal val="#ppt_y+0.025"/>
+                                          </p:val>
+                                        </p:tav>
+                                        <p:tav tm="100000">
+                                          <p:val>
+                                            <p:strVal val="#ppt_y"/>
+                                          </p:val>
+                                        </p:tav>
+                                      </p:tavLst>
+                                    </p:anim>
+                                  </p:childTnLst>
+                                </p:cTn>
+                              </p:par>
+                              <p:par>
+                                <p:cTn id="45" presetID="10" presetClass="entr" presetSubtype="0" fill="hold" grpId="0" nodeType="withEffect">
+                                  <p:stCondLst>
+                                    <p:cond delay="610"/>
+                                  </p:stCondLst>
+                                  <p:childTnLst>
+                                    <p:set>
+                                      <p:cBhvr>
+                                        <p:cTn id="46" dur="1" fill="hold">
+                                          <p:stCondLst>
+                                            <p:cond delay="0"/>
+                                          </p:stCondLst>
+                                        </p:cTn>
+                                        <p:tgtEl>
+                                          <p:spTgt spid="13"/>
+                                        </p:tgtEl>
+                                        <p:attrNameLst>
+                                          <p:attrName>style.visibility</p:attrName>
+                                        </p:attrNameLst>
+                                      </p:cBhvr>
+                                      <p:to>
+                                        <p:strVal val="visible"/>
+                                      </p:to>
+                                    </p:set>
+                                    <p:animEffect transition="in" filter="fade">
+                                      <p:cBhvr>
+                                        <p:cTn id="47" dur="450"/>
+                                        <p:tgtEl>
+                                          <p:spTgt spid="13"/>
+                                        </p:tgtEl>
+                                      </p:cBhvr>
+                                    </p:animEffect>
+                                    <p:anim calcmode="lin" valueType="num">
+                                      <p:cBhvr additive="base">
+                                        <p:cTn id="48" dur="450" fill="hold"/>
+                                        <p:tgtEl>
+                                          <p:spTgt spid="13"/>
+                                        </p:tgtEl>
+                                        <p:attrNameLst>
+                                          <p:attrName>ppt_y</p:attrName>
+                                        </p:attrNameLst>
+                                      </p:cBhvr>
+                                      <p:tavLst>
+                                        <p:tav tm="0">
+                                          <p:val>
+                                            <p:strVal val="#ppt_y+0.025"/>
+                                          </p:val>
+                                        </p:tav>
+                                        <p:tav tm="100000">
+                                          <p:val>
+                                            <p:strVal val="#ppt_y"/>
+                                          </p:val>
+                                        </p:tav>
+                                      </p:tavLst>
+                                    </p:anim>
+                                  </p:childTnLst>
+                                </p:cTn>
+                              </p:par>
+                              <p:par>
+                                <p:cTn id="49" presetID="10" presetClass="entr" presetSubtype="0" fill="hold" grpId="0" nodeType="withEffect">
+                                  <p:stCondLst>
+                                    <p:cond delay="671"/>
+                                  </p:stCondLst>
+                                  <p:childTnLst>
+                                    <p:set>
+                                      <p:cBhvr>
+                                        <p:cTn id="50" dur="1" fill="hold">
+                                          <p:stCondLst>
+                                            <p:cond delay="0"/>
+                                          </p:stCondLst>
+                                        </p:cTn>
+                                        <p:tgtEl>
+                                          <p:spTgt spid="16"/>
+                                        </p:tgtEl>
+                                        <p:attrNameLst>
+                                          <p:attrName>style.visibility</p:attrName>
+                                        </p:attrNameLst>
+                                      </p:cBhvr>
+                                      <p:to>
+                                        <p:strVal val="visible"/>
+                                      </p:to>
+                                    </p:set>
+                                    <p:animEffect transition="in" filter="fade">
+                                      <p:cBhvr>
+                                        <p:cTn id="51" dur="450"/>
+                                        <p:tgtEl>
+                                          <p:spTgt spid="16"/>
+                                        </p:tgtEl>
+                                      </p:cBhvr>
+                                    </p:animEffect>
+                                    <p:anim calcmode="lin" valueType="num">
+                                      <p:cBhvr additive="base">
+                                        <p:cTn id="52" dur="450" fill="hold"/>
+                                        <p:tgtEl>
+                                          <p:spTgt spid="16"/>
+                                        </p:tgtEl>
+                                        <p:attrNameLst>
+                                          <p:attrName>ppt_y</p:attrName>
+                                        </p:attrNameLst>
+                                      </p:cBhvr>
+                                      <p:tavLst>
+                                        <p:tav tm="0">
+                                          <p:val>
+                                            <p:strVal val="#ppt_y+0.025"/>
+                                          </p:val>
+                                        </p:tav>
+                                        <p:tav tm="100000">
+                                          <p:val>
+                                            <p:strVal val="#ppt_y"/>
+                                          </p:val>
+                                        </p:tav>
+                                      </p:tavLst>
+                                    </p:anim>
+                                  </p:childTnLst>
+                                </p:cTn>
+                              </p:par>
+                              <p:par>
+                                <p:cTn id="53" presetID="10" presetClass="entr" presetSubtype="0" fill="hold" grpId="0" nodeType="withEffect">
+                                  <p:stCondLst>
+                                    <p:cond delay="732"/>
+                                  </p:stCondLst>
+                                  <p:childTnLst>
+                                    <p:set>
+                                      <p:cBhvr>
+                                        <p:cTn id="54" dur="1" fill="hold">
+                                          <p:stCondLst>
+                                            <p:cond delay="0"/>
+                                          </p:stCondLst>
+                                        </p:cTn>
+                                        <p:tgtEl>
+                                          <p:spTgt spid="19"/>
+                                        </p:tgtEl>
+                                        <p:attrNameLst>
+                                          <p:attrName>style.visibility</p:attrName>
+                                        </p:attrNameLst>
+                                      </p:cBhvr>
+                                      <p:to>
+                                        <p:strVal val="visible"/>
+                                      </p:to>
+                                    </p:set>
+                                    <p:animEffect transition="in" filter="fade">
+                                      <p:cBhvr>
+                                        <p:cTn id="55" dur="450"/>
+                                        <p:tgtEl>
+                                          <p:spTgt spid="19"/>
+                                        </p:tgtEl>
+                                      </p:cBhvr>
+                                    </p:animEffect>
+                                    <p:anim calcmode="lin" valueType="num">
+                                      <p:cBhvr additive="base">
+                                        <p:cTn id="56" dur="450" fill="hold"/>
+                                        <p:tgtEl>
+                                          <p:spTgt spid="19"/>
+                                        </p:tgtEl>
+                                        <p:attrNameLst>
+                                          <p:attrName>ppt_y</p:attrName>
+                                        </p:attrNameLst>
+                                      </p:cBhvr>
+                                      <p:tavLst>
+                                        <p:tav tm="0">
+                                          <p:val>
+                                            <p:strVal val="#ppt_y+0.025"/>
+                                          </p:val>
+                                        </p:tav>
+                                        <p:tav tm="100000">
+                                          <p:val>
+                                            <p:strVal val="#ppt_y"/>
+                                          </p:val>
+                                        </p:tav>
+                                      </p:tavLst>
+                                    </p:anim>
+                                  </p:childTnLst>
+                                </p:cTn>
+                              </p:par>
+                              <p:par>
+                                <p:cTn id="57" presetID="10" presetClass="entr" presetSubtype="0" fill="hold" grpId="0" nodeType="withEffect">
+                                  <p:stCondLst>
+                                    <p:cond delay="793"/>
+                                  </p:stCondLst>
+                                  <p:childTnLst>
+                                    <p:set>
+                                      <p:cBhvr>
+                                        <p:cTn id="58" dur="1" fill="hold">
+                                          <p:stCondLst>
+                                            <p:cond delay="0"/>
+                                          </p:stCondLst>
+                                        </p:cTn>
+                                        <p:tgtEl>
+                                          <p:spTgt spid="5"/>
+                                        </p:tgtEl>
+                                        <p:attrNameLst>
+                                          <p:attrName>style.visibility</p:attrName>
+                                        </p:attrNameLst>
+                                      </p:cBhvr>
+                                      <p:to>
+                                        <p:strVal val="visible"/>
+                                      </p:to>
+                                    </p:set>
+                                    <p:animEffect transition="in" filter="fade">
+                                      <p:cBhvr>
+                                        <p:cTn id="59" dur="450"/>
+                                        <p:tgtEl>
+                                          <p:spTgt spid="5"/>
+                                        </p:tgtEl>
+                                      </p:cBhvr>
+                                    </p:animEffect>
+                                    <p:anim calcmode="lin" valueType="num">
+                                      <p:cBhvr additive="base">
+                                        <p:cTn id="60" dur="450" fill="hold"/>
+                                        <p:tgtEl>
+                                          <p:spTgt spid="5"/>
+                                        </p:tgtEl>
+                                        <p:attrNameLst>
+                                          <p:attrName>ppt_y</p:attrName>
+                                        </p:attrNameLst>
+                                      </p:cBhvr>
+                                      <p:tavLst>
+                                        <p:tav tm="0">
+                                          <p:val>
+                                            <p:strVal val="#ppt_y+0.025"/>
+                                          </p:val>
+                                        </p:tav>
+                                        <p:tav tm="100000">
+                                          <p:val>
+                                            <p:strVal val="#ppt_y"/>
+                                          </p:val>
+                                        </p:tav>
+                                      </p:tavLst>
+                                    </p:anim>
+                                  </p:childTnLst>
+                                </p:cTn>
+                              </p:par>
+                              <p:par>
+                                <p:cTn id="61" presetID="10" presetClass="entr" presetSubtype="0" fill="hold" grpId="0" nodeType="withEffect">
+                                  <p:stCondLst>
+                                    <p:cond delay="854"/>
+                                  </p:stCondLst>
+                                  <p:childTnLst>
+                                    <p:set>
+                                      <p:cBhvr>
+                                        <p:cTn id="62" dur="1" fill="hold">
+                                          <p:stCondLst>
+                                            <p:cond delay="0"/>
+                                          </p:stCondLst>
+                                        </p:cTn>
+                                        <p:tgtEl>
+                                          <p:spTgt spid="8"/>
+                                        </p:tgtEl>
+                                        <p:attrNameLst>
+                                          <p:attrName>style.visibility</p:attrName>
+                                        </p:attrNameLst>
+                                      </p:cBhvr>
+                                      <p:to>
+                                        <p:strVal val="visible"/>
+                                      </p:to>
+                                    </p:set>
+                                    <p:animEffect transition="in" filter="fade">
+                                      <p:cBhvr>
+                                        <p:cTn id="63" dur="450"/>
+                                        <p:tgtEl>
+                                          <p:spTgt spid="8"/>
+                                        </p:tgtEl>
+                                      </p:cBhvr>
+                                    </p:animEffect>
+                                    <p:anim calcmode="lin" valueType="num">
+                                      <p:cBhvr additive="base">
+                                        <p:cTn id="64" dur="450" fill="hold"/>
+                                        <p:tgtEl>
+                                          <p:spTgt spid="8"/>
+                                        </p:tgtEl>
+                                        <p:attrNameLst>
+                                          <p:attrName>ppt_y</p:attrName>
+                                        </p:attrNameLst>
+                                      </p:cBhvr>
+                                      <p:tavLst>
+                                        <p:tav tm="0">
+                                          <p:val>
+                                            <p:strVal val="#ppt_y+0.025"/>
+                                          </p:val>
+                                        </p:tav>
+                                        <p:tav tm="100000">
+                                          <p:val>
+                                            <p:strVal val="#ppt_y"/>
+                                          </p:val>
+                                        </p:tav>
+                                      </p:tavLst>
+                                    </p:anim>
+                                  </p:childTnLst>
+                                </p:cTn>
+                              </p:par>
+                              <p:par>
+                                <p:cTn id="65" presetID="10" presetClass="entr" presetSubtype="0" fill="hold" grpId="0" nodeType="withEffect">
+                                  <p:stCondLst>
+                                    <p:cond delay="915"/>
+                                  </p:stCondLst>
+                                  <p:childTnLst>
+                                    <p:set>
+                                      <p:cBhvr>
+                                        <p:cTn id="66" dur="1" fill="hold">
+                                          <p:stCondLst>
+                                            <p:cond delay="0"/>
+                                          </p:stCondLst>
+                                        </p:cTn>
+                                        <p:tgtEl>
+                                          <p:spTgt spid="11"/>
+                                        </p:tgtEl>
+                                        <p:attrNameLst>
+                                          <p:attrName>style.visibility</p:attrName>
+                                        </p:attrNameLst>
+                                      </p:cBhvr>
+                                      <p:to>
+                                        <p:strVal val="visible"/>
+                                      </p:to>
+                                    </p:set>
+                                    <p:animEffect transition="in" filter="fade">
+                                      <p:cBhvr>
+                                        <p:cTn id="67" dur="450"/>
+                                        <p:tgtEl>
+                                          <p:spTgt spid="11"/>
+                                        </p:tgtEl>
+                                      </p:cBhvr>
+                                    </p:animEffect>
+                                    <p:anim calcmode="lin" valueType="num">
+                                      <p:cBhvr additive="base">
+                                        <p:cTn id="68" dur="450" fill="hold"/>
+                                        <p:tgtEl>
+                                          <p:spTgt spid="11"/>
+                                        </p:tgtEl>
+                                        <p:attrNameLst>
+                                          <p:attrName>ppt_y</p:attrName>
+                                        </p:attrNameLst>
+                                      </p:cBhvr>
+                                      <p:tavLst>
+                                        <p:tav tm="0">
+                                          <p:val>
+                                            <p:strVal val="#ppt_y+0.025"/>
+                                          </p:val>
+                                        </p:tav>
+                                        <p:tav tm="100000">
+                                          <p:val>
+                                            <p:strVal val="#ppt_y"/>
+                                          </p:val>
+                                        </p:tav>
+                                      </p:tavLst>
+                                    </p:anim>
+                                  </p:childTnLst>
+                                </p:cTn>
+                              </p:par>
+                              <p:par>
+                                <p:cTn id="69" presetID="10" presetClass="entr" presetSubtype="0" fill="hold" grpId="0" nodeType="withEffect">
+                                  <p:stCondLst>
+                                    <p:cond delay="976"/>
+                                  </p:stCondLst>
+                                  <p:childTnLst>
+                                    <p:set>
+                                      <p:cBhvr>
+                                        <p:cTn id="70" dur="1" fill="hold">
+                                          <p:stCondLst>
+                                            <p:cond delay="0"/>
+                                          </p:stCondLst>
+                                        </p:cTn>
+                                        <p:tgtEl>
+                                          <p:spTgt spid="14"/>
+                                        </p:tgtEl>
+                                        <p:attrNameLst>
+                                          <p:attrName>style.visibility</p:attrName>
+                                        </p:attrNameLst>
+                                      </p:cBhvr>
+                                      <p:to>
+                                        <p:strVal val="visible"/>
+                                      </p:to>
+                                    </p:set>
+                                    <p:animEffect transition="in" filter="fade">
+                                      <p:cBhvr>
+                                        <p:cTn id="71" dur="450"/>
+                                        <p:tgtEl>
+                                          <p:spTgt spid="14"/>
+                                        </p:tgtEl>
+                                      </p:cBhvr>
+                                    </p:animEffect>
+                                    <p:anim calcmode="lin" valueType="num">
+                                      <p:cBhvr additive="base">
+                                        <p:cTn id="72" dur="450" fill="hold"/>
+                                        <p:tgtEl>
+                                          <p:spTgt spid="14"/>
+                                        </p:tgtEl>
+                                        <p:attrNameLst>
+                                          <p:attrName>ppt_y</p:attrName>
+                                        </p:attrNameLst>
+                                      </p:cBhvr>
+                                      <p:tavLst>
+                                        <p:tav tm="0">
+                                          <p:val>
+                                            <p:strVal val="#ppt_y+0.025"/>
+                                          </p:val>
+                                        </p:tav>
+                                        <p:tav tm="100000">
+                                          <p:val>
+                                            <p:strVal val="#ppt_y"/>
+                                          </p:val>
+                                        </p:tav>
+                                      </p:tavLst>
+                                    </p:anim>
+                                  </p:childTnLst>
+                                </p:cTn>
+                              </p:par>
+                              <p:par>
+                                <p:cTn id="73" presetID="10" presetClass="entr" presetSubtype="0" fill="hold" grpId="0" nodeType="withEffect">
+                                  <p:stCondLst>
+                                    <p:cond delay="1037"/>
+                                  </p:stCondLst>
+                                  <p:childTnLst>
+                                    <p:set>
+                                      <p:cBhvr>
+                                        <p:cTn id="74" dur="1" fill="hold">
+                                          <p:stCondLst>
+                                            <p:cond delay="0"/>
+                                          </p:stCondLst>
+                                        </p:cTn>
+                                        <p:tgtEl>
+                                          <p:spTgt spid="17"/>
+                                        </p:tgtEl>
+                                        <p:attrNameLst>
+                                          <p:attrName>style.visibility</p:attrName>
+                                        </p:attrNameLst>
+                                      </p:cBhvr>
+                                      <p:to>
+                                        <p:strVal val="visible"/>
+                                      </p:to>
+                                    </p:set>
+                                    <p:animEffect transition="in" filter="fade">
+                                      <p:cBhvr>
+                                        <p:cTn id="75" dur="450"/>
+                                        <p:tgtEl>
+                                          <p:spTgt spid="17"/>
+                                        </p:tgtEl>
+                                      </p:cBhvr>
+                                    </p:animEffect>
+                                    <p:anim calcmode="lin" valueType="num">
+                                      <p:cBhvr additive="base">
+                                        <p:cTn id="76" dur="450" fill="hold"/>
+                                        <p:tgtEl>
+                                          <p:spTgt spid="17"/>
+                                        </p:tgtEl>
+                                        <p:attrNameLst>
+                                          <p:attrName>ppt_y</p:attrName>
+                                        </p:attrNameLst>
+                                      </p:cBhvr>
+                                      <p:tavLst>
+                                        <p:tav tm="0">
+                                          <p:val>
+                                            <p:strVal val="#ppt_y+0.025"/>
+                                          </p:val>
+                                        </p:tav>
+                                        <p:tav tm="100000">
+                                          <p:val>
+                                            <p:strVal val="#ppt_y"/>
+                                          </p:val>
+                                        </p:tav>
+                                      </p:tavLst>
+                                    </p:anim>
+                                  </p:childTnLst>
+                                </p:cTn>
+                              </p:par>
+                              <p:par>
+                                <p:cTn id="77" presetID="10" presetClass="entr" presetSubtype="0" fill="hold" grpId="0" nodeType="withEffect">
+                                  <p:stCondLst>
+                                    <p:cond delay="1098"/>
+                                  </p:stCondLst>
+                                  <p:childTnLst>
+                                    <p:set>
+                                      <p:cBhvr>
+                                        <p:cTn id="78" dur="1" fill="hold">
+                                          <p:stCondLst>
+                                            <p:cond delay="0"/>
+                                          </p:stCondLst>
+                                        </p:cTn>
+                                        <p:tgtEl>
+                                          <p:spTgt spid="20"/>
+                                        </p:tgtEl>
+                                        <p:attrNameLst>
+                                          <p:attrName>style.visibility</p:attrName>
+                                        </p:attrNameLst>
+                                      </p:cBhvr>
+                                      <p:to>
+                                        <p:strVal val="visible"/>
+                                      </p:to>
+                                    </p:set>
+                                    <p:animEffect transition="in" filter="fade">
+                                      <p:cBhvr>
+                                        <p:cTn id="79" dur="450"/>
+                                        <p:tgtEl>
+                                          <p:spTgt spid="20"/>
+                                        </p:tgtEl>
+                                      </p:cBhvr>
+                                    </p:animEffect>
+                                    <p:anim calcmode="lin" valueType="num">
+                                      <p:cBhvr additive="base">
+                                        <p:cTn id="80" dur="450" fill="hold"/>
+                                        <p:tgtEl>
+                                          <p:spTgt spid="20"/>
+                                        </p:tgtEl>
+                                        <p:attrNameLst>
+                                          <p:attrName>ppt_y</p:attrName>
+                                        </p:attrNameLst>
+                                      </p:cBhvr>
+                                      <p:tavLst>
+                                        <p:tav tm="0">
+                                          <p:val>
+                                            <p:strVal val="#ppt_y+0.025"/>
+                                          </p:val>
+                                        </p:tav>
+                                        <p:tav tm="100000">
+                                          <p:val>
+                                            <p:strVal val="#ppt_y"/>
+                                          </p:val>
+                                        </p:tav>
+                                      </p:tavLst>
+                                    </p:anim>
+                                  </p:childTnLst>
+                                </p:cTn>
+                              </p:par>
+                            </p:childTnLst>
+                          </p:cTn>
+                        </p:par>
+                      </p:childTnLst>
+                    </p:cTn>
+                  </p:par>
+                </p:childTnLst>
+              </p:cTn>
+              <p:prevCondLst>
+                <p:cond evt="onPrev" delay="0">
+                  <p:tgtEl>
+                    <p:sldTgt/>
+                  </p:tgtEl>
+                </p:cond>
+              </p:prevCondLst>
+              <p:nextCondLst>
+                <p:cond evt="onNext" delay="0">
+                  <p:tgtEl>
+                    <p:sldTgt/>
+                  </p:tgtEl>
+                </p:cond>
+              </p:nextCondLst>
+            </p:seq>
+          </p:childTnLst>
+        </p:cTn>
+      </p:par>
+    </p:tnLst>
+    <p:bldLst>
+      <p:bldP spid="2" grpId="0"/>
+      <p:bldP spid="4" grpId="0"/>
+      <p:bldP spid="7" grpId="0"/>
+      <p:bldP spid="10" grpId="0"/>
+      <p:bldP spid="13" grpId="0"/>
+      <p:bldP spid="16" grpId="0"/>
+      <p:bldP spid="19" grpId="0"/>
+      <p:bldP spid="5" grpId="0"/>
+      <p:bldP spid="8" grpId="0"/>
+      <p:bldP spid="11" grpId="0"/>
+      <p:bldP spid="14" grpId="0"/>
+      <p:bldP spid="17" grpId="0"/>
+      <p:bldP spid="20" grpId="0"/>
+    </p:bldLst>
+  </p:timing>
 </p:sld>
 </file>
 
@@ -4487,6 +8341,180 @@
   <p:clrMapOvr>
     <a:masterClrMapping/>
   </p:clrMapOvr>
+  <p:transition xmlns:p14="http://schemas.microsoft.com/office/powerpoint/2010/main" spd="slow" p14:dur="700">
+    <p:fade/>
+  </p:transition>
+  <p:timing xmlns:p="http://schemas.openxmlformats.org/presentationml/2006/main">
+    <p:tnLst>
+      <p:par>
+        <p:cTn id="1" dur="indefinite" restart="never" nodeType="tmRoot">
+          <p:childTnLst>
+            <p:seq concurrent="1" nextAc="seek">
+              <p:cTn id="2" dur="indefinite" nodeType="mainSeq">
+                <p:childTnLst>
+                  <p:par>
+                    <p:cTn id="3" fill="hold">
+                      <p:stCondLst>
+                        <p:cond delay="indefinite"/>
+                        <p:cond evt="onBegin" delay="0">
+                          <p:tn val="2"/>
+                        </p:cond>
+                      </p:stCondLst>
+                      <p:childTnLst>
+                        <p:par>
+                          <p:cTn id="4" fill="hold">
+                            <p:stCondLst>
+                              <p:cond delay="0"/>
+                            </p:stCondLst>
+                            <p:childTnLst>
+                              <p:par>
+                                <p:cTn id="5" presetID="10" presetClass="entr" presetSubtype="0" fill="hold" grpId="0" nodeType="withEffect">
+                                  <p:stCondLst>
+                                    <p:cond delay="0"/>
+                                  </p:stCondLst>
+                                  <p:childTnLst>
+                                    <p:set>
+                                      <p:cBhvr>
+                                        <p:cTn id="6" dur="1" fill="hold">
+                                          <p:stCondLst>
+                                            <p:cond delay="0"/>
+                                          </p:stCondLst>
+                                        </p:cTn>
+                                        <p:tgtEl>
+                                          <p:spTgt spid="2"/>
+                                        </p:tgtEl>
+                                        <p:attrNameLst>
+                                          <p:attrName>style.visibility</p:attrName>
+                                        </p:attrNameLst>
+                                      </p:cBhvr>
+                                      <p:to>
+                                        <p:strVal val="visible"/>
+                                      </p:to>
+                                    </p:set>
+                                    <p:animEffect transition="in" filter="fade">
+                                      <p:cBhvr>
+                                        <p:cTn id="7" dur="450"/>
+                                        <p:tgtEl>
+                                          <p:spTgt spid="2"/>
+                                        </p:tgtEl>
+                                      </p:cBhvr>
+                                    </p:animEffect>
+                                    <p:anim calcmode="lin" valueType="num">
+                                      <p:cBhvr additive="base">
+                                        <p:cTn id="8" dur="450" fill="hold"/>
+                                        <p:tgtEl>
+                                          <p:spTgt spid="2"/>
+                                        </p:tgtEl>
+                                        <p:attrNameLst>
+                                          <p:attrName>ppt_y</p:attrName>
+                                        </p:attrNameLst>
+                                      </p:cBhvr>
+                                      <p:tavLst>
+                                        <p:tav tm="0">
+                                          <p:val>
+                                            <p:strVal val="#ppt_y+0.025"/>
+                                          </p:val>
+                                        </p:tav>
+                                        <p:tav tm="100000">
+                                          <p:val>
+                                            <p:strVal val="#ppt_y"/>
+                                          </p:val>
+                                        </p:tav>
+                                      </p:tavLst>
+                                    </p:anim>
+                                  </p:childTnLst>
+                                </p:cTn>
+                              </p:par>
+                              <p:par>
+                                <p:cTn id="9" presetID="10" presetClass="entr" presetSubtype="0" fill="hold" grpId="0" nodeType="withEffect">
+                                  <p:stCondLst>
+                                    <p:cond delay="160"/>
+                                  </p:stCondLst>
+                                  <p:childTnLst>
+                                    <p:set>
+                                      <p:cBhvr>
+                                        <p:cTn id="10" dur="1" fill="hold">
+                                          <p:stCondLst>
+                                            <p:cond delay="0"/>
+                                          </p:stCondLst>
+                                        </p:cTn>
+                                        <p:tgtEl>
+                                          <p:spTgt spid="3"/>
+                                        </p:tgtEl>
+                                        <p:attrNameLst>
+                                          <p:attrName>style.visibility</p:attrName>
+                                        </p:attrNameLst>
+                                      </p:cBhvr>
+                                      <p:to>
+                                        <p:strVal val="visible"/>
+                                      </p:to>
+                                    </p:set>
+                                    <p:animEffect transition="in" filter="fade">
+                                      <p:cBhvr>
+                                        <p:cTn id="11" dur="450"/>
+                                        <p:tgtEl>
+                                          <p:spTgt spid="3"/>
+                                        </p:tgtEl>
+                                      </p:cBhvr>
+                                    </p:animEffect>
+                                    <p:anim calcmode="lin" valueType="num">
+                                      <p:cBhvr additive="base">
+                                        <p:cTn id="12" dur="450" fill="hold"/>
+                                        <p:tgtEl>
+                                          <p:spTgt spid="3"/>
+                                        </p:tgtEl>
+                                        <p:attrNameLst>
+                                          <p:attrName>ppt_y</p:attrName>
+                                        </p:attrNameLst>
+                                      </p:cBhvr>
+                                      <p:tavLst>
+                                        <p:tav tm="0">
+                                          <p:val>
+                                            <p:strVal val="#ppt_y+0.025"/>
+                                          </p:val>
+                                        </p:tav>
+                                        <p:tav tm="100000">
+                                          <p:val>
+                                            <p:strVal val="#ppt_y"/>
+                                          </p:val>
+                                        </p:tav>
+                                      </p:tavLst>
+                                    </p:anim>
+                                  </p:childTnLst>
+                                </p:cTn>
+                              </p:par>
+                            </p:childTnLst>
+                          </p:cTn>
+                        </p:par>
+                      </p:childTnLst>
+                    </p:cTn>
+                  </p:par>
+                </p:childTnLst>
+              </p:cTn>
+              <p:prevCondLst>
+                <p:cond evt="onPrev" delay="0">
+                  <p:tgtEl>
+                    <p:sldTgt/>
+                  </p:tgtEl>
+                </p:cond>
+              </p:prevCondLst>
+              <p:nextCondLst>
+                <p:cond evt="onNext" delay="0">
+                  <p:tgtEl>
+                    <p:sldTgt/>
+                  </p:tgtEl>
+                </p:cond>
+              </p:nextCondLst>
+            </p:seq>
+          </p:childTnLst>
+        </p:cTn>
+      </p:par>
+    </p:tnLst>
+    <p:bldLst>
+      <p:bldP spid="2" grpId="0"/>
+      <p:bldP spid="3" grpId="0"/>
+    </p:bldLst>
+  </p:timing>
 </p:sld>
 </file>
 

</xml_diff>

<commit_message>
feat: choreography-based varied animations (5 designer programs)
Replace fixed fade+rise with a designer-choreography system:
- 5 programs: cinematic / crisp / editorial / bold / tvos - each defines
  transition (fade/fade-thru-black + duration), per-role element effects
  (hero scale-grow, body fade+rise, shapes fade+scale, annotated wipe),
  cascade order (top-down / center-out) and rhythm
- selection: outline 'choreography' explicit, else title-hash auto pick
  with per-deek duration jitter - every deck animates differently
- role inference: text >=55pt treated as hero (scale entrance)
- objectName anim:wipe hints on bars/timeline-axis/compare-divider for
  grow-from-left reveals
- showcase decks pinned: milk-tea cinematic, inkpod tvos, business crisp,
  aurora bold (verified distinct: 0.62/0.72/0.42/0.82s, thruBlk on bold)
- fix: p14:dur now on p:transition (was misplaced on p:fade)
- docs intentionally not updated per maintainer request
</commit_message>
<xml_diff>
--- a/assets/example_deck.pptx
+++ b/assets/example_deck.pptx
@@ -2029,7 +2029,7 @@
   <p:clrMapOvr>
     <a:masterClrMapping/>
   </p:clrMapOvr>
-  <p:transition xmlns:p14="http://schemas.microsoft.com/office/powerpoint/2010/main" spd="slow" p14:dur="700">
+  <p:transition xmlns:p14="http://schemas.microsoft.com/office/powerpoint/2010/main" spd="slow" p14:dur="620">
     <p:fade/>
   </p:transition>
   <p:timing xmlns:p="http://schemas.openxmlformats.org/presentationml/2006/main">
@@ -2145,29 +2145,16 @@
                                         </p:tgtEl>
                                       </p:cBhvr>
                                     </p:animEffect>
-                                    <p:anim calcmode="lin" valueType="num">
-                                      <p:cBhvr additive="base">
+                                    <p:animScale>
+                                      <p:cBhvr>
                                         <p:cTn id="12" dur="450" fill="hold"/>
                                         <p:tgtEl>
                                           <p:spTgt spid="3"/>
                                         </p:tgtEl>
-                                        <p:attrNameLst>
-                                          <p:attrName>ppt_y</p:attrName>
-                                        </p:attrNameLst>
-                                      </p:cBhvr>
-                                      <p:tavLst>
-                                        <p:tav tm="0">
-                                          <p:val>
-                                            <p:strVal val="#ppt_y+0.025"/>
-                                          </p:val>
-                                        </p:tav>
-                                        <p:tav tm="100000">
-                                          <p:val>
-                                            <p:strVal val="#ppt_y"/>
-                                          </p:val>
-                                        </p:tav>
-                                      </p:tavLst>
-                                    </p:anim>
+                                      </p:cBhvr>
+                                      <p:from x="96000" y="96000"/>
+                                      <p:to x="100000" y="100000"/>
+                                    </p:animScale>
                                   </p:childTnLst>
                                 </p:cTn>
                               </p:par>
@@ -2409,7 +2396,7 @@
   <p:clrMapOvr>
     <a:masterClrMapping/>
   </p:clrMapOvr>
-  <p:transition xmlns:p14="http://schemas.microsoft.com/office/powerpoint/2010/main" spd="slow" p14:dur="700">
+  <p:transition xmlns:p14="http://schemas.microsoft.com/office/powerpoint/2010/main" spd="slow" p14:dur="620">
     <p:fade/>
   </p:transition>
   <p:timing xmlns:p="http://schemas.openxmlformats.org/presentationml/2006/main">
@@ -2726,7 +2713,7 @@
   <p:clrMapOvr>
     <a:masterClrMapping/>
   </p:clrMapOvr>
-  <p:transition xmlns:p14="http://schemas.microsoft.com/office/powerpoint/2010/main" spd="slow" p14:dur="700">
+  <p:transition xmlns:p14="http://schemas.microsoft.com/office/powerpoint/2010/main" spd="slow" p14:dur="620">
     <p:fade/>
   </p:transition>
   <p:timing xmlns:p="http://schemas.openxmlformats.org/presentationml/2006/main">
@@ -2784,29 +2771,16 @@
                                         </p:tgtEl>
                                       </p:cBhvr>
                                     </p:animEffect>
-                                    <p:anim calcmode="lin" valueType="num">
-                                      <p:cBhvr additive="base">
+                                    <p:animScale>
+                                      <p:cBhvr>
                                         <p:cTn id="8" dur="450" fill="hold"/>
                                         <p:tgtEl>
                                           <p:spTgt spid="2"/>
                                         </p:tgtEl>
-                                        <p:attrNameLst>
-                                          <p:attrName>ppt_y</p:attrName>
-                                        </p:attrNameLst>
-                                      </p:cBhvr>
-                                      <p:tavLst>
-                                        <p:tav tm="0">
-                                          <p:val>
-                                            <p:strVal val="#ppt_y+0.025"/>
-                                          </p:val>
-                                        </p:tav>
-                                        <p:tav tm="100000">
-                                          <p:val>
-                                            <p:strVal val="#ppt_y"/>
-                                          </p:val>
-                                        </p:tav>
-                                      </p:tavLst>
-                                    </p:anim>
+                                      </p:cBhvr>
+                                      <p:from x="96000" y="96000"/>
+                                      <p:to x="100000" y="100000"/>
+                                    </p:animScale>
                                   </p:childTnLst>
                                 </p:cTn>
                               </p:par>
@@ -3181,7 +3155,7 @@
   <p:clrMapOvr>
     <a:masterClrMapping/>
   </p:clrMapOvr>
-  <p:transition xmlns:p14="http://schemas.microsoft.com/office/powerpoint/2010/main" spd="slow" p14:dur="700">
+  <p:transition xmlns:p14="http://schemas.microsoft.com/office/powerpoint/2010/main" spd="slow" p14:dur="620">
     <p:fade/>
   </p:transition>
   <p:timing xmlns:p="http://schemas.openxmlformats.org/presentationml/2006/main">
@@ -3488,7 +3462,7 @@
   <p:clrMapOvr>
     <a:masterClrMapping/>
   </p:clrMapOvr>
-  <p:transition xmlns:p14="http://schemas.microsoft.com/office/powerpoint/2010/main" spd="slow" p14:dur="700">
+  <p:transition xmlns:p14="http://schemas.microsoft.com/office/powerpoint/2010/main" spd="slow" p14:dur="620">
     <p:fade/>
   </p:transition>
   <p:timing xmlns:p="http://schemas.openxmlformats.org/presentationml/2006/main">
@@ -3752,7 +3726,7 @@
   <p:clrMapOvr>
     <a:masterClrMapping/>
   </p:clrMapOvr>
-  <p:transition xmlns:p14="http://schemas.microsoft.com/office/powerpoint/2010/main" spd="slow" p14:dur="700">
+  <p:transition xmlns:p14="http://schemas.microsoft.com/office/powerpoint/2010/main" spd="slow" p14:dur="620">
     <p:fade/>
   </p:transition>
   <p:timing xmlns:p="http://schemas.openxmlformats.org/presentationml/2006/main">
@@ -3810,29 +3784,16 @@
                                         </p:tgtEl>
                                       </p:cBhvr>
                                     </p:animEffect>
-                                    <p:anim calcmode="lin" valueType="num">
-                                      <p:cBhvr additive="base">
+                                    <p:animScale>
+                                      <p:cBhvr>
                                         <p:cTn id="8" dur="450" fill="hold"/>
                                         <p:tgtEl>
                                           <p:spTgt spid="2"/>
                                         </p:tgtEl>
-                                        <p:attrNameLst>
-                                          <p:attrName>ppt_y</p:attrName>
-                                        </p:attrNameLst>
-                                      </p:cBhvr>
-                                      <p:tavLst>
-                                        <p:tav tm="0">
-                                          <p:val>
-                                            <p:strVal val="#ppt_y+0.025"/>
-                                          </p:val>
-                                        </p:tav>
-                                        <p:tav tm="100000">
-                                          <p:val>
-                                            <p:strVal val="#ppt_y"/>
-                                          </p:val>
-                                        </p:tav>
-                                      </p:tavLst>
-                                    </p:anim>
+                                      </p:cBhvr>
+                                      <p:from x="96000" y="96000"/>
+                                      <p:to x="100000" y="100000"/>
+                                    </p:animScale>
                                   </p:childTnLst>
                                 </p:cTn>
                               </p:par>
@@ -4095,7 +4056,7 @@
   <p:clrMapOvr>
     <a:masterClrMapping/>
   </p:clrMapOvr>
-  <p:transition xmlns:p14="http://schemas.microsoft.com/office/powerpoint/2010/main" spd="slow" p14:dur="700">
+  <p:transition xmlns:p14="http://schemas.microsoft.com/office/powerpoint/2010/main" spd="slow" p14:dur="620">
     <p:fade/>
   </p:transition>
   <p:timing xmlns:p="http://schemas.openxmlformats.org/presentationml/2006/main">
@@ -4471,7 +4432,7 @@
   <p:clrMapOvr>
     <a:masterClrMapping/>
   </p:clrMapOvr>
-  <p:transition xmlns:p14="http://schemas.microsoft.com/office/powerpoint/2010/main" spd="slow" p14:dur="700">
+  <p:transition xmlns:p14="http://schemas.microsoft.com/office/powerpoint/2010/main" spd="slow" p14:dur="620">
     <p:fade/>
   </p:transition>
   <p:timing xmlns:p="http://schemas.openxmlformats.org/presentationml/2006/main">
@@ -4587,29 +4548,16 @@
                                         </p:tgtEl>
                                       </p:cBhvr>
                                     </p:animEffect>
-                                    <p:anim calcmode="lin" valueType="num">
-                                      <p:cBhvr additive="base">
+                                    <p:animScale>
+                                      <p:cBhvr>
                                         <p:cTn id="12" dur="450" fill="hold"/>
                                         <p:tgtEl>
                                           <p:spTgt spid="3"/>
                                         </p:tgtEl>
-                                        <p:attrNameLst>
-                                          <p:attrName>ppt_y</p:attrName>
-                                        </p:attrNameLst>
-                                      </p:cBhvr>
-                                      <p:tavLst>
-                                        <p:tav tm="0">
-                                          <p:val>
-                                            <p:strVal val="#ppt_y+0.025"/>
-                                          </p:val>
-                                        </p:tav>
-                                        <p:tav tm="100000">
-                                          <p:val>
-                                            <p:strVal val="#ppt_y"/>
-                                          </p:val>
-                                        </p:tav>
-                                      </p:tavLst>
-                                    </p:anim>
+                                      </p:cBhvr>
+                                      <p:from x="96000" y="96000"/>
+                                      <p:to x="100000" y="100000"/>
+                                    </p:animScale>
                                   </p:childTnLst>
                                 </p:cTn>
                               </p:par>
@@ -5077,7 +5025,7 @@
   <p:clrMapOvr>
     <a:masterClrMapping/>
   </p:clrMapOvr>
-  <p:transition xmlns:p14="http://schemas.microsoft.com/office/powerpoint/2010/main" spd="slow" p14:dur="700">
+  <p:transition xmlns:p14="http://schemas.microsoft.com/office/powerpoint/2010/main" spd="slow" p14:dur="620">
     <p:fade/>
   </p:transition>
   <p:timing xmlns:p="http://schemas.openxmlformats.org/presentationml/2006/main">
@@ -5895,7 +5843,7 @@
       </p:sp>
       <p:sp>
         <p:nvSpPr>
-          <p:cNvPr id="8" name="Shape 6"/>
+          <p:cNvPr id="8" name="anim:wipe"/>
           <p:cNvSpPr/>
           <p:nvPr/>
         </p:nvSpPr>
@@ -5918,7 +5866,7 @@
   <p:clrMapOvr>
     <a:masterClrMapping/>
   </p:clrMapOvr>
-  <p:transition xmlns:p14="http://schemas.microsoft.com/office/powerpoint/2010/main" spd="slow" p14:dur="700">
+  <p:transition xmlns:p14="http://schemas.microsoft.com/office/powerpoint/2010/main" spd="slow" p14:dur="620">
     <p:fade/>
   </p:transition>
   <p:timing xmlns:p="http://schemas.openxmlformats.org/presentationml/2006/main">
@@ -6084,19 +6032,54 @@
                                         <p:strVal val="visible"/>
                                       </p:to>
                                     </p:set>
+                                    <p:animEffect transition="in" filter="wipe(left)">
+                                      <p:cBhvr>
+                                        <p:cTn id="15" dur="450"/>
+                                        <p:tgtEl>
+                                          <p:spTgt spid="8"/>
+                                        </p:tgtEl>
+                                      </p:cBhvr>
+                                    </p:animEffect>
+                                  </p:childTnLst>
+                                </p:cTn>
+                              </p:par>
+                              <p:par>
+                                <p:cTn id="16" presetID="10" presetClass="entr" presetSubtype="0" fill="hold" grpId="0" nodeType="withEffect">
+                                  <p:stCondLst>
+                                    <p:cond delay="480"/>
+                                  </p:stCondLst>
+                                  <p:childTnLst>
+                                    <p:set>
+                                      <p:cBhvr>
+                                        <p:cTn id="17" dur="1" fill="hold">
+                                          <p:stCondLst>
+                                            <p:cond delay="0"/>
+                                          </p:stCondLst>
+                                        </p:cTn>
+                                        <p:tgtEl>
+                                          <p:spTgt spid="4"/>
+                                        </p:tgtEl>
+                                        <p:attrNameLst>
+                                          <p:attrName>style.visibility</p:attrName>
+                                        </p:attrNameLst>
+                                      </p:cBhvr>
+                                      <p:to>
+                                        <p:strVal val="visible"/>
+                                      </p:to>
+                                    </p:set>
                                     <p:animEffect transition="in" filter="fade">
                                       <p:cBhvr>
-                                        <p:cTn id="15" dur="450"/>
-                                        <p:tgtEl>
-                                          <p:spTgt spid="8"/>
+                                        <p:cTn id="18" dur="450"/>
+                                        <p:tgtEl>
+                                          <p:spTgt spid="4"/>
                                         </p:tgtEl>
                                       </p:cBhvr>
                                     </p:animEffect>
                                     <p:anim calcmode="lin" valueType="num">
                                       <p:cBhvr additive="base">
-                                        <p:cTn id="16" dur="450" fill="hold"/>
-                                        <p:tgtEl>
-                                          <p:spTgt spid="8"/>
+                                        <p:cTn id="19" dur="450" fill="hold"/>
+                                        <p:tgtEl>
+                                          <p:spTgt spid="4"/>
                                         </p:tgtEl>
                                         <p:attrNameLst>
                                           <p:attrName>ppt_y</p:attrName>
@@ -6119,20 +6102,20 @@
                                 </p:cTn>
                               </p:par>
                               <p:par>
-                                <p:cTn id="17" presetID="10" presetClass="entr" presetSubtype="0" fill="hold" grpId="0" nodeType="withEffect">
+                                <p:cTn id="20" presetID="10" presetClass="entr" presetSubtype="0" fill="hold" grpId="0" nodeType="withEffect">
                                   <p:stCondLst>
-                                    <p:cond delay="480"/>
+                                    <p:cond delay="640"/>
                                   </p:stCondLst>
                                   <p:childTnLst>
                                     <p:set>
                                       <p:cBhvr>
-                                        <p:cTn id="18" dur="1" fill="hold">
+                                        <p:cTn id="21" dur="1" fill="hold">
                                           <p:stCondLst>
                                             <p:cond delay="0"/>
                                           </p:stCondLst>
                                         </p:cTn>
                                         <p:tgtEl>
-                                          <p:spTgt spid="4"/>
+                                          <p:spTgt spid="5"/>
                                         </p:tgtEl>
                                         <p:attrNameLst>
                                           <p:attrName>style.visibility</p:attrName>
@@ -6144,17 +6127,17 @@
                                     </p:set>
                                     <p:animEffect transition="in" filter="fade">
                                       <p:cBhvr>
-                                        <p:cTn id="19" dur="450"/>
-                                        <p:tgtEl>
-                                          <p:spTgt spid="4"/>
+                                        <p:cTn id="22" dur="450"/>
+                                        <p:tgtEl>
+                                          <p:spTgt spid="5"/>
                                         </p:tgtEl>
                                       </p:cBhvr>
                                     </p:animEffect>
                                     <p:anim calcmode="lin" valueType="num">
                                       <p:cBhvr additive="base">
-                                        <p:cTn id="20" dur="450" fill="hold"/>
-                                        <p:tgtEl>
-                                          <p:spTgt spid="4"/>
+                                        <p:cTn id="23" dur="450" fill="hold"/>
+                                        <p:tgtEl>
+                                          <p:spTgt spid="5"/>
                                         </p:tgtEl>
                                         <p:attrNameLst>
                                           <p:attrName>ppt_y</p:attrName>
@@ -6177,20 +6160,20 @@
                                 </p:cTn>
                               </p:par>
                               <p:par>
-                                <p:cTn id="21" presetID="10" presetClass="entr" presetSubtype="0" fill="hold" grpId="0" nodeType="withEffect">
+                                <p:cTn id="24" presetID="10" presetClass="entr" presetSubtype="0" fill="hold" grpId="0" nodeType="withEffect">
                                   <p:stCondLst>
-                                    <p:cond delay="640"/>
+                                    <p:cond delay="800"/>
                                   </p:stCondLst>
                                   <p:childTnLst>
                                     <p:set>
                                       <p:cBhvr>
-                                        <p:cTn id="22" dur="1" fill="hold">
+                                        <p:cTn id="25" dur="1" fill="hold">
                                           <p:stCondLst>
                                             <p:cond delay="0"/>
                                           </p:stCondLst>
                                         </p:cTn>
                                         <p:tgtEl>
-                                          <p:spTgt spid="5"/>
+                                          <p:spTgt spid="6"/>
                                         </p:tgtEl>
                                         <p:attrNameLst>
                                           <p:attrName>style.visibility</p:attrName>
@@ -6202,17 +6185,17 @@
                                     </p:set>
                                     <p:animEffect transition="in" filter="fade">
                                       <p:cBhvr>
-                                        <p:cTn id="23" dur="450"/>
-                                        <p:tgtEl>
-                                          <p:spTgt spid="5"/>
+                                        <p:cTn id="26" dur="450"/>
+                                        <p:tgtEl>
+                                          <p:spTgt spid="6"/>
                                         </p:tgtEl>
                                       </p:cBhvr>
                                     </p:animEffect>
                                     <p:anim calcmode="lin" valueType="num">
                                       <p:cBhvr additive="base">
-                                        <p:cTn id="24" dur="450" fill="hold"/>
-                                        <p:tgtEl>
-                                          <p:spTgt spid="5"/>
+                                        <p:cTn id="27" dur="450" fill="hold"/>
+                                        <p:tgtEl>
+                                          <p:spTgt spid="6"/>
                                         </p:tgtEl>
                                         <p:attrNameLst>
                                           <p:attrName>ppt_y</p:attrName>
@@ -6235,20 +6218,20 @@
                                 </p:cTn>
                               </p:par>
                               <p:par>
-                                <p:cTn id="25" presetID="10" presetClass="entr" presetSubtype="0" fill="hold" grpId="0" nodeType="withEffect">
+                                <p:cTn id="28" presetID="10" presetClass="entr" presetSubtype="0" fill="hold" grpId="0" nodeType="withEffect">
                                   <p:stCondLst>
-                                    <p:cond delay="800"/>
+                                    <p:cond delay="960"/>
                                   </p:stCondLst>
                                   <p:childTnLst>
                                     <p:set>
                                       <p:cBhvr>
-                                        <p:cTn id="26" dur="1" fill="hold">
+                                        <p:cTn id="29" dur="1" fill="hold">
                                           <p:stCondLst>
                                             <p:cond delay="0"/>
                                           </p:stCondLst>
                                         </p:cTn>
                                         <p:tgtEl>
-                                          <p:spTgt spid="6"/>
+                                          <p:spTgt spid="7"/>
                                         </p:tgtEl>
                                         <p:attrNameLst>
                                           <p:attrName>style.visibility</p:attrName>
@@ -6260,73 +6243,15 @@
                                     </p:set>
                                     <p:animEffect transition="in" filter="fade">
                                       <p:cBhvr>
-                                        <p:cTn id="27" dur="450"/>
-                                        <p:tgtEl>
-                                          <p:spTgt spid="6"/>
+                                        <p:cTn id="30" dur="450"/>
+                                        <p:tgtEl>
+                                          <p:spTgt spid="7"/>
                                         </p:tgtEl>
                                       </p:cBhvr>
                                     </p:animEffect>
                                     <p:anim calcmode="lin" valueType="num">
                                       <p:cBhvr additive="base">
-                                        <p:cTn id="28" dur="450" fill="hold"/>
-                                        <p:tgtEl>
-                                          <p:spTgt spid="6"/>
-                                        </p:tgtEl>
-                                        <p:attrNameLst>
-                                          <p:attrName>ppt_y</p:attrName>
-                                        </p:attrNameLst>
-                                      </p:cBhvr>
-                                      <p:tavLst>
-                                        <p:tav tm="0">
-                                          <p:val>
-                                            <p:strVal val="#ppt_y+0.025"/>
-                                          </p:val>
-                                        </p:tav>
-                                        <p:tav tm="100000">
-                                          <p:val>
-                                            <p:strVal val="#ppt_y"/>
-                                          </p:val>
-                                        </p:tav>
-                                      </p:tavLst>
-                                    </p:anim>
-                                  </p:childTnLst>
-                                </p:cTn>
-                              </p:par>
-                              <p:par>
-                                <p:cTn id="29" presetID="10" presetClass="entr" presetSubtype="0" fill="hold" grpId="0" nodeType="withEffect">
-                                  <p:stCondLst>
-                                    <p:cond delay="960"/>
-                                  </p:stCondLst>
-                                  <p:childTnLst>
-                                    <p:set>
-                                      <p:cBhvr>
-                                        <p:cTn id="30" dur="1" fill="hold">
-                                          <p:stCondLst>
-                                            <p:cond delay="0"/>
-                                          </p:stCondLst>
-                                        </p:cTn>
-                                        <p:tgtEl>
-                                          <p:spTgt spid="7"/>
-                                        </p:tgtEl>
-                                        <p:attrNameLst>
-                                          <p:attrName>style.visibility</p:attrName>
-                                        </p:attrNameLst>
-                                      </p:cBhvr>
-                                      <p:to>
-                                        <p:strVal val="visible"/>
-                                      </p:to>
-                                    </p:set>
-                                    <p:animEffect transition="in" filter="fade">
-                                      <p:cBhvr>
-                                        <p:cTn id="31" dur="450"/>
-                                        <p:tgtEl>
-                                          <p:spTgt spid="7"/>
-                                        </p:tgtEl>
-                                      </p:cBhvr>
-                                    </p:animEffect>
-                                    <p:anim calcmode="lin" valueType="num">
-                                      <p:cBhvr additive="base">
-                                        <p:cTn id="32" dur="450" fill="hold"/>
+                                        <p:cTn id="31" dur="450" fill="hold"/>
                                         <p:tgtEl>
                                           <p:spTgt spid="7"/>
                                         </p:tgtEl>
@@ -7057,7 +6982,7 @@
   <p:clrMapOvr>
     <a:masterClrMapping/>
   </p:clrMapOvr>
-  <p:transition xmlns:p14="http://schemas.microsoft.com/office/powerpoint/2010/main" spd="slow" p14:dur="700">
+  <p:transition xmlns:p14="http://schemas.microsoft.com/office/powerpoint/2010/main" spd="slow" p14:dur="620">
     <p:fade/>
   </p:transition>
   <p:timing xmlns:p="http://schemas.openxmlformats.org/presentationml/2006/main">
@@ -7144,7 +7069,7 @@
                               <p:par>
                                 <p:cTn id="9" presetID="10" presetClass="entr" presetSubtype="0" fill="hold" grpId="0" nodeType="withEffect">
                                   <p:stCondLst>
-                                    <p:cond delay="61"/>
+                                    <p:cond delay="66"/>
                                   </p:stCondLst>
                                   <p:childTnLst>
                                     <p:set>
@@ -7173,36 +7098,23 @@
                                         </p:tgtEl>
                                       </p:cBhvr>
                                     </p:animEffect>
-                                    <p:anim calcmode="lin" valueType="num">
-                                      <p:cBhvr additive="base">
+                                    <p:animScale>
+                                      <p:cBhvr>
                                         <p:cTn id="12" dur="450" fill="hold"/>
                                         <p:tgtEl>
                                           <p:spTgt spid="3"/>
                                         </p:tgtEl>
-                                        <p:attrNameLst>
-                                          <p:attrName>ppt_y</p:attrName>
-                                        </p:attrNameLst>
-                                      </p:cBhvr>
-                                      <p:tavLst>
-                                        <p:tav tm="0">
-                                          <p:val>
-                                            <p:strVal val="#ppt_y+0.025"/>
-                                          </p:val>
-                                        </p:tav>
-                                        <p:tav tm="100000">
-                                          <p:val>
-                                            <p:strVal val="#ppt_y"/>
-                                          </p:val>
-                                        </p:tav>
-                                      </p:tavLst>
-                                    </p:anim>
+                                      </p:cBhvr>
+                                      <p:from x="94000" y="94000"/>
+                                      <p:to x="100000" y="100000"/>
+                                    </p:animScale>
                                   </p:childTnLst>
                                 </p:cTn>
                               </p:par>
                               <p:par>
                                 <p:cTn id="13" presetID="10" presetClass="entr" presetSubtype="0" fill="hold" grpId="0" nodeType="withEffect">
                                   <p:stCondLst>
-                                    <p:cond delay="122"/>
+                                    <p:cond delay="132"/>
                                   </p:stCondLst>
                                   <p:childTnLst>
                                     <p:set>
@@ -7231,36 +7143,23 @@
                                         </p:tgtEl>
                                       </p:cBhvr>
                                     </p:animEffect>
-                                    <p:anim calcmode="lin" valueType="num">
-                                      <p:cBhvr additive="base">
+                                    <p:animScale>
+                                      <p:cBhvr>
                                         <p:cTn id="16" dur="450" fill="hold"/>
                                         <p:tgtEl>
                                           <p:spTgt spid="6"/>
                                         </p:tgtEl>
-                                        <p:attrNameLst>
-                                          <p:attrName>ppt_y</p:attrName>
-                                        </p:attrNameLst>
-                                      </p:cBhvr>
-                                      <p:tavLst>
-                                        <p:tav tm="0">
-                                          <p:val>
-                                            <p:strVal val="#ppt_y+0.025"/>
-                                          </p:val>
-                                        </p:tav>
-                                        <p:tav tm="100000">
-                                          <p:val>
-                                            <p:strVal val="#ppt_y"/>
-                                          </p:val>
-                                        </p:tav>
-                                      </p:tavLst>
-                                    </p:anim>
+                                      </p:cBhvr>
+                                      <p:from x="94000" y="94000"/>
+                                      <p:to x="100000" y="100000"/>
+                                    </p:animScale>
                                   </p:childTnLst>
                                 </p:cTn>
                               </p:par>
                               <p:par>
                                 <p:cTn id="17" presetID="10" presetClass="entr" presetSubtype="0" fill="hold" grpId="0" nodeType="withEffect">
                                   <p:stCondLst>
-                                    <p:cond delay="183"/>
+                                    <p:cond delay="198"/>
                                   </p:stCondLst>
                                   <p:childTnLst>
                                     <p:set>
@@ -7289,36 +7188,23 @@
                                         </p:tgtEl>
                                       </p:cBhvr>
                                     </p:animEffect>
-                                    <p:anim calcmode="lin" valueType="num">
-                                      <p:cBhvr additive="base">
+                                    <p:animScale>
+                                      <p:cBhvr>
                                         <p:cTn id="20" dur="450" fill="hold"/>
                                         <p:tgtEl>
                                           <p:spTgt spid="9"/>
                                         </p:tgtEl>
-                                        <p:attrNameLst>
-                                          <p:attrName>ppt_y</p:attrName>
-                                        </p:attrNameLst>
-                                      </p:cBhvr>
-                                      <p:tavLst>
-                                        <p:tav tm="0">
-                                          <p:val>
-                                            <p:strVal val="#ppt_y+0.025"/>
-                                          </p:val>
-                                        </p:tav>
-                                        <p:tav tm="100000">
-                                          <p:val>
-                                            <p:strVal val="#ppt_y"/>
-                                          </p:val>
-                                        </p:tav>
-                                      </p:tavLst>
-                                    </p:anim>
+                                      </p:cBhvr>
+                                      <p:from x="94000" y="94000"/>
+                                      <p:to x="100000" y="100000"/>
+                                    </p:animScale>
                                   </p:childTnLst>
                                 </p:cTn>
                               </p:par>
                               <p:par>
                                 <p:cTn id="21" presetID="10" presetClass="entr" presetSubtype="0" fill="hold" grpId="0" nodeType="withEffect">
                                   <p:stCondLst>
-                                    <p:cond delay="244"/>
+                                    <p:cond delay="264"/>
                                   </p:stCondLst>
                                   <p:childTnLst>
                                     <p:set>
@@ -7347,36 +7233,23 @@
                                         </p:tgtEl>
                                       </p:cBhvr>
                                     </p:animEffect>
-                                    <p:anim calcmode="lin" valueType="num">
-                                      <p:cBhvr additive="base">
+                                    <p:animScale>
+                                      <p:cBhvr>
                                         <p:cTn id="24" dur="450" fill="hold"/>
                                         <p:tgtEl>
                                           <p:spTgt spid="12"/>
                                         </p:tgtEl>
-                                        <p:attrNameLst>
-                                          <p:attrName>ppt_y</p:attrName>
-                                        </p:attrNameLst>
-                                      </p:cBhvr>
-                                      <p:tavLst>
-                                        <p:tav tm="0">
-                                          <p:val>
-                                            <p:strVal val="#ppt_y+0.025"/>
-                                          </p:val>
-                                        </p:tav>
-                                        <p:tav tm="100000">
-                                          <p:val>
-                                            <p:strVal val="#ppt_y"/>
-                                          </p:val>
-                                        </p:tav>
-                                      </p:tavLst>
-                                    </p:anim>
+                                      </p:cBhvr>
+                                      <p:from x="94000" y="94000"/>
+                                      <p:to x="100000" y="100000"/>
+                                    </p:animScale>
                                   </p:childTnLst>
                                 </p:cTn>
                               </p:par>
                               <p:par>
                                 <p:cTn id="25" presetID="10" presetClass="entr" presetSubtype="0" fill="hold" grpId="0" nodeType="withEffect">
                                   <p:stCondLst>
-                                    <p:cond delay="305"/>
+                                    <p:cond delay="330"/>
                                   </p:stCondLst>
                                   <p:childTnLst>
                                     <p:set>
@@ -7405,36 +7278,23 @@
                                         </p:tgtEl>
                                       </p:cBhvr>
                                     </p:animEffect>
-                                    <p:anim calcmode="lin" valueType="num">
-                                      <p:cBhvr additive="base">
+                                    <p:animScale>
+                                      <p:cBhvr>
                                         <p:cTn id="28" dur="450" fill="hold"/>
                                         <p:tgtEl>
                                           <p:spTgt spid="15"/>
                                         </p:tgtEl>
-                                        <p:attrNameLst>
-                                          <p:attrName>ppt_y</p:attrName>
-                                        </p:attrNameLst>
-                                      </p:cBhvr>
-                                      <p:tavLst>
-                                        <p:tav tm="0">
-                                          <p:val>
-                                            <p:strVal val="#ppt_y+0.025"/>
-                                          </p:val>
-                                        </p:tav>
-                                        <p:tav tm="100000">
-                                          <p:val>
-                                            <p:strVal val="#ppt_y"/>
-                                          </p:val>
-                                        </p:tav>
-                                      </p:tavLst>
-                                    </p:anim>
+                                      </p:cBhvr>
+                                      <p:from x="94000" y="94000"/>
+                                      <p:to x="100000" y="100000"/>
+                                    </p:animScale>
                                   </p:childTnLst>
                                 </p:cTn>
                               </p:par>
                               <p:par>
                                 <p:cTn id="29" presetID="10" presetClass="entr" presetSubtype="0" fill="hold" grpId="0" nodeType="withEffect">
                                   <p:stCondLst>
-                                    <p:cond delay="366"/>
+                                    <p:cond delay="396"/>
                                   </p:stCondLst>
                                   <p:childTnLst>
                                     <p:set>
@@ -7463,36 +7323,23 @@
                                         </p:tgtEl>
                                       </p:cBhvr>
                                     </p:animEffect>
-                                    <p:anim calcmode="lin" valueType="num">
-                                      <p:cBhvr additive="base">
+                                    <p:animScale>
+                                      <p:cBhvr>
                                         <p:cTn id="32" dur="450" fill="hold"/>
                                         <p:tgtEl>
                                           <p:spTgt spid="18"/>
                                         </p:tgtEl>
-                                        <p:attrNameLst>
-                                          <p:attrName>ppt_y</p:attrName>
-                                        </p:attrNameLst>
-                                      </p:cBhvr>
-                                      <p:tavLst>
-                                        <p:tav tm="0">
-                                          <p:val>
-                                            <p:strVal val="#ppt_y+0.025"/>
-                                          </p:val>
-                                        </p:tav>
-                                        <p:tav tm="100000">
-                                          <p:val>
-                                            <p:strVal val="#ppt_y"/>
-                                          </p:val>
-                                        </p:tav>
-                                      </p:tavLst>
-                                    </p:anim>
+                                      </p:cBhvr>
+                                      <p:from x="94000" y="94000"/>
+                                      <p:to x="100000" y="100000"/>
+                                    </p:animScale>
                                   </p:childTnLst>
                                 </p:cTn>
                               </p:par>
                               <p:par>
                                 <p:cTn id="33" presetID="10" presetClass="entr" presetSubtype="0" fill="hold" grpId="0" nodeType="withEffect">
                                   <p:stCondLst>
-                                    <p:cond delay="427"/>
+                                    <p:cond delay="462"/>
                                   </p:stCondLst>
                                   <p:childTnLst>
                                     <p:set>
@@ -7550,7 +7397,7 @@
                               <p:par>
                                 <p:cTn id="37" presetID="10" presetClass="entr" presetSubtype="0" fill="hold" grpId="0" nodeType="withEffect">
                                   <p:stCondLst>
-                                    <p:cond delay="488"/>
+                                    <p:cond delay="528"/>
                                   </p:stCondLst>
                                   <p:childTnLst>
                                     <p:set>
@@ -7608,7 +7455,7 @@
                               <p:par>
                                 <p:cTn id="41" presetID="10" presetClass="entr" presetSubtype="0" fill="hold" grpId="0" nodeType="withEffect">
                                   <p:stCondLst>
-                                    <p:cond delay="549"/>
+                                    <p:cond delay="594"/>
                                   </p:stCondLst>
                                   <p:childTnLst>
                                     <p:set>
@@ -7666,7 +7513,7 @@
                               <p:par>
                                 <p:cTn id="45" presetID="10" presetClass="entr" presetSubtype="0" fill="hold" grpId="0" nodeType="withEffect">
                                   <p:stCondLst>
-                                    <p:cond delay="610"/>
+                                    <p:cond delay="660"/>
                                   </p:stCondLst>
                                   <p:childTnLst>
                                     <p:set>
@@ -7724,7 +7571,7 @@
                               <p:par>
                                 <p:cTn id="49" presetID="10" presetClass="entr" presetSubtype="0" fill="hold" grpId="0" nodeType="withEffect">
                                   <p:stCondLst>
-                                    <p:cond delay="671"/>
+                                    <p:cond delay="726"/>
                                   </p:stCondLst>
                                   <p:childTnLst>
                                     <p:set>
@@ -7782,7 +7629,7 @@
                               <p:par>
                                 <p:cTn id="53" presetID="10" presetClass="entr" presetSubtype="0" fill="hold" grpId="0" nodeType="withEffect">
                                   <p:stCondLst>
-                                    <p:cond delay="732"/>
+                                    <p:cond delay="792"/>
                                   </p:stCondLst>
                                   <p:childTnLst>
                                     <p:set>
@@ -7840,7 +7687,7 @@
                               <p:par>
                                 <p:cTn id="57" presetID="10" presetClass="entr" presetSubtype="0" fill="hold" grpId="0" nodeType="withEffect">
                                   <p:stCondLst>
-                                    <p:cond delay="793"/>
+                                    <p:cond delay="858"/>
                                   </p:stCondLst>
                                   <p:childTnLst>
                                     <p:set>
@@ -7898,7 +7745,7 @@
                               <p:par>
                                 <p:cTn id="61" presetID="10" presetClass="entr" presetSubtype="0" fill="hold" grpId="0" nodeType="withEffect">
                                   <p:stCondLst>
-                                    <p:cond delay="854"/>
+                                    <p:cond delay="924"/>
                                   </p:stCondLst>
                                   <p:childTnLst>
                                     <p:set>
@@ -7956,7 +7803,7 @@
                               <p:par>
                                 <p:cTn id="65" presetID="10" presetClass="entr" presetSubtype="0" fill="hold" grpId="0" nodeType="withEffect">
                                   <p:stCondLst>
-                                    <p:cond delay="915"/>
+                                    <p:cond delay="990"/>
                                   </p:stCondLst>
                                   <p:childTnLst>
                                     <p:set>
@@ -8014,7 +7861,7 @@
                               <p:par>
                                 <p:cTn id="69" presetID="10" presetClass="entr" presetSubtype="0" fill="hold" grpId="0" nodeType="withEffect">
                                   <p:stCondLst>
-                                    <p:cond delay="976"/>
+                                    <p:cond delay="1056"/>
                                   </p:stCondLst>
                                   <p:childTnLst>
                                     <p:set>
@@ -8072,7 +7919,7 @@
                               <p:par>
                                 <p:cTn id="73" presetID="10" presetClass="entr" presetSubtype="0" fill="hold" grpId="0" nodeType="withEffect">
                                   <p:stCondLst>
-                                    <p:cond delay="1037"/>
+                                    <p:cond delay="1122"/>
                                   </p:stCondLst>
                                   <p:childTnLst>
                                     <p:set>
@@ -8130,7 +7977,7 @@
                               <p:par>
                                 <p:cTn id="77" presetID="10" presetClass="entr" presetSubtype="0" fill="hold" grpId="0" nodeType="withEffect">
                                   <p:stCondLst>
-                                    <p:cond delay="1098"/>
+                                    <p:cond delay="1188"/>
                                   </p:stCondLst>
                                   <p:childTnLst>
                                     <p:set>
@@ -8341,7 +8188,7 @@
   <p:clrMapOvr>
     <a:masterClrMapping/>
   </p:clrMapOvr>
-  <p:transition xmlns:p14="http://schemas.microsoft.com/office/powerpoint/2010/main" spd="slow" p14:dur="700">
+  <p:transition xmlns:p14="http://schemas.microsoft.com/office/powerpoint/2010/main" spd="slow" p14:dur="620">
     <p:fade/>
   </p:transition>
   <p:timing xmlns:p="http://schemas.openxmlformats.org/presentationml/2006/main">

</xml_diff>

<commit_message>
feat(motion): Apple-grade motion audit fixes - easing, beats, weight
Audit findings and remediation (designer review):
- CRITICAL: rise/scale animations were linear (calcmode=lin, no easing) -
  added decel curves (decel=80000 rise / 60000 scale) for settle-out motion
- CRITICAL: elements entered one-by-one, fragmented reading groups - new
  beat grouping merges vertically-overlapping shapes into one beat
  (bar rows grow as a unit: 40ms intra-beat, 110ms between rows)
- size-aware duration: larger/heavier elements move slower (0.85-1.35x by
  element height); statement/cover pages hold 1.4x longer
- beat cap raised to 6 so bars/timeline rows stay as distinct beats

Verified: decel attrs present, bars page row-cascade confirmed via XML
delay sequence, statement hold 604ms, all decks open clean in PowerPoint
</commit_message>
<xml_diff>
--- a/assets/example_deck.pptx
+++ b/assets/example_deck.pptx
@@ -2081,7 +2081,7 @@
                                     </p:set>
                                     <p:animEffect transition="in" filter="fade">
                                       <p:cBhvr>
-                                        <p:cTn id="7" dur="450"/>
+                                        <p:cTn id="7" dur="411"/>
                                         <p:tgtEl>
                                           <p:spTgt spid="2"/>
                                         </p:tgtEl>
@@ -2089,7 +2089,7 @@
                                     </p:animEffect>
                                     <p:anim calcmode="lin" valueType="num">
                                       <p:cBhvr additive="base">
-                                        <p:cTn id="8" dur="450" fill="hold"/>
+                                        <p:cTn id="8" dur="411" fill="hold" decel="80000"/>
                                         <p:tgtEl>
                                           <p:spTgt spid="2"/>
                                         </p:tgtEl>
@@ -2139,7 +2139,7 @@
                                     </p:set>
                                     <p:animEffect transition="in" filter="fade">
                                       <p:cBhvr>
-                                        <p:cTn id="11" dur="450"/>
+                                        <p:cTn id="11" dur="519"/>
                                         <p:tgtEl>
                                           <p:spTgt spid="3"/>
                                         </p:tgtEl>
@@ -2147,7 +2147,7 @@
                                     </p:animEffect>
                                     <p:animScale>
                                       <p:cBhvr>
-                                        <p:cTn id="12" dur="450" fill="hold"/>
+                                        <p:cTn id="12" dur="519" fill="hold" decel="60000"/>
                                         <p:tgtEl>
                                           <p:spTgt spid="3"/>
                                         </p:tgtEl>
@@ -2184,7 +2184,7 @@
                                     </p:set>
                                     <p:animEffect transition="in" filter="fade">
                                       <p:cBhvr>
-                                        <p:cTn id="15" dur="450"/>
+                                        <p:cTn id="15" dur="425"/>
                                         <p:tgtEl>
                                           <p:spTgt spid="4"/>
                                         </p:tgtEl>
@@ -2192,7 +2192,7 @@
                                     </p:animEffect>
                                     <p:anim calcmode="lin" valueType="num">
                                       <p:cBhvr additive="base">
-                                        <p:cTn id="16" dur="450" fill="hold"/>
+                                        <p:cTn id="16" dur="425" fill="hold" decel="80000"/>
                                         <p:tgtEl>
                                           <p:spTgt spid="4"/>
                                         </p:tgtEl>
@@ -2242,7 +2242,7 @@
                                     </p:set>
                                     <p:animEffect transition="in" filter="fade">
                                       <p:cBhvr>
-                                        <p:cTn id="19" dur="450"/>
+                                        <p:cTn id="19" dur="411"/>
                                         <p:tgtEl>
                                           <p:spTgt spid="5"/>
                                         </p:tgtEl>
@@ -2250,7 +2250,7 @@
                                     </p:animEffect>
                                     <p:anim calcmode="lin" valueType="num">
                                       <p:cBhvr additive="base">
-                                        <p:cTn id="20" dur="450" fill="hold"/>
+                                        <p:cTn id="20" dur="411" fill="hold" decel="80000"/>
                                         <p:tgtEl>
                                           <p:spTgt spid="5"/>
                                         </p:tgtEl>
@@ -2448,7 +2448,7 @@
                                     </p:set>
                                     <p:animEffect transition="in" filter="fade">
                                       <p:cBhvr>
-                                        <p:cTn id="7" dur="450"/>
+                                        <p:cTn id="7" dur="850"/>
                                         <p:tgtEl>
                                           <p:spTgt spid="2"/>
                                         </p:tgtEl>
@@ -2456,7 +2456,7 @@
                                     </p:animEffect>
                                     <p:anim calcmode="lin" valueType="num">
                                       <p:cBhvr additive="base">
-                                        <p:cTn id="8" dur="450" fill="hold"/>
+                                        <p:cTn id="8" dur="850" fill="hold" decel="80000"/>
                                         <p:tgtEl>
                                           <p:spTgt spid="2"/>
                                         </p:tgtEl>
@@ -2765,7 +2765,7 @@
                                     </p:set>
                                     <p:animEffect transition="in" filter="fade">
                                       <p:cBhvr>
-                                        <p:cTn id="7" dur="450"/>
+                                        <p:cTn id="7" dur="526"/>
                                         <p:tgtEl>
                                           <p:spTgt spid="2"/>
                                         </p:tgtEl>
@@ -2773,7 +2773,7 @@
                                     </p:animEffect>
                                     <p:animScale>
                                       <p:cBhvr>
-                                        <p:cTn id="8" dur="450" fill="hold"/>
+                                        <p:cTn id="8" dur="526" fill="hold" decel="60000"/>
                                         <p:tgtEl>
                                           <p:spTgt spid="2"/>
                                         </p:tgtEl>
@@ -2810,7 +2810,7 @@
                                     </p:set>
                                     <p:animEffect transition="in" filter="fade">
                                       <p:cBhvr>
-                                        <p:cTn id="11" dur="450"/>
+                                        <p:cTn id="11" dur="425"/>
                                         <p:tgtEl>
                                           <p:spTgt spid="3"/>
                                         </p:tgtEl>
@@ -2818,7 +2818,7 @@
                                     </p:animEffect>
                                     <p:anim calcmode="lin" valueType="num">
                                       <p:cBhvr additive="base">
-                                        <p:cTn id="12" dur="450" fill="hold"/>
+                                        <p:cTn id="12" dur="425" fill="hold" decel="80000"/>
                                         <p:tgtEl>
                                           <p:spTgt spid="3"/>
                                         </p:tgtEl>
@@ -2868,7 +2868,7 @@
                                     </p:set>
                                     <p:animEffect transition="in" filter="fade">
                                       <p:cBhvr>
-                                        <p:cTn id="15" dur="450"/>
+                                        <p:cTn id="15" dur="425"/>
                                         <p:tgtEl>
                                           <p:spTgt spid="4"/>
                                         </p:tgtEl>
@@ -2876,7 +2876,7 @@
                                     </p:animEffect>
                                     <p:anim calcmode="lin" valueType="num">
                                       <p:cBhvr additive="base">
-                                        <p:cTn id="16" dur="450" fill="hold"/>
+                                        <p:cTn id="16" dur="425" fill="hold" decel="80000"/>
                                         <p:tgtEl>
                                           <p:spTgt spid="4"/>
                                         </p:tgtEl>
@@ -2926,7 +2926,7 @@
                                     </p:set>
                                     <p:animEffect transition="in" filter="fade">
                                       <p:cBhvr>
-                                        <p:cTn id="19" dur="450"/>
+                                        <p:cTn id="19" dur="411"/>
                                         <p:tgtEl>
                                           <p:spTgt spid="5"/>
                                         </p:tgtEl>
@@ -2934,7 +2934,7 @@
                                     </p:animEffect>
                                     <p:anim calcmode="lin" valueType="num">
                                       <p:cBhvr additive="base">
-                                        <p:cTn id="20" dur="450" fill="hold"/>
+                                        <p:cTn id="20" dur="411" fill="hold" decel="80000"/>
                                         <p:tgtEl>
                                           <p:spTgt spid="5"/>
                                         </p:tgtEl>
@@ -3207,7 +3207,7 @@
                                     </p:set>
                                     <p:animEffect transition="in" filter="fade">
                                       <p:cBhvr>
-                                        <p:cTn id="7" dur="450"/>
+                                        <p:cTn id="7" dur="490"/>
                                         <p:tgtEl>
                                           <p:spTgt spid="2"/>
                                         </p:tgtEl>
@@ -3215,7 +3215,7 @@
                                     </p:animEffect>
                                     <p:anim calcmode="lin" valueType="num">
                                       <p:cBhvr additive="base">
-                                        <p:cTn id="8" dur="450" fill="hold"/>
+                                        <p:cTn id="8" dur="490" fill="hold" decel="80000"/>
                                         <p:tgtEl>
                                           <p:spTgt spid="2"/>
                                         </p:tgtEl>
@@ -3265,7 +3265,7 @@
                                     </p:set>
                                     <p:animEffect transition="in" filter="fade">
                                       <p:cBhvr>
-                                        <p:cTn id="11" dur="450"/>
+                                        <p:cTn id="11" dur="425"/>
                                         <p:tgtEl>
                                           <p:spTgt spid="3"/>
                                         </p:tgtEl>
@@ -3273,7 +3273,7 @@
                                     </p:animEffect>
                                     <p:anim calcmode="lin" valueType="num">
                                       <p:cBhvr additive="base">
-                                        <p:cTn id="12" dur="450" fill="hold"/>
+                                        <p:cTn id="12" dur="425" fill="hold" decel="80000"/>
                                         <p:tgtEl>
                                           <p:spTgt spid="3"/>
                                         </p:tgtEl>
@@ -3323,7 +3323,7 @@
                                     </p:set>
                                     <p:animEffect transition="in" filter="fade">
                                       <p:cBhvr>
-                                        <p:cTn id="15" dur="450"/>
+                                        <p:cTn id="15" dur="411"/>
                                         <p:tgtEl>
                                           <p:spTgt spid="4"/>
                                         </p:tgtEl>
@@ -3331,7 +3331,7 @@
                                     </p:animEffect>
                                     <p:anim calcmode="lin" valueType="num">
                                       <p:cBhvr additive="base">
-                                        <p:cTn id="16" dur="450" fill="hold"/>
+                                        <p:cTn id="16" dur="411" fill="hold" decel="80000"/>
                                         <p:tgtEl>
                                           <p:spTgt spid="4"/>
                                         </p:tgtEl>
@@ -3514,7 +3514,7 @@
                                     </p:set>
                                     <p:animEffect transition="in" filter="fade">
                                       <p:cBhvr>
-                                        <p:cTn id="7" dur="450"/>
+                                        <p:cTn id="7" dur="850"/>
                                         <p:tgtEl>
                                           <p:spTgt spid="2"/>
                                         </p:tgtEl>
@@ -3522,7 +3522,7 @@
                                     </p:animEffect>
                                     <p:anim calcmode="lin" valueType="num">
                                       <p:cBhvr additive="base">
-                                        <p:cTn id="8" dur="450" fill="hold"/>
+                                        <p:cTn id="8" dur="850" fill="hold" decel="80000"/>
                                         <p:tgtEl>
                                           <p:spTgt spid="2"/>
                                         </p:tgtEl>
@@ -3778,7 +3778,7 @@
                                     </p:set>
                                     <p:animEffect transition="in" filter="fade">
                                       <p:cBhvr>
-                                        <p:cTn id="7" dur="450"/>
+                                        <p:cTn id="7" dur="504"/>
                                         <p:tgtEl>
                                           <p:spTgt spid="2"/>
                                         </p:tgtEl>
@@ -3786,7 +3786,7 @@
                                     </p:animEffect>
                                     <p:animScale>
                                       <p:cBhvr>
-                                        <p:cTn id="8" dur="450" fill="hold"/>
+                                        <p:cTn id="8" dur="504" fill="hold" decel="60000"/>
                                         <p:tgtEl>
                                           <p:spTgt spid="2"/>
                                         </p:tgtEl>
@@ -3823,7 +3823,7 @@
                                     </p:set>
                                     <p:animEffect transition="in" filter="fade">
                                       <p:cBhvr>
-                                        <p:cTn id="11" dur="450"/>
+                                        <p:cTn id="11" dur="476"/>
                                         <p:tgtEl>
                                           <p:spTgt spid="3"/>
                                         </p:tgtEl>
@@ -3831,7 +3831,7 @@
                                     </p:animEffect>
                                     <p:anim calcmode="lin" valueType="num">
                                       <p:cBhvr additive="base">
-                                        <p:cTn id="12" dur="450" fill="hold"/>
+                                        <p:cTn id="12" dur="476" fill="hold" decel="80000"/>
                                         <p:tgtEl>
                                           <p:spTgt spid="3"/>
                                         </p:tgtEl>
@@ -3881,7 +3881,7 @@
                                     </p:set>
                                     <p:animEffect transition="in" filter="fade">
                                       <p:cBhvr>
-                                        <p:cTn id="15" dur="450"/>
+                                        <p:cTn id="15" dur="425"/>
                                         <p:tgtEl>
                                           <p:spTgt spid="4"/>
                                         </p:tgtEl>
@@ -3889,7 +3889,7 @@
                                     </p:animEffect>
                                     <p:anim calcmode="lin" valueType="num">
                                       <p:cBhvr additive="base">
-                                        <p:cTn id="16" dur="450" fill="hold"/>
+                                        <p:cTn id="16" dur="425" fill="hold" decel="80000"/>
                                         <p:tgtEl>
                                           <p:spTgt spid="4"/>
                                         </p:tgtEl>
@@ -4108,7 +4108,7 @@
                                     </p:set>
                                     <p:animEffect transition="in" filter="fade">
                                       <p:cBhvr>
-                                        <p:cTn id="7" dur="450"/>
+                                        <p:cTn id="7" dur="696"/>
                                         <p:tgtEl>
                                           <p:spTgt spid="2"/>
                                         </p:tgtEl>
@@ -4116,7 +4116,7 @@
                                     </p:animEffect>
                                     <p:anim calcmode="lin" valueType="num">
                                       <p:cBhvr additive="base">
-                                        <p:cTn id="8" dur="450" fill="hold"/>
+                                        <p:cTn id="8" dur="696" fill="hold" decel="80000"/>
                                         <p:tgtEl>
                                           <p:spTgt spid="2"/>
                                         </p:tgtEl>
@@ -4166,7 +4166,7 @@
                                     </p:set>
                                     <p:animEffect transition="in" filter="fade">
                                       <p:cBhvr>
-                                        <p:cTn id="11" dur="450"/>
+                                        <p:cTn id="11" dur="595"/>
                                         <p:tgtEl>
                                           <p:spTgt spid="3"/>
                                         </p:tgtEl>
@@ -4174,7 +4174,7 @@
                                     </p:animEffect>
                                     <p:anim calcmode="lin" valueType="num">
                                       <p:cBhvr additive="base">
-                                        <p:cTn id="12" dur="450" fill="hold"/>
+                                        <p:cTn id="12" dur="595" fill="hold" decel="80000"/>
                                         <p:tgtEl>
                                           <p:spTgt spid="3"/>
                                         </p:tgtEl>
@@ -4484,7 +4484,7 @@
                                     </p:set>
                                     <p:animEffect transition="in" filter="fade">
                                       <p:cBhvr>
-                                        <p:cTn id="7" dur="450"/>
+                                        <p:cTn id="7" dur="411"/>
                                         <p:tgtEl>
                                           <p:spTgt spid="2"/>
                                         </p:tgtEl>
@@ -4492,7 +4492,7 @@
                                     </p:animEffect>
                                     <p:anim calcmode="lin" valueType="num">
                                       <p:cBhvr additive="base">
-                                        <p:cTn id="8" dur="450" fill="hold"/>
+                                        <p:cTn id="8" dur="411" fill="hold" decel="80000"/>
                                         <p:tgtEl>
                                           <p:spTgt spid="2"/>
                                         </p:tgtEl>
@@ -4542,7 +4542,7 @@
                                     </p:set>
                                     <p:animEffect transition="in" filter="fade">
                                       <p:cBhvr>
-                                        <p:cTn id="11" dur="450"/>
+                                        <p:cTn id="11" dur="548"/>
                                         <p:tgtEl>
                                           <p:spTgt spid="3"/>
                                         </p:tgtEl>
@@ -4550,7 +4550,7 @@
                                     </p:animEffect>
                                     <p:animScale>
                                       <p:cBhvr>
-                                        <p:cTn id="12" dur="450" fill="hold"/>
+                                        <p:cTn id="12" dur="548" fill="hold" decel="60000"/>
                                         <p:tgtEl>
                                           <p:spTgt spid="3"/>
                                         </p:tgtEl>
@@ -4587,7 +4587,7 @@
                                     </p:set>
                                     <p:animEffect transition="in" filter="fade">
                                       <p:cBhvr>
-                                        <p:cTn id="15" dur="450"/>
+                                        <p:cTn id="15" dur="432"/>
                                         <p:tgtEl>
                                           <p:spTgt spid="4"/>
                                         </p:tgtEl>
@@ -4595,7 +4595,7 @@
                                     </p:animEffect>
                                     <p:anim calcmode="lin" valueType="num">
                                       <p:cBhvr additive="base">
-                                        <p:cTn id="16" dur="450" fill="hold"/>
+                                        <p:cTn id="16" dur="432" fill="hold" decel="80000"/>
                                         <p:tgtEl>
                                           <p:spTgt spid="4"/>
                                         </p:tgtEl>
@@ -4645,7 +4645,7 @@
                                     </p:set>
                                     <p:animEffect transition="in" filter="fade">
                                       <p:cBhvr>
-                                        <p:cTn id="19" dur="450"/>
+                                        <p:cTn id="19" dur="447"/>
                                         <p:tgtEl>
                                           <p:spTgt spid="5"/>
                                         </p:tgtEl>
@@ -4653,7 +4653,7 @@
                                     </p:animEffect>
                                     <p:anim calcmode="lin" valueType="num">
                                       <p:cBhvr additive="base">
-                                        <p:cTn id="20" dur="450" fill="hold"/>
+                                        <p:cTn id="20" dur="447" fill="hold" decel="80000"/>
                                         <p:tgtEl>
                                           <p:spTgt spid="5"/>
                                         </p:tgtEl>
@@ -5077,7 +5077,7 @@
                                     </p:set>
                                     <p:animEffect transition="in" filter="fade">
                                       <p:cBhvr>
-                                        <p:cTn id="7" dur="450"/>
+                                        <p:cTn id="7" dur="440"/>
                                         <p:tgtEl>
                                           <p:spTgt spid="2"/>
                                         </p:tgtEl>
@@ -5085,7 +5085,7 @@
                                     </p:animEffect>
                                     <p:anim calcmode="lin" valueType="num">
                                       <p:cBhvr additive="base">
-                                        <p:cTn id="8" dur="450" fill="hold"/>
+                                        <p:cTn id="8" dur="440" fill="hold" decel="80000"/>
                                         <p:tgtEl>
                                           <p:spTgt spid="2"/>
                                         </p:tgtEl>
@@ -5135,7 +5135,7 @@
                                     </p:set>
                                     <p:animEffect transition="in" filter="fade">
                                       <p:cBhvr>
-                                        <p:cTn id="11" dur="450"/>
+                                        <p:cTn id="11" dur="425"/>
                                         <p:tgtEl>
                                           <p:spTgt spid="3"/>
                                         </p:tgtEl>
@@ -5143,7 +5143,7 @@
                                     </p:animEffect>
                                     <p:anim calcmode="lin" valueType="num">
                                       <p:cBhvr additive="base">
-                                        <p:cTn id="12" dur="450" fill="hold"/>
+                                        <p:cTn id="12" dur="425" fill="hold" decel="80000"/>
                                         <p:tgtEl>
                                           <p:spTgt spid="3"/>
                                         </p:tgtEl>
@@ -5170,7 +5170,7 @@
                               <p:par>
                                 <p:cTn id="13" presetID="10" presetClass="entr" presetSubtype="0" fill="hold" grpId="0" nodeType="withEffect">
                                   <p:stCondLst>
-                                    <p:cond delay="320"/>
+                                    <p:cond delay="200"/>
                                   </p:stCondLst>
                                   <p:childTnLst>
                                     <p:set>
@@ -5193,7 +5193,7 @@
                                     </p:set>
                                     <p:animEffect transition="in" filter="fade">
                                       <p:cBhvr>
-                                        <p:cTn id="15" dur="450"/>
+                                        <p:cTn id="15" dur="425"/>
                                         <p:tgtEl>
                                           <p:spTgt spid="5"/>
                                         </p:tgtEl>
@@ -5201,7 +5201,7 @@
                                     </p:animEffect>
                                     <p:anim calcmode="lin" valueType="num">
                                       <p:cBhvr additive="base">
-                                        <p:cTn id="16" dur="450" fill="hold"/>
+                                        <p:cTn id="16" dur="425" fill="hold" decel="80000"/>
                                         <p:tgtEl>
                                           <p:spTgt spid="5"/>
                                         </p:tgtEl>
@@ -5228,7 +5228,7 @@
                               <p:par>
                                 <p:cTn id="17" presetID="10" presetClass="entr" presetSubtype="0" fill="hold" grpId="0" nodeType="withEffect">
                                   <p:stCondLst>
-                                    <p:cond delay="480"/>
+                                    <p:cond delay="240"/>
                                   </p:stCondLst>
                                   <p:childTnLst>
                                     <p:set>
@@ -5251,7 +5251,7 @@
                                     </p:set>
                                     <p:animEffect transition="in" filter="fade">
                                       <p:cBhvr>
-                                        <p:cTn id="19" dur="450"/>
+                                        <p:cTn id="19" dur="425"/>
                                         <p:tgtEl>
                                           <p:spTgt spid="7"/>
                                         </p:tgtEl>
@@ -5259,7 +5259,7 @@
                                     </p:animEffect>
                                     <p:anim calcmode="lin" valueType="num">
                                       <p:cBhvr additive="base">
-                                        <p:cTn id="20" dur="450" fill="hold"/>
+                                        <p:cTn id="20" dur="425" fill="hold" decel="80000"/>
                                         <p:tgtEl>
                                           <p:spTgt spid="7"/>
                                         </p:tgtEl>
@@ -5286,7 +5286,7 @@
                               <p:par>
                                 <p:cTn id="21" presetID="10" presetClass="entr" presetSubtype="0" fill="hold" grpId="0" nodeType="withEffect">
                                   <p:stCondLst>
-                                    <p:cond delay="640"/>
+                                    <p:cond delay="320"/>
                                   </p:stCondLst>
                                   <p:childTnLst>
                                     <p:set>
@@ -5309,7 +5309,7 @@
                                     </p:set>
                                     <p:animEffect transition="in" filter="fade">
                                       <p:cBhvr>
-                                        <p:cTn id="23" dur="450"/>
+                                        <p:cTn id="23" dur="555"/>
                                         <p:tgtEl>
                                           <p:spTgt spid="4"/>
                                         </p:tgtEl>
@@ -5317,7 +5317,7 @@
                                     </p:animEffect>
                                     <p:anim calcmode="lin" valueType="num">
                                       <p:cBhvr additive="base">
-                                        <p:cTn id="24" dur="450" fill="hold"/>
+                                        <p:cTn id="24" dur="555" fill="hold" decel="80000"/>
                                         <p:tgtEl>
                                           <p:spTgt spid="4"/>
                                         </p:tgtEl>
@@ -5344,7 +5344,7 @@
                               <p:par>
                                 <p:cTn id="25" presetID="10" presetClass="entr" presetSubtype="0" fill="hold" grpId="0" nodeType="withEffect">
                                   <p:stCondLst>
-                                    <p:cond delay="800"/>
+                                    <p:cond delay="360"/>
                                   </p:stCondLst>
                                   <p:childTnLst>
                                     <p:set>
@@ -5367,7 +5367,7 @@
                                     </p:set>
                                     <p:animEffect transition="in" filter="fade">
                                       <p:cBhvr>
-                                        <p:cTn id="27" dur="450"/>
+                                        <p:cTn id="27" dur="555"/>
                                         <p:tgtEl>
                                           <p:spTgt spid="6"/>
                                         </p:tgtEl>
@@ -5375,7 +5375,7 @@
                                     </p:animEffect>
                                     <p:anim calcmode="lin" valueType="num">
                                       <p:cBhvr additive="base">
-                                        <p:cTn id="28" dur="450" fill="hold"/>
+                                        <p:cTn id="28" dur="555" fill="hold" decel="80000"/>
                                         <p:tgtEl>
                                           <p:spTgt spid="6"/>
                                         </p:tgtEl>
@@ -5402,7 +5402,7 @@
                               <p:par>
                                 <p:cTn id="29" presetID="10" presetClass="entr" presetSubtype="0" fill="hold" grpId="0" nodeType="withEffect">
                                   <p:stCondLst>
-                                    <p:cond delay="960"/>
+                                    <p:cond delay="400"/>
                                   </p:stCondLst>
                                   <p:childTnLst>
                                     <p:set>
@@ -5425,7 +5425,7 @@
                                     </p:set>
                                     <p:animEffect transition="in" filter="fade">
                                       <p:cBhvr>
-                                        <p:cTn id="31" dur="450"/>
+                                        <p:cTn id="31" dur="555"/>
                                         <p:tgtEl>
                                           <p:spTgt spid="8"/>
                                         </p:tgtEl>
@@ -5433,7 +5433,7 @@
                                     </p:animEffect>
                                     <p:anim calcmode="lin" valueType="num">
                                       <p:cBhvr additive="base">
-                                        <p:cTn id="32" dur="450" fill="hold"/>
+                                        <p:cTn id="32" dur="555" fill="hold" decel="80000"/>
                                         <p:tgtEl>
                                           <p:spTgt spid="8"/>
                                         </p:tgtEl>
@@ -5918,7 +5918,7 @@
                                     </p:set>
                                     <p:animEffect transition="in" filter="fade">
                                       <p:cBhvr>
-                                        <p:cTn id="7" dur="450"/>
+                                        <p:cTn id="7" dur="411"/>
                                         <p:tgtEl>
                                           <p:spTgt spid="2"/>
                                         </p:tgtEl>
@@ -5926,7 +5926,7 @@
                                     </p:animEffect>
                                     <p:anim calcmode="lin" valueType="num">
                                       <p:cBhvr additive="base">
-                                        <p:cTn id="8" dur="450" fill="hold"/>
+                                        <p:cTn id="8" dur="411" fill="hold" decel="80000"/>
                                         <p:tgtEl>
                                           <p:spTgt spid="2"/>
                                         </p:tgtEl>
@@ -5953,7 +5953,7 @@
                               <p:par>
                                 <p:cTn id="9" presetID="10" presetClass="entr" presetSubtype="0" fill="hold" grpId="0" nodeType="withEffect">
                                   <p:stCondLst>
-                                    <p:cond delay="160"/>
+                                    <p:cond delay="40"/>
                                   </p:stCondLst>
                                   <p:childTnLst>
                                     <p:set>
@@ -5976,7 +5976,7 @@
                                     </p:set>
                                     <p:animEffect transition="in" filter="fade">
                                       <p:cBhvr>
-                                        <p:cTn id="11" dur="450"/>
+                                        <p:cTn id="11" dur="411"/>
                                         <p:tgtEl>
                                           <p:spTgt spid="3"/>
                                         </p:tgtEl>
@@ -5984,7 +5984,7 @@
                                     </p:animEffect>
                                     <p:anim calcmode="lin" valueType="num">
                                       <p:cBhvr additive="base">
-                                        <p:cTn id="12" dur="450" fill="hold"/>
+                                        <p:cTn id="12" dur="411" fill="hold" decel="80000"/>
                                         <p:tgtEl>
                                           <p:spTgt spid="3"/>
                                         </p:tgtEl>
@@ -6011,7 +6011,7 @@
                               <p:par>
                                 <p:cTn id="13" presetID="10" presetClass="entr" presetSubtype="0" fill="hold" grpId="0" nodeType="withEffect">
                                   <p:stCondLst>
-                                    <p:cond delay="320"/>
+                                    <p:cond delay="160"/>
                                   </p:stCondLst>
                                   <p:childTnLst>
                                     <p:set>
@@ -6034,7 +6034,7 @@
                                     </p:set>
                                     <p:animEffect transition="in" filter="wipe(left)">
                                       <p:cBhvr>
-                                        <p:cTn id="15" dur="450"/>
+                                        <p:cTn id="15" dur="607"/>
                                         <p:tgtEl>
                                           <p:spTgt spid="8"/>
                                         </p:tgtEl>
@@ -6046,7 +6046,7 @@
                               <p:par>
                                 <p:cTn id="16" presetID="10" presetClass="entr" presetSubtype="0" fill="hold" grpId="0" nodeType="withEffect">
                                   <p:stCondLst>
-                                    <p:cond delay="480"/>
+                                    <p:cond delay="200"/>
                                   </p:stCondLst>
                                   <p:childTnLst>
                                     <p:set>
@@ -6069,7 +6069,7 @@
                                     </p:set>
                                     <p:animEffect transition="in" filter="fade">
                                       <p:cBhvr>
-                                        <p:cTn id="18" dur="450"/>
+                                        <p:cTn id="18" dur="461"/>
                                         <p:tgtEl>
                                           <p:spTgt spid="4"/>
                                         </p:tgtEl>
@@ -6077,7 +6077,7 @@
                                     </p:animEffect>
                                     <p:anim calcmode="lin" valueType="num">
                                       <p:cBhvr additive="base">
-                                        <p:cTn id="19" dur="450" fill="hold"/>
+                                        <p:cTn id="19" dur="461" fill="hold" decel="80000"/>
                                         <p:tgtEl>
                                           <p:spTgt spid="4"/>
                                         </p:tgtEl>
@@ -6104,7 +6104,7 @@
                               <p:par>
                                 <p:cTn id="20" presetID="10" presetClass="entr" presetSubtype="0" fill="hold" grpId="0" nodeType="withEffect">
                                   <p:stCondLst>
-                                    <p:cond delay="640"/>
+                                    <p:cond delay="240"/>
                                   </p:stCondLst>
                                   <p:childTnLst>
                                     <p:set>
@@ -6127,7 +6127,7 @@
                                     </p:set>
                                     <p:animEffect transition="in" filter="fade">
                                       <p:cBhvr>
-                                        <p:cTn id="22" dur="450"/>
+                                        <p:cTn id="22" dur="461"/>
                                         <p:tgtEl>
                                           <p:spTgt spid="5"/>
                                         </p:tgtEl>
@@ -6135,7 +6135,7 @@
                                     </p:animEffect>
                                     <p:anim calcmode="lin" valueType="num">
                                       <p:cBhvr additive="base">
-                                        <p:cTn id="23" dur="450" fill="hold"/>
+                                        <p:cTn id="23" dur="461" fill="hold" decel="80000"/>
                                         <p:tgtEl>
                                           <p:spTgt spid="5"/>
                                         </p:tgtEl>
@@ -6162,7 +6162,7 @@
                               <p:par>
                                 <p:cTn id="24" presetID="10" presetClass="entr" presetSubtype="0" fill="hold" grpId="0" nodeType="withEffect">
                                   <p:stCondLst>
-                                    <p:cond delay="800"/>
+                                    <p:cond delay="280"/>
                                   </p:stCondLst>
                                   <p:childTnLst>
                                     <p:set>
@@ -6185,7 +6185,7 @@
                                     </p:set>
                                     <p:animEffect transition="in" filter="fade">
                                       <p:cBhvr>
-                                        <p:cTn id="26" dur="450"/>
+                                        <p:cTn id="26" dur="607"/>
                                         <p:tgtEl>
                                           <p:spTgt spid="6"/>
                                         </p:tgtEl>
@@ -6193,7 +6193,7 @@
                                     </p:animEffect>
                                     <p:anim calcmode="lin" valueType="num">
                                       <p:cBhvr additive="base">
-                                        <p:cTn id="27" dur="450" fill="hold"/>
+                                        <p:cTn id="27" dur="607" fill="hold" decel="80000"/>
                                         <p:tgtEl>
                                           <p:spTgt spid="6"/>
                                         </p:tgtEl>
@@ -6220,7 +6220,7 @@
                               <p:par>
                                 <p:cTn id="28" presetID="10" presetClass="entr" presetSubtype="0" fill="hold" grpId="0" nodeType="withEffect">
                                   <p:stCondLst>
-                                    <p:cond delay="960"/>
+                                    <p:cond delay="320"/>
                                   </p:stCondLst>
                                   <p:childTnLst>
                                     <p:set>
@@ -6243,7 +6243,7 @@
                                     </p:set>
                                     <p:animEffect transition="in" filter="fade">
                                       <p:cBhvr>
-                                        <p:cTn id="30" dur="450"/>
+                                        <p:cTn id="30" dur="607"/>
                                         <p:tgtEl>
                                           <p:spTgt spid="7"/>
                                         </p:tgtEl>
@@ -6251,7 +6251,7 @@
                                     </p:animEffect>
                                     <p:anim calcmode="lin" valueType="num">
                                       <p:cBhvr additive="base">
-                                        <p:cTn id="31" dur="450" fill="hold"/>
+                                        <p:cTn id="31" dur="607" fill="hold" decel="80000"/>
                                         <p:tgtEl>
                                           <p:spTgt spid="7"/>
                                         </p:tgtEl>
@@ -7034,7 +7034,7 @@
                                     </p:set>
                                     <p:animEffect transition="in" filter="fade">
                                       <p:cBhvr>
-                                        <p:cTn id="7" dur="450"/>
+                                        <p:cTn id="7" dur="432"/>
                                         <p:tgtEl>
                                           <p:spTgt spid="2"/>
                                         </p:tgtEl>
@@ -7042,7 +7042,7 @@
                                     </p:animEffect>
                                     <p:anim calcmode="lin" valueType="num">
                                       <p:cBhvr additive="base">
-                                        <p:cTn id="8" dur="450" fill="hold"/>
+                                        <p:cTn id="8" dur="432" fill="hold" decel="80000"/>
                                         <p:tgtEl>
                                           <p:spTgt spid="2"/>
                                         </p:tgtEl>
@@ -7069,7 +7069,7 @@
                               <p:par>
                                 <p:cTn id="9" presetID="10" presetClass="entr" presetSubtype="0" fill="hold" grpId="0" nodeType="withEffect">
                                   <p:stCondLst>
-                                    <p:cond delay="66"/>
+                                    <p:cond delay="160"/>
                                   </p:stCondLst>
                                   <p:childTnLst>
                                     <p:set>
@@ -7092,7 +7092,7 @@
                                     </p:set>
                                     <p:animEffect transition="in" filter="fade">
                                       <p:cBhvr>
-                                        <p:cTn id="11" dur="450"/>
+                                        <p:cTn id="11" dur="569"/>
                                         <p:tgtEl>
                                           <p:spTgt spid="3"/>
                                         </p:tgtEl>
@@ -7100,7 +7100,7 @@
                                     </p:animEffect>
                                     <p:animScale>
                                       <p:cBhvr>
-                                        <p:cTn id="12" dur="450" fill="hold"/>
+                                        <p:cTn id="12" dur="569" fill="hold" decel="60000"/>
                                         <p:tgtEl>
                                           <p:spTgt spid="3"/>
                                         </p:tgtEl>
@@ -7114,7 +7114,7 @@
                               <p:par>
                                 <p:cTn id="13" presetID="10" presetClass="entr" presetSubtype="0" fill="hold" grpId="0" nodeType="withEffect">
                                   <p:stCondLst>
-                                    <p:cond delay="132"/>
+                                    <p:cond delay="200"/>
                                   </p:stCondLst>
                                   <p:childTnLst>
                                     <p:set>
@@ -7137,7 +7137,7 @@
                                     </p:set>
                                     <p:animEffect transition="in" filter="fade">
                                       <p:cBhvr>
-                                        <p:cTn id="15" dur="450"/>
+                                        <p:cTn id="15" dur="569"/>
                                         <p:tgtEl>
                                           <p:spTgt spid="6"/>
                                         </p:tgtEl>
@@ -7145,7 +7145,7 @@
                                     </p:animEffect>
                                     <p:animScale>
                                       <p:cBhvr>
-                                        <p:cTn id="16" dur="450" fill="hold"/>
+                                        <p:cTn id="16" dur="569" fill="hold" decel="60000"/>
                                         <p:tgtEl>
                                           <p:spTgt spid="6"/>
                                         </p:tgtEl>
@@ -7159,7 +7159,7 @@
                               <p:par>
                                 <p:cTn id="17" presetID="10" presetClass="entr" presetSubtype="0" fill="hold" grpId="0" nodeType="withEffect">
                                   <p:stCondLst>
-                                    <p:cond delay="198"/>
+                                    <p:cond delay="240"/>
                                   </p:stCondLst>
                                   <p:childTnLst>
                                     <p:set>
@@ -7182,7 +7182,7 @@
                                     </p:set>
                                     <p:animEffect transition="in" filter="fade">
                                       <p:cBhvr>
-                                        <p:cTn id="19" dur="450"/>
+                                        <p:cTn id="19" dur="569"/>
                                         <p:tgtEl>
                                           <p:spTgt spid="9"/>
                                         </p:tgtEl>
@@ -7190,7 +7190,7 @@
                                     </p:animEffect>
                                     <p:animScale>
                                       <p:cBhvr>
-                                        <p:cTn id="20" dur="450" fill="hold"/>
+                                        <p:cTn id="20" dur="569" fill="hold" decel="60000"/>
                                         <p:tgtEl>
                                           <p:spTgt spid="9"/>
                                         </p:tgtEl>
@@ -7204,7 +7204,7 @@
                               <p:par>
                                 <p:cTn id="21" presetID="10" presetClass="entr" presetSubtype="0" fill="hold" grpId="0" nodeType="withEffect">
                                   <p:stCondLst>
-                                    <p:cond delay="264"/>
+                                    <p:cond delay="280"/>
                                   </p:stCondLst>
                                   <p:childTnLst>
                                     <p:set>
@@ -7227,7 +7227,7 @@
                                     </p:set>
                                     <p:animEffect transition="in" filter="fade">
                                       <p:cBhvr>
-                                        <p:cTn id="23" dur="450"/>
+                                        <p:cTn id="23" dur="569"/>
                                         <p:tgtEl>
                                           <p:spTgt spid="12"/>
                                         </p:tgtEl>
@@ -7235,7 +7235,7 @@
                                     </p:animEffect>
                                     <p:animScale>
                                       <p:cBhvr>
-                                        <p:cTn id="24" dur="450" fill="hold"/>
+                                        <p:cTn id="24" dur="569" fill="hold" decel="60000"/>
                                         <p:tgtEl>
                                           <p:spTgt spid="12"/>
                                         </p:tgtEl>
@@ -7249,7 +7249,7 @@
                               <p:par>
                                 <p:cTn id="25" presetID="10" presetClass="entr" presetSubtype="0" fill="hold" grpId="0" nodeType="withEffect">
                                   <p:stCondLst>
-                                    <p:cond delay="330"/>
+                                    <p:cond delay="320"/>
                                   </p:stCondLst>
                                   <p:childTnLst>
                                     <p:set>
@@ -7272,7 +7272,7 @@
                                     </p:set>
                                     <p:animEffect transition="in" filter="fade">
                                       <p:cBhvr>
-                                        <p:cTn id="27" dur="450"/>
+                                        <p:cTn id="27" dur="569"/>
                                         <p:tgtEl>
                                           <p:spTgt spid="15"/>
                                         </p:tgtEl>
@@ -7280,7 +7280,7 @@
                                     </p:animEffect>
                                     <p:animScale>
                                       <p:cBhvr>
-                                        <p:cTn id="28" dur="450" fill="hold"/>
+                                        <p:cTn id="28" dur="569" fill="hold" decel="60000"/>
                                         <p:tgtEl>
                                           <p:spTgt spid="15"/>
                                         </p:tgtEl>
@@ -7294,7 +7294,7 @@
                               <p:par>
                                 <p:cTn id="29" presetID="10" presetClass="entr" presetSubtype="0" fill="hold" grpId="0" nodeType="withEffect">
                                   <p:stCondLst>
-                                    <p:cond delay="396"/>
+                                    <p:cond delay="360"/>
                                   </p:stCondLst>
                                   <p:childTnLst>
                                     <p:set>
@@ -7317,7 +7317,7 @@
                                     </p:set>
                                     <p:animEffect transition="in" filter="fade">
                                       <p:cBhvr>
-                                        <p:cTn id="31" dur="450"/>
+                                        <p:cTn id="31" dur="569"/>
                                         <p:tgtEl>
                                           <p:spTgt spid="18"/>
                                         </p:tgtEl>
@@ -7325,7 +7325,7 @@
                                     </p:animEffect>
                                     <p:animScale>
                                       <p:cBhvr>
-                                        <p:cTn id="32" dur="450" fill="hold"/>
+                                        <p:cTn id="32" dur="569" fill="hold" decel="60000"/>
                                         <p:tgtEl>
                                           <p:spTgt spid="18"/>
                                         </p:tgtEl>
@@ -7339,7 +7339,7 @@
                               <p:par>
                                 <p:cTn id="33" presetID="10" presetClass="entr" presetSubtype="0" fill="hold" grpId="0" nodeType="withEffect">
                                   <p:stCondLst>
-                                    <p:cond delay="462"/>
+                                    <p:cond delay="320"/>
                                   </p:stCondLst>
                                   <p:childTnLst>
                                     <p:set>
@@ -7362,7 +7362,7 @@
                                     </p:set>
                                     <p:animEffect transition="in" filter="fade">
                                       <p:cBhvr>
-                                        <p:cTn id="35" dur="450"/>
+                                        <p:cTn id="35" dur="418"/>
                                         <p:tgtEl>
                                           <p:spTgt spid="4"/>
                                         </p:tgtEl>
@@ -7370,7 +7370,7 @@
                                     </p:animEffect>
                                     <p:anim calcmode="lin" valueType="num">
                                       <p:cBhvr additive="base">
-                                        <p:cTn id="36" dur="450" fill="hold"/>
+                                        <p:cTn id="36" dur="418" fill="hold" decel="80000"/>
                                         <p:tgtEl>
                                           <p:spTgt spid="4"/>
                                         </p:tgtEl>
@@ -7397,7 +7397,7 @@
                               <p:par>
                                 <p:cTn id="37" presetID="10" presetClass="entr" presetSubtype="0" fill="hold" grpId="0" nodeType="withEffect">
                                   <p:stCondLst>
-                                    <p:cond delay="528"/>
+                                    <p:cond delay="360"/>
                                   </p:stCondLst>
                                   <p:childTnLst>
                                     <p:set>
@@ -7420,7 +7420,7 @@
                                     </p:set>
                                     <p:animEffect transition="in" filter="fade">
                                       <p:cBhvr>
-                                        <p:cTn id="39" dur="450"/>
+                                        <p:cTn id="39" dur="418"/>
                                         <p:tgtEl>
                                           <p:spTgt spid="7"/>
                                         </p:tgtEl>
@@ -7428,7 +7428,7 @@
                                     </p:animEffect>
                                     <p:anim calcmode="lin" valueType="num">
                                       <p:cBhvr additive="base">
-                                        <p:cTn id="40" dur="450" fill="hold"/>
+                                        <p:cTn id="40" dur="418" fill="hold" decel="80000"/>
                                         <p:tgtEl>
                                           <p:spTgt spid="7"/>
                                         </p:tgtEl>
@@ -7455,7 +7455,7 @@
                               <p:par>
                                 <p:cTn id="41" presetID="10" presetClass="entr" presetSubtype="0" fill="hold" grpId="0" nodeType="withEffect">
                                   <p:stCondLst>
-                                    <p:cond delay="594"/>
+                                    <p:cond delay="400"/>
                                   </p:stCondLst>
                                   <p:childTnLst>
                                     <p:set>
@@ -7478,7 +7478,7 @@
                                     </p:set>
                                     <p:animEffect transition="in" filter="fade">
                                       <p:cBhvr>
-                                        <p:cTn id="43" dur="450"/>
+                                        <p:cTn id="43" dur="418"/>
                                         <p:tgtEl>
                                           <p:spTgt spid="10"/>
                                         </p:tgtEl>
@@ -7486,7 +7486,7 @@
                                     </p:animEffect>
                                     <p:anim calcmode="lin" valueType="num">
                                       <p:cBhvr additive="base">
-                                        <p:cTn id="44" dur="450" fill="hold"/>
+                                        <p:cTn id="44" dur="418" fill="hold" decel="80000"/>
                                         <p:tgtEl>
                                           <p:spTgt spid="10"/>
                                         </p:tgtEl>
@@ -7513,7 +7513,7 @@
                               <p:par>
                                 <p:cTn id="45" presetID="10" presetClass="entr" presetSubtype="0" fill="hold" grpId="0" nodeType="withEffect">
                                   <p:stCondLst>
-                                    <p:cond delay="660"/>
+                                    <p:cond delay="440"/>
                                   </p:stCondLst>
                                   <p:childTnLst>
                                     <p:set>
@@ -7536,7 +7536,7 @@
                                     </p:set>
                                     <p:animEffect transition="in" filter="fade">
                                       <p:cBhvr>
-                                        <p:cTn id="47" dur="450"/>
+                                        <p:cTn id="47" dur="418"/>
                                         <p:tgtEl>
                                           <p:spTgt spid="13"/>
                                         </p:tgtEl>
@@ -7544,7 +7544,7 @@
                                     </p:animEffect>
                                     <p:anim calcmode="lin" valueType="num">
                                       <p:cBhvr additive="base">
-                                        <p:cTn id="48" dur="450" fill="hold"/>
+                                        <p:cTn id="48" dur="418" fill="hold" decel="80000"/>
                                         <p:tgtEl>
                                           <p:spTgt spid="13"/>
                                         </p:tgtEl>
@@ -7571,7 +7571,7 @@
                               <p:par>
                                 <p:cTn id="49" presetID="10" presetClass="entr" presetSubtype="0" fill="hold" grpId="0" nodeType="withEffect">
                                   <p:stCondLst>
-                                    <p:cond delay="726"/>
+                                    <p:cond delay="480"/>
                                   </p:stCondLst>
                                   <p:childTnLst>
                                     <p:set>
@@ -7594,7 +7594,7 @@
                                     </p:set>
                                     <p:animEffect transition="in" filter="fade">
                                       <p:cBhvr>
-                                        <p:cTn id="51" dur="450"/>
+                                        <p:cTn id="51" dur="418"/>
                                         <p:tgtEl>
                                           <p:spTgt spid="16"/>
                                         </p:tgtEl>
@@ -7602,7 +7602,7 @@
                                     </p:animEffect>
                                     <p:anim calcmode="lin" valueType="num">
                                       <p:cBhvr additive="base">
-                                        <p:cTn id="52" dur="450" fill="hold"/>
+                                        <p:cTn id="52" dur="418" fill="hold" decel="80000"/>
                                         <p:tgtEl>
                                           <p:spTgt spid="16"/>
                                         </p:tgtEl>
@@ -7629,7 +7629,7 @@
                               <p:par>
                                 <p:cTn id="53" presetID="10" presetClass="entr" presetSubtype="0" fill="hold" grpId="0" nodeType="withEffect">
                                   <p:stCondLst>
-                                    <p:cond delay="792"/>
+                                    <p:cond delay="520"/>
                                   </p:stCondLst>
                                   <p:childTnLst>
                                     <p:set>
@@ -7652,7 +7652,7 @@
                                     </p:set>
                                     <p:animEffect transition="in" filter="fade">
                                       <p:cBhvr>
-                                        <p:cTn id="55" dur="450"/>
+                                        <p:cTn id="55" dur="418"/>
                                         <p:tgtEl>
                                           <p:spTgt spid="19"/>
                                         </p:tgtEl>
@@ -7660,7 +7660,7 @@
                                     </p:animEffect>
                                     <p:anim calcmode="lin" valueType="num">
                                       <p:cBhvr additive="base">
-                                        <p:cTn id="56" dur="450" fill="hold"/>
+                                        <p:cTn id="56" dur="418" fill="hold" decel="80000"/>
                                         <p:tgtEl>
                                           <p:spTgt spid="19"/>
                                         </p:tgtEl>
@@ -7687,7 +7687,7 @@
                               <p:par>
                                 <p:cTn id="57" presetID="10" presetClass="entr" presetSubtype="0" fill="hold" grpId="0" nodeType="withEffect">
                                   <p:stCondLst>
-                                    <p:cond delay="858"/>
+                                    <p:cond delay="480"/>
                                   </p:stCondLst>
                                   <p:childTnLst>
                                     <p:set>
@@ -7710,7 +7710,7 @@
                                     </p:set>
                                     <p:animEffect transition="in" filter="fade">
                                       <p:cBhvr>
-                                        <p:cTn id="59" dur="450"/>
+                                        <p:cTn id="59" dur="440"/>
                                         <p:tgtEl>
                                           <p:spTgt spid="5"/>
                                         </p:tgtEl>
@@ -7718,7 +7718,7 @@
                                     </p:animEffect>
                                     <p:anim calcmode="lin" valueType="num">
                                       <p:cBhvr additive="base">
-                                        <p:cTn id="60" dur="450" fill="hold"/>
+                                        <p:cTn id="60" dur="440" fill="hold" decel="80000"/>
                                         <p:tgtEl>
                                           <p:spTgt spid="5"/>
                                         </p:tgtEl>
@@ -7745,7 +7745,7 @@
                               <p:par>
                                 <p:cTn id="61" presetID="10" presetClass="entr" presetSubtype="0" fill="hold" grpId="0" nodeType="withEffect">
                                   <p:stCondLst>
-                                    <p:cond delay="924"/>
+                                    <p:cond delay="520"/>
                                   </p:stCondLst>
                                   <p:childTnLst>
                                     <p:set>
@@ -7768,7 +7768,7 @@
                                     </p:set>
                                     <p:animEffect transition="in" filter="fade">
                                       <p:cBhvr>
-                                        <p:cTn id="63" dur="450"/>
+                                        <p:cTn id="63" dur="440"/>
                                         <p:tgtEl>
                                           <p:spTgt spid="8"/>
                                         </p:tgtEl>
@@ -7776,7 +7776,7 @@
                                     </p:animEffect>
                                     <p:anim calcmode="lin" valueType="num">
                                       <p:cBhvr additive="base">
-                                        <p:cTn id="64" dur="450" fill="hold"/>
+                                        <p:cTn id="64" dur="440" fill="hold" decel="80000"/>
                                         <p:tgtEl>
                                           <p:spTgt spid="8"/>
                                         </p:tgtEl>
@@ -7803,7 +7803,7 @@
                               <p:par>
                                 <p:cTn id="65" presetID="10" presetClass="entr" presetSubtype="0" fill="hold" grpId="0" nodeType="withEffect">
                                   <p:stCondLst>
-                                    <p:cond delay="990"/>
+                                    <p:cond delay="560"/>
                                   </p:stCondLst>
                                   <p:childTnLst>
                                     <p:set>
@@ -7826,7 +7826,7 @@
                                     </p:set>
                                     <p:animEffect transition="in" filter="fade">
                                       <p:cBhvr>
-                                        <p:cTn id="67" dur="450"/>
+                                        <p:cTn id="67" dur="440"/>
                                         <p:tgtEl>
                                           <p:spTgt spid="11"/>
                                         </p:tgtEl>
@@ -7834,7 +7834,7 @@
                                     </p:animEffect>
                                     <p:anim calcmode="lin" valueType="num">
                                       <p:cBhvr additive="base">
-                                        <p:cTn id="68" dur="450" fill="hold"/>
+                                        <p:cTn id="68" dur="440" fill="hold" decel="80000"/>
                                         <p:tgtEl>
                                           <p:spTgt spid="11"/>
                                         </p:tgtEl>
@@ -7861,7 +7861,7 @@
                               <p:par>
                                 <p:cTn id="69" presetID="10" presetClass="entr" presetSubtype="0" fill="hold" grpId="0" nodeType="withEffect">
                                   <p:stCondLst>
-                                    <p:cond delay="1056"/>
+                                    <p:cond delay="600"/>
                                   </p:stCondLst>
                                   <p:childTnLst>
                                     <p:set>
@@ -7884,7 +7884,7 @@
                                     </p:set>
                                     <p:animEffect transition="in" filter="fade">
                                       <p:cBhvr>
-                                        <p:cTn id="71" dur="450"/>
+                                        <p:cTn id="71" dur="440"/>
                                         <p:tgtEl>
                                           <p:spTgt spid="14"/>
                                         </p:tgtEl>
@@ -7892,7 +7892,7 @@
                                     </p:animEffect>
                                     <p:anim calcmode="lin" valueType="num">
                                       <p:cBhvr additive="base">
-                                        <p:cTn id="72" dur="450" fill="hold"/>
+                                        <p:cTn id="72" dur="440" fill="hold" decel="80000"/>
                                         <p:tgtEl>
                                           <p:spTgt spid="14"/>
                                         </p:tgtEl>
@@ -7919,7 +7919,7 @@
                               <p:par>
                                 <p:cTn id="73" presetID="10" presetClass="entr" presetSubtype="0" fill="hold" grpId="0" nodeType="withEffect">
                                   <p:stCondLst>
-                                    <p:cond delay="1122"/>
+                                    <p:cond delay="640"/>
                                   </p:stCondLst>
                                   <p:childTnLst>
                                     <p:set>
@@ -7942,7 +7942,7 @@
                                     </p:set>
                                     <p:animEffect transition="in" filter="fade">
                                       <p:cBhvr>
-                                        <p:cTn id="75" dur="450"/>
+                                        <p:cTn id="75" dur="440"/>
                                         <p:tgtEl>
                                           <p:spTgt spid="17"/>
                                         </p:tgtEl>
@@ -7950,7 +7950,7 @@
                                     </p:animEffect>
                                     <p:anim calcmode="lin" valueType="num">
                                       <p:cBhvr additive="base">
-                                        <p:cTn id="76" dur="450" fill="hold"/>
+                                        <p:cTn id="76" dur="440" fill="hold" decel="80000"/>
                                         <p:tgtEl>
                                           <p:spTgt spid="17"/>
                                         </p:tgtEl>
@@ -7977,7 +7977,7 @@
                               <p:par>
                                 <p:cTn id="77" presetID="10" presetClass="entr" presetSubtype="0" fill="hold" grpId="0" nodeType="withEffect">
                                   <p:stCondLst>
-                                    <p:cond delay="1188"/>
+                                    <p:cond delay="680"/>
                                   </p:stCondLst>
                                   <p:childTnLst>
                                     <p:set>
@@ -8000,7 +8000,7 @@
                                     </p:set>
                                     <p:animEffect transition="in" filter="fade">
                                       <p:cBhvr>
-                                        <p:cTn id="79" dur="450"/>
+                                        <p:cTn id="79" dur="440"/>
                                         <p:tgtEl>
                                           <p:spTgt spid="20"/>
                                         </p:tgtEl>
@@ -8008,7 +8008,7 @@
                                     </p:animEffect>
                                     <p:anim calcmode="lin" valueType="num">
                                       <p:cBhvr additive="base">
-                                        <p:cTn id="80" dur="450" fill="hold"/>
+                                        <p:cTn id="80" dur="440" fill="hold" decel="80000"/>
                                         <p:tgtEl>
                                           <p:spTgt spid="20"/>
                                         </p:tgtEl>
@@ -8240,7 +8240,7 @@
                                     </p:set>
                                     <p:animEffect transition="in" filter="fade">
                                       <p:cBhvr>
-                                        <p:cTn id="7" dur="450"/>
+                                        <p:cTn id="7" dur="777"/>
                                         <p:tgtEl>
                                           <p:spTgt spid="2"/>
                                         </p:tgtEl>
@@ -8248,7 +8248,7 @@
                                     </p:animEffect>
                                     <p:anim calcmode="lin" valueType="num">
                                       <p:cBhvr additive="base">
-                                        <p:cTn id="8" dur="450" fill="hold"/>
+                                        <p:cTn id="8" dur="777" fill="hold" decel="80000"/>
                                         <p:tgtEl>
                                           <p:spTgt spid="2"/>
                                         </p:tgtEl>
@@ -8298,7 +8298,7 @@
                                     </p:set>
                                     <p:animEffect transition="in" filter="fade">
                                       <p:cBhvr>
-                                        <p:cTn id="11" dur="450"/>
+                                        <p:cTn id="11" dur="585"/>
                                         <p:tgtEl>
                                           <p:spTgt spid="3"/>
                                         </p:tgtEl>
@@ -8306,7 +8306,7 @@
                                     </p:animEffect>
                                     <p:anim calcmode="lin" valueType="num">
                                       <p:cBhvr additive="base">
-                                        <p:cTn id="12" dur="450" fill="hold"/>
+                                        <p:cTn id="12" dur="585" fill="hold" decel="80000"/>
                                         <p:tgtEl>
                                           <p:spTgt spid="3"/>
                                         </p:tgtEl>

</xml_diff>